<commit_message>
docs: add verified live demo evidence
</commit_message>
<xml_diff>
--- a/deliverables/KAOP-by-Nirit-Terehovsky.pptx
+++ b/deliverables/KAOP-by-Nirit-Terehovsky.pptx
@@ -2,24 +2,24 @@
 <file path=ppt/presentation.xml><?xml version="1.0" encoding="utf-8"?>
 <p:presentation xmlns:p="http://schemas.openxmlformats.org/presentationml/2006/main">
   <p:sldMasterIdLst>
-    <p:sldMasterId xmlns:r="http://schemas.openxmlformats.org/officeDocument/2006/relationships" id="2147483648" r:id="R98d7dd78c126483e"/>
+    <p:sldMasterId xmlns:r="http://schemas.openxmlformats.org/officeDocument/2006/relationships" id="2147483648" r:id="R19cfb8b2845f4f8d"/>
   </p:sldMasterIdLst>
   <p:notesMasterIdLst>
-    <p:notesMasterId xmlns:r="http://schemas.openxmlformats.org/officeDocument/2006/relationships" r:id="R1bd14088fd54459e"/>
+    <p:notesMasterId xmlns:r="http://schemas.openxmlformats.org/officeDocument/2006/relationships" r:id="R714bcbdc674644a7"/>
   </p:notesMasterIdLst>
   <p:sldIdLst>
-    <p:sldId xmlns:r="http://schemas.openxmlformats.org/officeDocument/2006/relationships" id="256" r:id="R6a7389701a934320"/>
-    <p:sldId xmlns:r="http://schemas.openxmlformats.org/officeDocument/2006/relationships" id="257" r:id="R2e7fbc82257149ce"/>
-    <p:sldId xmlns:r="http://schemas.openxmlformats.org/officeDocument/2006/relationships" id="258" r:id="Rd85f412a64a84c75"/>
-    <p:sldId xmlns:r="http://schemas.openxmlformats.org/officeDocument/2006/relationships" id="259" r:id="R8b251a65ac8d42a2"/>
-    <p:sldId xmlns:r="http://schemas.openxmlformats.org/officeDocument/2006/relationships" id="260" r:id="R116a7dfa0a9e4f71"/>
-    <p:sldId xmlns:r="http://schemas.openxmlformats.org/officeDocument/2006/relationships" id="261" r:id="R621387b22b584ca1"/>
-    <p:sldId xmlns:r="http://schemas.openxmlformats.org/officeDocument/2006/relationships" id="262" r:id="Rff362e11bea84ea1"/>
-    <p:sldId xmlns:r="http://schemas.openxmlformats.org/officeDocument/2006/relationships" id="263" r:id="Re3cc4c51881e4504"/>
-    <p:sldId xmlns:r="http://schemas.openxmlformats.org/officeDocument/2006/relationships" id="264" r:id="R02823e284ae74849"/>
-    <p:sldId xmlns:r="http://schemas.openxmlformats.org/officeDocument/2006/relationships" id="265" r:id="Re1384e68139649cc"/>
-    <p:sldId xmlns:r="http://schemas.openxmlformats.org/officeDocument/2006/relationships" id="266" r:id="Rfd06a6ef06c4463c"/>
-    <p:sldId xmlns:r="http://schemas.openxmlformats.org/officeDocument/2006/relationships" id="267" r:id="R90de88e4c5ca42e4"/>
+    <p:sldId xmlns:r="http://schemas.openxmlformats.org/officeDocument/2006/relationships" id="256" r:id="Rcb688af847144d6a"/>
+    <p:sldId xmlns:r="http://schemas.openxmlformats.org/officeDocument/2006/relationships" id="257" r:id="Rc99458adc84642cd"/>
+    <p:sldId xmlns:r="http://schemas.openxmlformats.org/officeDocument/2006/relationships" id="258" r:id="Rc2eeea3e90b84e44"/>
+    <p:sldId xmlns:r="http://schemas.openxmlformats.org/officeDocument/2006/relationships" id="259" r:id="R6888153fff2341de"/>
+    <p:sldId xmlns:r="http://schemas.openxmlformats.org/officeDocument/2006/relationships" id="260" r:id="R57c1e58ade574093"/>
+    <p:sldId xmlns:r="http://schemas.openxmlformats.org/officeDocument/2006/relationships" id="261" r:id="R5d09a744ef8145d9"/>
+    <p:sldId xmlns:r="http://schemas.openxmlformats.org/officeDocument/2006/relationships" id="262" r:id="R4956586cd3c843c5"/>
+    <p:sldId xmlns:r="http://schemas.openxmlformats.org/officeDocument/2006/relationships" id="263" r:id="Rf66f6ebd49c24c14"/>
+    <p:sldId xmlns:r="http://schemas.openxmlformats.org/officeDocument/2006/relationships" id="264" r:id="R66630da269c94864"/>
+    <p:sldId xmlns:r="http://schemas.openxmlformats.org/officeDocument/2006/relationships" id="265" r:id="R9fe877e4f75246d3"/>
+    <p:sldId xmlns:r="http://schemas.openxmlformats.org/officeDocument/2006/relationships" id="266" r:id="Rf1f447e643be4461"/>
+    <p:sldId xmlns:r="http://schemas.openxmlformats.org/officeDocument/2006/relationships" id="267" r:id="R8e8ee22b5c784a2d"/>
   </p:sldIdLst>
   <p:sldSz cx="12192000" cy="6858000"/>
   <p:notesSz cx="6858000" cy="9144000"/>
@@ -713,7 +713,7 @@
           <a:lstStyle xmlns:a="http://schemas.openxmlformats.org/drawingml/2006/main"/>
           <a:p xmlns:a="http://schemas.openxmlformats.org/drawingml/2006/main">
             <a:r>
-              <a:t>The local smoke test produced a real Redis Service with no endpoints, failed readiness and liveness probes, BackOff events, and three restarts on the new frontend Pod. Recovery restored the healthy overlay and endpoint.</a:t>
+              <a:t>The live workflow produced a real Redis Service with no endpoints, connection failures, failed readiness and liveness probes, and seven restarts on the new frontend Pod. KAOP returned high confidence, named the mismatched role selector, identified the liveness regression, and recommended the exact repair. Recovery restored the endpoint and Grafana returned to Normal.</a:t>
             </a:r>
           </a:p>
           <a:p xmlns:a="http://schemas.openxmlformats.org/drawingml/2006/main">
@@ -729,6 +729,16 @@
           <a:p xmlns:a="http://schemas.openxmlformats.org/drawingml/2006/main">
             <a:r>
               <a:t>- Live verification from the kaop-demo cluster on 2026-10-07</a:t>
+            </a:r>
+          </a:p>
+          <a:p xmlns:a="http://schemas.openxmlformats.org/drawingml/2006/main">
+            <a:r>
+              <a:t>- https://kaop.komodor.com/a/hire-task-9/runs/run_e15c91fc04701d47c908ec0f</a:t>
+            </a:r>
+          </a:p>
+          <a:p xmlns:a="http://schemas.openxmlformats.org/drawingml/2006/main">
+            <a:r>
+              <a:t>- https://contentcheetah182.grafana.net/alerting/grafana/fg0jdq07jv9c0e/view</a:t>
             </a:r>
           </a:p>
         </p:txBody>
@@ -1338,7 +1348,7 @@
           <a:lstStyle xmlns:a="http://schemas.openxmlformats.org/drawingml/2006/main"/>
           <a:p xmlns:a="http://schemas.openxmlformats.org/drawingml/2006/main">
             <a:r>
-              <a:t>Start the demo in KAOP. Show inventory, workflow structure, permission scope, and run history before triggering the fault. Then move to Grafana, the KAOP finding, and the open GitHub PR.</a:t>
+              <a:t>Start the demo in KAOP. Show inventory, workflow structure, permission scope, and run history before triggering the fault. The verified live run identified the Service selector mismatch, the dependency-coupled liveness probe, and the exact recovery. Then move to Grafana and the open GitHub PR.</a:t>
             </a:r>
           </a:p>
           <a:p xmlns:a="http://schemas.openxmlformats.org/drawingml/2006/main">
@@ -1354,6 +1364,21 @@
           <a:p xmlns:a="http://schemas.openxmlformats.org/drawingml/2006/main">
             <a:r>
               <a:t>- Product Architect Home Assignment.pdf, page 2</a:t>
+            </a:r>
+          </a:p>
+          <a:p xmlns:a="http://schemas.openxmlformats.org/drawingml/2006/main">
+            <a:r>
+              <a:t>- https://kaop.komodor.com/a/hire-task-9/runs/run_e15c91fc04701d47c908ec0f</a:t>
+            </a:r>
+          </a:p>
+          <a:p xmlns:a="http://schemas.openxmlformats.org/drawingml/2006/main">
+            <a:r>
+              <a:t>- https://contentcheetah182.grafana.net/alerting/grafana/fg0jdq07jv9c0e/view</a:t>
+            </a:r>
+          </a:p>
+          <a:p xmlns:a="http://schemas.openxmlformats.org/drawingml/2006/main">
+            <a:r>
+              <a:t>- https://github.com/nirittere/kaop-guestbook-demo/pull/1#issuecomment-6045140326</a:t>
             </a:r>
           </a:p>
         </p:txBody>
@@ -1506,7 +1531,7 @@
   </p:cSld>
   <p:clrMap bg1="lt1" tx1="dk1" bg2="lt2" tx2="dk2" accent1="accent1" accent2="accent2" accent3="accent3" accent4="accent4" accent5="accent5" accent6="accent6" hlink="hlink" folHlink="folHlink"/>
   <p:sldLayoutIdLst>
-    <p:sldLayoutId xmlns:r="http://schemas.openxmlformats.org/officeDocument/2006/relationships" id="2147483649" r:id="R23e228da6237499a"/>
+    <p:sldLayoutId xmlns:r="http://schemas.openxmlformats.org/officeDocument/2006/relationships" id="2147483649" r:id="R4c0c089cc09540e6"/>
   </p:sldLayoutIdLst>
   <p:txStyles>
     <p:titleStyle>
@@ -2061,7 +2086,7 @@
           <p:nvPr/>
         </p:nvPicPr>
         <p:blipFill>
-          <a:blip xmlns:r="http://schemas.openxmlformats.org/officeDocument/2006/relationships" xmlns:a="http://schemas.openxmlformats.org/drawingml/2006/main" r:embed="R60fb5db32b4a420c"/>
+          <a:blip xmlns:r="http://schemas.openxmlformats.org/officeDocument/2006/relationships" xmlns:a="http://schemas.openxmlformats.org/drawingml/2006/main" r:embed="R8ea402a810a044de"/>
           <a:srcRect xmlns:a="http://schemas.openxmlformats.org/drawingml/2006/main" l="0" t="27" r="0" b="27"/>
           <a:stretch xmlns:a="http://schemas.openxmlformats.org/drawingml/2006/main">
             <a:fillRect l="0" t="0" r="0" b="0"/>
@@ -2082,7 +2107,7 @@
           <p:cNvPr id="2" name="">
             <a:extLst xmlns:a="http://schemas.openxmlformats.org/drawingml/2006/main">
               <a:ext uri="{FF2B5EF4-FFF2-40B4-BE49-F238E27FC236}">
-                <a16:creationId xmlns:a16="http://schemas.microsoft.com/office/drawing/2014/main" id="{1AAA054F-732B-432C-94DB-FD4AFEC2530E}"/>
+                <a16:creationId xmlns:a16="http://schemas.microsoft.com/office/drawing/2014/main" id="{F7653D9F-BC58-44FD-94EE-1D6BD0C64002}"/>
               </a:ext>
             </a:extLst>
           </p:cNvPr>
@@ -2139,7 +2164,7 @@
           <p:cNvPr id="3" name="">
             <a:extLst xmlns:a="http://schemas.openxmlformats.org/drawingml/2006/main">
               <a:ext uri="{FF2B5EF4-FFF2-40B4-BE49-F238E27FC236}">
-                <a16:creationId xmlns:a16="http://schemas.microsoft.com/office/drawing/2014/main" id="{7F2AC62A-A9A4-4B9B-83AC-FAA9E1E18E01}"/>
+                <a16:creationId xmlns:a16="http://schemas.microsoft.com/office/drawing/2014/main" id="{4871E1D7-F4DA-4B5F-90B1-1A9ABCE82D4B}"/>
               </a:ext>
             </a:extLst>
           </p:cNvPr>
@@ -2196,7 +2221,7 @@
           <p:cNvPr id="4" name="">
             <a:extLst xmlns:a="http://schemas.openxmlformats.org/drawingml/2006/main">
               <a:ext uri="{FF2B5EF4-FFF2-40B4-BE49-F238E27FC236}">
-                <a16:creationId xmlns:a16="http://schemas.microsoft.com/office/drawing/2014/main" id="{5F090BA3-8866-4E8B-BA0B-4A04A59D4260}"/>
+                <a16:creationId xmlns:a16="http://schemas.microsoft.com/office/drawing/2014/main" id="{4C3645B3-F77C-48D8-A0FD-B33A16274783}"/>
               </a:ext>
             </a:extLst>
           </p:cNvPr>
@@ -2253,7 +2278,7 @@
           <p:cNvPr id="5" name="">
             <a:extLst xmlns:a="http://schemas.openxmlformats.org/drawingml/2006/main">
               <a:ext uri="{FF2B5EF4-FFF2-40B4-BE49-F238E27FC236}">
-                <a16:creationId xmlns:a16="http://schemas.microsoft.com/office/drawing/2014/main" id="{4A520280-7EF7-45B1-B592-E6CBBF60345E}"/>
+                <a16:creationId xmlns:a16="http://schemas.microsoft.com/office/drawing/2014/main" id="{78104B8A-FDDC-40D0-8A94-78D80EB56F2D}"/>
               </a:ext>
             </a:extLst>
           </p:cNvPr>
@@ -2310,7 +2335,7 @@
           <p:cNvPr id="6" name="">
             <a:extLst xmlns:a="http://schemas.openxmlformats.org/drawingml/2006/main">
               <a:ext uri="{FF2B5EF4-FFF2-40B4-BE49-F238E27FC236}">
-                <a16:creationId xmlns:a16="http://schemas.microsoft.com/office/drawing/2014/main" id="{DF1AA810-0641-4167-B01F-99C05F9B7A44}"/>
+                <a16:creationId xmlns:a16="http://schemas.microsoft.com/office/drawing/2014/main" id="{3F023DA2-F3F6-4858-87D1-4B5396270EA7}"/>
               </a:ext>
             </a:extLst>
           </p:cNvPr>
@@ -2365,7 +2390,7 @@
     </p:spTree>
     <p:extLst>
       <p:ext uri="{BB962C8B-B14F-4D97-AF65-F5344CB8AC3E}">
-        <p14:creationId xmlns:p14="http://schemas.microsoft.com/office/powerpoint/2010/main" val="82209191"/>
+        <p14:creationId xmlns:p14="http://schemas.microsoft.com/office/powerpoint/2010/main" val="1037027699"/>
       </p:ext>
     </p:extLst>
   </p:cSld>
@@ -2396,7 +2421,7 @@
           <p:cNvPr id="25" name="">
             <a:extLst xmlns:a="http://schemas.openxmlformats.org/drawingml/2006/main">
               <a:ext uri="{FF2B5EF4-FFF2-40B4-BE49-F238E27FC236}">
-                <a16:creationId xmlns:a16="http://schemas.microsoft.com/office/drawing/2014/main" id="{19C2186C-A3BF-4403-9606-D45694407C8D}"/>
+                <a16:creationId xmlns:a16="http://schemas.microsoft.com/office/drawing/2014/main" id="{F707DC2F-E4DD-4ED4-A9D9-790A1376C622}"/>
               </a:ext>
             </a:extLst>
           </p:cNvPr>
@@ -2426,7 +2451,7 @@
           <p:cNvPr id="2" name="">
             <a:extLst xmlns:a="http://schemas.openxmlformats.org/drawingml/2006/main">
               <a:ext uri="{FF2B5EF4-FFF2-40B4-BE49-F238E27FC236}">
-                <a16:creationId xmlns:a16="http://schemas.microsoft.com/office/drawing/2014/main" id="{97AD4D2D-BD04-45AA-BDA2-C7A872653EA1}"/>
+                <a16:creationId xmlns:a16="http://schemas.microsoft.com/office/drawing/2014/main" id="{B75A6528-5236-476D-8D0E-4A905675C44A}"/>
               </a:ext>
             </a:extLst>
           </p:cNvPr>
@@ -2483,7 +2508,7 @@
           <p:cNvPr id="3" name="">
             <a:extLst xmlns:a="http://schemas.openxmlformats.org/drawingml/2006/main">
               <a:ext uri="{FF2B5EF4-FFF2-40B4-BE49-F238E27FC236}">
-                <a16:creationId xmlns:a16="http://schemas.microsoft.com/office/drawing/2014/main" id="{CB206DC6-EB49-446B-86B7-E25A635DADC9}"/>
+                <a16:creationId xmlns:a16="http://schemas.microsoft.com/office/drawing/2014/main" id="{E33D5C12-D18B-4241-A3D0-A3FF6B7792F1}"/>
               </a:ext>
             </a:extLst>
           </p:cNvPr>
@@ -2540,7 +2565,7 @@
           <p:cNvPr id="4" name="">
             <a:extLst xmlns:a="http://schemas.openxmlformats.org/drawingml/2006/main">
               <a:ext uri="{FF2B5EF4-FFF2-40B4-BE49-F238E27FC236}">
-                <a16:creationId xmlns:a16="http://schemas.microsoft.com/office/drawing/2014/main" id="{51DEECC6-AFBD-46E3-B6AE-B25E345CE92A}"/>
+                <a16:creationId xmlns:a16="http://schemas.microsoft.com/office/drawing/2014/main" id="{32884F2B-0CFE-4714-9E5E-DF88A88F3252}"/>
               </a:ext>
             </a:extLst>
           </p:cNvPr>
@@ -2597,7 +2622,7 @@
           <p:cNvPr id="5" name="">
             <a:extLst xmlns:a="http://schemas.openxmlformats.org/drawingml/2006/main">
               <a:ext uri="{FF2B5EF4-FFF2-40B4-BE49-F238E27FC236}">
-                <a16:creationId xmlns:a16="http://schemas.microsoft.com/office/drawing/2014/main" id="{6A4F0E48-D692-4945-8254-323988BB2247}"/>
+                <a16:creationId xmlns:a16="http://schemas.microsoft.com/office/drawing/2014/main" id="{B6E7A233-3125-41C3-A240-965497E4E9D3}"/>
               </a:ext>
             </a:extLst>
           </p:cNvPr>
@@ -2654,7 +2679,7 @@
           <p:cNvPr id="6" name="">
             <a:extLst xmlns:a="http://schemas.openxmlformats.org/drawingml/2006/main">
               <a:ext uri="{FF2B5EF4-FFF2-40B4-BE49-F238E27FC236}">
-                <a16:creationId xmlns:a16="http://schemas.microsoft.com/office/drawing/2014/main" id="{9B07E54B-7D46-459E-A3AF-C7B33983F0BC}"/>
+                <a16:creationId xmlns:a16="http://schemas.microsoft.com/office/drawing/2014/main" id="{4651DE89-0FE1-461F-8E99-C62A8ACA355A}"/>
               </a:ext>
             </a:extLst>
           </p:cNvPr>
@@ -2689,7 +2714,7 @@
           <p:cNvPr id="7" name="">
             <a:extLst xmlns:a="http://schemas.openxmlformats.org/drawingml/2006/main">
               <a:ext uri="{FF2B5EF4-FFF2-40B4-BE49-F238E27FC236}">
-                <a16:creationId xmlns:a16="http://schemas.microsoft.com/office/drawing/2014/main" id="{2760A301-CF9D-428F-B479-12182F72AC38}"/>
+                <a16:creationId xmlns:a16="http://schemas.microsoft.com/office/drawing/2014/main" id="{4CC43C8E-3870-45CC-9BA2-0338018DDC18}"/>
               </a:ext>
             </a:extLst>
           </p:cNvPr>
@@ -2746,7 +2771,7 @@
           <p:cNvPr id="8" name="">
             <a:extLst xmlns:a="http://schemas.openxmlformats.org/drawingml/2006/main">
               <a:ext uri="{FF2B5EF4-FFF2-40B4-BE49-F238E27FC236}">
-                <a16:creationId xmlns:a16="http://schemas.microsoft.com/office/drawing/2014/main" id="{6B77CA9C-A2E3-499D-B068-ECA9F920D05D}"/>
+                <a16:creationId xmlns:a16="http://schemas.microsoft.com/office/drawing/2014/main" id="{D8407915-2A03-42AD-A049-781F36D4B7EB}"/>
               </a:ext>
             </a:extLst>
           </p:cNvPr>
@@ -2803,7 +2828,7 @@
           <p:cNvPr id="9" name="">
             <a:extLst xmlns:a="http://schemas.openxmlformats.org/drawingml/2006/main">
               <a:ext uri="{FF2B5EF4-FFF2-40B4-BE49-F238E27FC236}">
-                <a16:creationId xmlns:a16="http://schemas.microsoft.com/office/drawing/2014/main" id="{437407ED-A592-41CB-9317-8B8D1CE9860F}"/>
+                <a16:creationId xmlns:a16="http://schemas.microsoft.com/office/drawing/2014/main" id="{82993435-B63F-4655-A8EC-B178DF9FE8B7}"/>
               </a:ext>
             </a:extLst>
           </p:cNvPr>
@@ -2838,7 +2863,7 @@
           <p:cNvPr id="10" name="">
             <a:extLst xmlns:a="http://schemas.openxmlformats.org/drawingml/2006/main">
               <a:ext uri="{FF2B5EF4-FFF2-40B4-BE49-F238E27FC236}">
-                <a16:creationId xmlns:a16="http://schemas.microsoft.com/office/drawing/2014/main" id="{A3067453-67E8-48CB-BEDE-C2E507975D18}"/>
+                <a16:creationId xmlns:a16="http://schemas.microsoft.com/office/drawing/2014/main" id="{B19B37CB-98BE-4658-83A4-68E83A509C2D}"/>
               </a:ext>
             </a:extLst>
           </p:cNvPr>
@@ -2895,7 +2920,7 @@
           <p:cNvPr id="11" name="">
             <a:extLst xmlns:a="http://schemas.openxmlformats.org/drawingml/2006/main">
               <a:ext uri="{FF2B5EF4-FFF2-40B4-BE49-F238E27FC236}">
-                <a16:creationId xmlns:a16="http://schemas.microsoft.com/office/drawing/2014/main" id="{8E794DC0-58F2-4458-9FFE-AC80329F2754}"/>
+                <a16:creationId xmlns:a16="http://schemas.microsoft.com/office/drawing/2014/main" id="{77011880-0642-40FD-8393-78A2707F922E}"/>
               </a:ext>
             </a:extLst>
           </p:cNvPr>
@@ -2952,7 +2977,7 @@
           <p:cNvPr id="12" name="">
             <a:extLst xmlns:a="http://schemas.openxmlformats.org/drawingml/2006/main">
               <a:ext uri="{FF2B5EF4-FFF2-40B4-BE49-F238E27FC236}">
-                <a16:creationId xmlns:a16="http://schemas.microsoft.com/office/drawing/2014/main" id="{75A259D7-213A-4341-8A02-17E2A50DF1EA}"/>
+                <a16:creationId xmlns:a16="http://schemas.microsoft.com/office/drawing/2014/main" id="{4E303653-F27B-4483-9B2F-E3F88F534131}"/>
               </a:ext>
             </a:extLst>
           </p:cNvPr>
@@ -2987,7 +3012,7 @@
           <p:cNvPr id="13" name="">
             <a:extLst xmlns:a="http://schemas.openxmlformats.org/drawingml/2006/main">
               <a:ext uri="{FF2B5EF4-FFF2-40B4-BE49-F238E27FC236}">
-                <a16:creationId xmlns:a16="http://schemas.microsoft.com/office/drawing/2014/main" id="{1B9D5B4F-6EB0-4007-A235-555BC44C9A03}"/>
+                <a16:creationId xmlns:a16="http://schemas.microsoft.com/office/drawing/2014/main" id="{5CAF8F38-8114-46C1-87CF-4228810C1793}"/>
               </a:ext>
             </a:extLst>
           </p:cNvPr>
@@ -3044,7 +3069,7 @@
           <p:cNvPr id="14" name="">
             <a:extLst xmlns:a="http://schemas.openxmlformats.org/drawingml/2006/main">
               <a:ext uri="{FF2B5EF4-FFF2-40B4-BE49-F238E27FC236}">
-                <a16:creationId xmlns:a16="http://schemas.microsoft.com/office/drawing/2014/main" id="{7CA8E94F-85B6-4722-B000-B845854AE4EA}"/>
+                <a16:creationId xmlns:a16="http://schemas.microsoft.com/office/drawing/2014/main" id="{6609DE83-7573-42DF-8704-E5B3CB0D9960}"/>
               </a:ext>
             </a:extLst>
           </p:cNvPr>
@@ -3101,7 +3126,7 @@
           <p:cNvPr id="15" name="">
             <a:extLst xmlns:a="http://schemas.openxmlformats.org/drawingml/2006/main">
               <a:ext uri="{FF2B5EF4-FFF2-40B4-BE49-F238E27FC236}">
-                <a16:creationId xmlns:a16="http://schemas.microsoft.com/office/drawing/2014/main" id="{947D38CC-57E7-4A45-8DB1-1F16F2A5F48C}"/>
+                <a16:creationId xmlns:a16="http://schemas.microsoft.com/office/drawing/2014/main" id="{244BA36D-F3C2-4978-A4A8-ABDA476FCAEB}"/>
               </a:ext>
             </a:extLst>
           </p:cNvPr>
@@ -3136,7 +3161,7 @@
           <p:cNvPr id="16" name="">
             <a:extLst xmlns:a="http://schemas.openxmlformats.org/drawingml/2006/main">
               <a:ext uri="{FF2B5EF4-FFF2-40B4-BE49-F238E27FC236}">
-                <a16:creationId xmlns:a16="http://schemas.microsoft.com/office/drawing/2014/main" id="{AA1C6010-8E60-46F2-BB6F-ACBD49CDE02B}"/>
+                <a16:creationId xmlns:a16="http://schemas.microsoft.com/office/drawing/2014/main" id="{4793F329-7531-4AC6-B2AD-5BE6388B947F}"/>
               </a:ext>
             </a:extLst>
           </p:cNvPr>
@@ -3193,7 +3218,7 @@
           <p:cNvPr id="17" name="">
             <a:extLst xmlns:a="http://schemas.openxmlformats.org/drawingml/2006/main">
               <a:ext uri="{FF2B5EF4-FFF2-40B4-BE49-F238E27FC236}">
-                <a16:creationId xmlns:a16="http://schemas.microsoft.com/office/drawing/2014/main" id="{C52DB0FA-B098-407A-B47D-C7C9CF8C558F}"/>
+                <a16:creationId xmlns:a16="http://schemas.microsoft.com/office/drawing/2014/main" id="{80ECE40D-6461-4CA4-B8A9-02160E13A8D7}"/>
               </a:ext>
             </a:extLst>
           </p:cNvPr>
@@ -3250,7 +3275,7 @@
           <p:cNvPr id="18" name="">
             <a:extLst xmlns:a="http://schemas.openxmlformats.org/drawingml/2006/main">
               <a:ext uri="{FF2B5EF4-FFF2-40B4-BE49-F238E27FC236}">
-                <a16:creationId xmlns:a16="http://schemas.microsoft.com/office/drawing/2014/main" id="{08489739-DE6C-4FDC-AD54-413DFEE188F8}"/>
+                <a16:creationId xmlns:a16="http://schemas.microsoft.com/office/drawing/2014/main" id="{C483D0E5-6674-45CA-9BB4-C6BC32D80158}"/>
               </a:ext>
             </a:extLst>
           </p:cNvPr>
@@ -3281,7 +3306,7 @@
           <p:cNvPr id="19" name="">
             <a:extLst xmlns:a="http://schemas.openxmlformats.org/drawingml/2006/main">
               <a:ext uri="{FF2B5EF4-FFF2-40B4-BE49-F238E27FC236}">
-                <a16:creationId xmlns:a16="http://schemas.microsoft.com/office/drawing/2014/main" id="{CB48B7FD-47A3-4793-983D-DC7A7F7B29DF}"/>
+                <a16:creationId xmlns:a16="http://schemas.microsoft.com/office/drawing/2014/main" id="{3FB38F26-702F-4E5F-8655-0BA5F929E65E}"/>
               </a:ext>
             </a:extLst>
           </p:cNvPr>
@@ -3312,7 +3337,7 @@
           <p:cNvPr id="20" name="">
             <a:extLst xmlns:a="http://schemas.openxmlformats.org/drawingml/2006/main">
               <a:ext uri="{FF2B5EF4-FFF2-40B4-BE49-F238E27FC236}">
-                <a16:creationId xmlns:a16="http://schemas.microsoft.com/office/drawing/2014/main" id="{DCFE90CA-51E6-430A-AFB0-D25FF8E7D1AE}"/>
+                <a16:creationId xmlns:a16="http://schemas.microsoft.com/office/drawing/2014/main" id="{D5C4F99C-E089-4120-B822-A645ADC1251C}"/>
               </a:ext>
             </a:extLst>
           </p:cNvPr>
@@ -3343,7 +3368,7 @@
           <p:cNvPr id="21" name="">
             <a:extLst xmlns:a="http://schemas.openxmlformats.org/drawingml/2006/main">
               <a:ext uri="{FF2B5EF4-FFF2-40B4-BE49-F238E27FC236}">
-                <a16:creationId xmlns:a16="http://schemas.microsoft.com/office/drawing/2014/main" id="{10D9B56F-A71D-4921-9947-8873CE80FCDC}"/>
+                <a16:creationId xmlns:a16="http://schemas.microsoft.com/office/drawing/2014/main" id="{60683AA4-2497-48F6-8C10-B6384FA8B3E2}"/>
               </a:ext>
             </a:extLst>
           </p:cNvPr>
@@ -3400,7 +3425,7 @@
           <p:cNvPr id="22" name="">
             <a:extLst xmlns:a="http://schemas.openxmlformats.org/drawingml/2006/main">
               <a:ext uri="{FF2B5EF4-FFF2-40B4-BE49-F238E27FC236}">
-                <a16:creationId xmlns:a16="http://schemas.microsoft.com/office/drawing/2014/main" id="{08A31305-56AD-4742-BD73-FA41ABFC3E21}"/>
+                <a16:creationId xmlns:a16="http://schemas.microsoft.com/office/drawing/2014/main" id="{D27C28A2-475A-4A6E-B051-801C5420DE6C}"/>
               </a:ext>
             </a:extLst>
           </p:cNvPr>
@@ -3457,7 +3482,7 @@
           <p:cNvPr id="23" name="">
             <a:extLst xmlns:a="http://schemas.openxmlformats.org/drawingml/2006/main">
               <a:ext uri="{FF2B5EF4-FFF2-40B4-BE49-F238E27FC236}">
-                <a16:creationId xmlns:a16="http://schemas.microsoft.com/office/drawing/2014/main" id="{BEC0DE3A-3348-4157-8612-D1FA1CD367E9}"/>
+                <a16:creationId xmlns:a16="http://schemas.microsoft.com/office/drawing/2014/main" id="{CE3C1018-A3F0-4C5E-8601-66791C403BA2}"/>
               </a:ext>
             </a:extLst>
           </p:cNvPr>
@@ -3514,7 +3539,7 @@
           <p:cNvPr id="24" name="">
             <a:extLst xmlns:a="http://schemas.openxmlformats.org/drawingml/2006/main">
               <a:ext uri="{FF2B5EF4-FFF2-40B4-BE49-F238E27FC236}">
-                <a16:creationId xmlns:a16="http://schemas.microsoft.com/office/drawing/2014/main" id="{20DBC57A-7311-4E00-B53E-A7A0C3BB86BF}"/>
+                <a16:creationId xmlns:a16="http://schemas.microsoft.com/office/drawing/2014/main" id="{FC21AAE6-DCEB-4667-BE36-38D2313A61E1}"/>
               </a:ext>
             </a:extLst>
           </p:cNvPr>
@@ -3569,7 +3594,7 @@
     </p:spTree>
     <p:extLst>
       <p:ext uri="{BB962C8B-B14F-4D97-AF65-F5344CB8AC3E}">
-        <p14:creationId xmlns:p14="http://schemas.microsoft.com/office/powerpoint/2010/main" val="307942301"/>
+        <p14:creationId xmlns:p14="http://schemas.microsoft.com/office/powerpoint/2010/main" val="1654761745"/>
       </p:ext>
     </p:extLst>
   </p:cSld>
@@ -3600,7 +3625,7 @@
           <p:cNvPr id="8" name="">
             <a:extLst xmlns:a="http://schemas.openxmlformats.org/drawingml/2006/main">
               <a:ext uri="{FF2B5EF4-FFF2-40B4-BE49-F238E27FC236}">
-                <a16:creationId xmlns:a16="http://schemas.microsoft.com/office/drawing/2014/main" id="{703A5277-FBC5-4ED9-A268-31F8539C5F93}"/>
+                <a16:creationId xmlns:a16="http://schemas.microsoft.com/office/drawing/2014/main" id="{57FEB794-A5FF-490E-90B9-32A7D0602583}"/>
               </a:ext>
             </a:extLst>
           </p:cNvPr>
@@ -3630,7 +3655,7 @@
           <p:cNvPr id="2" name="">
             <a:extLst xmlns:a="http://schemas.openxmlformats.org/drawingml/2006/main">
               <a:ext uri="{FF2B5EF4-FFF2-40B4-BE49-F238E27FC236}">
-                <a16:creationId xmlns:a16="http://schemas.microsoft.com/office/drawing/2014/main" id="{27EE6F9A-9B42-4E12-B266-3E4B096C1AA6}"/>
+                <a16:creationId xmlns:a16="http://schemas.microsoft.com/office/drawing/2014/main" id="{7D28BE5E-E32C-4C3E-BE92-9439457BF390}"/>
               </a:ext>
             </a:extLst>
           </p:cNvPr>
@@ -3687,7 +3712,7 @@
           <p:cNvPr id="3" name="">
             <a:extLst xmlns:a="http://schemas.openxmlformats.org/drawingml/2006/main">
               <a:ext uri="{FF2B5EF4-FFF2-40B4-BE49-F238E27FC236}">
-                <a16:creationId xmlns:a16="http://schemas.microsoft.com/office/drawing/2014/main" id="{1361AAF3-5178-4297-AA36-78B1F81BF9C7}"/>
+                <a16:creationId xmlns:a16="http://schemas.microsoft.com/office/drawing/2014/main" id="{81C36CCD-3208-4B68-9860-A6A96D942A06}"/>
               </a:ext>
             </a:extLst>
           </p:cNvPr>
@@ -3744,7 +3769,7 @@
           <p:cNvPr id="4" name="">
             <a:extLst xmlns:a="http://schemas.openxmlformats.org/drawingml/2006/main">
               <a:ext uri="{FF2B5EF4-FFF2-40B4-BE49-F238E27FC236}">
-                <a16:creationId xmlns:a16="http://schemas.microsoft.com/office/drawing/2014/main" id="{711BCCBD-32FC-4FB6-84FE-C0EEDFB1D7EA}"/>
+                <a16:creationId xmlns:a16="http://schemas.microsoft.com/office/drawing/2014/main" id="{717E74EC-9F29-4011-9D16-3EA8183FA61E}"/>
               </a:ext>
             </a:extLst>
           </p:cNvPr>
@@ -3801,7 +3826,7 @@
           <p:cNvPr id="5" name="">
             <a:extLst xmlns:a="http://schemas.openxmlformats.org/drawingml/2006/main">
               <a:ext uri="{FF2B5EF4-FFF2-40B4-BE49-F238E27FC236}">
-                <a16:creationId xmlns:a16="http://schemas.microsoft.com/office/drawing/2014/main" id="{3777EC7D-8F94-4142-A7BC-D96D6315AE85}"/>
+                <a16:creationId xmlns:a16="http://schemas.microsoft.com/office/drawing/2014/main" id="{80DB446F-3D02-4483-8A73-09F45DEFD91C}"/>
               </a:ext>
             </a:extLst>
           </p:cNvPr>
@@ -4470,7 +4495,7 @@
           <p:cNvPr id="7" name="">
             <a:extLst xmlns:a="http://schemas.openxmlformats.org/drawingml/2006/main">
               <a:ext uri="{FF2B5EF4-FFF2-40B4-BE49-F238E27FC236}">
-                <a16:creationId xmlns:a16="http://schemas.microsoft.com/office/drawing/2014/main" id="{F3AA257A-924A-4443-A728-D3107D7AC45B}"/>
+                <a16:creationId xmlns:a16="http://schemas.microsoft.com/office/drawing/2014/main" id="{6E3CC33C-C2A3-4240-8688-800C31B10452}"/>
               </a:ext>
             </a:extLst>
           </p:cNvPr>
@@ -4525,7 +4550,7 @@
     </p:spTree>
     <p:extLst>
       <p:ext uri="{BB962C8B-B14F-4D97-AF65-F5344CB8AC3E}">
-        <p14:creationId xmlns:p14="http://schemas.microsoft.com/office/powerpoint/2010/main" val="153937172"/>
+        <p14:creationId xmlns:p14="http://schemas.microsoft.com/office/powerpoint/2010/main" val="398524453"/>
       </p:ext>
     </p:extLst>
   </p:cSld>
@@ -4556,7 +4581,7 @@
           <p:cNvPr id="27" name="">
             <a:extLst xmlns:a="http://schemas.openxmlformats.org/drawingml/2006/main">
               <a:ext uri="{FF2B5EF4-FFF2-40B4-BE49-F238E27FC236}">
-                <a16:creationId xmlns:a16="http://schemas.microsoft.com/office/drawing/2014/main" id="{1AEAAA9A-6108-4CDB-8D66-47AC03F83320}"/>
+                <a16:creationId xmlns:a16="http://schemas.microsoft.com/office/drawing/2014/main" id="{8192438D-78CC-4EC0-8EF8-07360B147078}"/>
               </a:ext>
             </a:extLst>
           </p:cNvPr>
@@ -4586,7 +4611,7 @@
           <p:cNvPr id="2" name="">
             <a:extLst xmlns:a="http://schemas.openxmlformats.org/drawingml/2006/main">
               <a:ext uri="{FF2B5EF4-FFF2-40B4-BE49-F238E27FC236}">
-                <a16:creationId xmlns:a16="http://schemas.microsoft.com/office/drawing/2014/main" id="{83C16368-A120-4AB5-83A1-6A37C57DB286}"/>
+                <a16:creationId xmlns:a16="http://schemas.microsoft.com/office/drawing/2014/main" id="{73315AA4-32AE-4D26-B15E-6895DEE4E945}"/>
               </a:ext>
             </a:extLst>
           </p:cNvPr>
@@ -4643,7 +4668,7 @@
           <p:cNvPr id="3" name="">
             <a:extLst xmlns:a="http://schemas.openxmlformats.org/drawingml/2006/main">
               <a:ext uri="{FF2B5EF4-FFF2-40B4-BE49-F238E27FC236}">
-                <a16:creationId xmlns:a16="http://schemas.microsoft.com/office/drawing/2014/main" id="{B34103AF-52E0-4C52-A254-FC779C5BBDBB}"/>
+                <a16:creationId xmlns:a16="http://schemas.microsoft.com/office/drawing/2014/main" id="{B1AD0EB3-D6C5-4368-91E1-1A29B1CE316F}"/>
               </a:ext>
             </a:extLst>
           </p:cNvPr>
@@ -4700,7 +4725,7 @@
           <p:cNvPr id="4" name="">
             <a:extLst xmlns:a="http://schemas.openxmlformats.org/drawingml/2006/main">
               <a:ext uri="{FF2B5EF4-FFF2-40B4-BE49-F238E27FC236}">
-                <a16:creationId xmlns:a16="http://schemas.microsoft.com/office/drawing/2014/main" id="{3CEF7E10-18D8-43FA-992C-61303FA6B92B}"/>
+                <a16:creationId xmlns:a16="http://schemas.microsoft.com/office/drawing/2014/main" id="{C99B7695-738A-4C3C-9D27-70709238788C}"/>
               </a:ext>
             </a:extLst>
           </p:cNvPr>
@@ -4757,7 +4782,7 @@
           <p:cNvPr id="5" name="">
             <a:extLst xmlns:a="http://schemas.openxmlformats.org/drawingml/2006/main">
               <a:ext uri="{FF2B5EF4-FFF2-40B4-BE49-F238E27FC236}">
-                <a16:creationId xmlns:a16="http://schemas.microsoft.com/office/drawing/2014/main" id="{392807A3-147A-4E61-BB3B-B3EE3EAFF4C7}"/>
+                <a16:creationId xmlns:a16="http://schemas.microsoft.com/office/drawing/2014/main" id="{918B425E-A97B-4403-BDD4-67F323852F6C}"/>
               </a:ext>
             </a:extLst>
           </p:cNvPr>
@@ -4814,7 +4839,7 @@
           <p:cNvPr id="6" name="">
             <a:extLst xmlns:a="http://schemas.openxmlformats.org/drawingml/2006/main">
               <a:ext uri="{FF2B5EF4-FFF2-40B4-BE49-F238E27FC236}">
-                <a16:creationId xmlns:a16="http://schemas.microsoft.com/office/drawing/2014/main" id="{F4AD82C8-8AD3-44B6-8C0C-A0E4BEDF0F45}"/>
+                <a16:creationId xmlns:a16="http://schemas.microsoft.com/office/drawing/2014/main" id="{03D70010-4254-4864-85F1-21A15E54192C}"/>
               </a:ext>
             </a:extLst>
           </p:cNvPr>
@@ -4849,7 +4874,7 @@
           <p:cNvPr id="7" name="">
             <a:extLst xmlns:a="http://schemas.openxmlformats.org/drawingml/2006/main">
               <a:ext uri="{FF2B5EF4-FFF2-40B4-BE49-F238E27FC236}">
-                <a16:creationId xmlns:a16="http://schemas.microsoft.com/office/drawing/2014/main" id="{1C55E10A-CD73-4A8B-9343-D93E355C2209}"/>
+                <a16:creationId xmlns:a16="http://schemas.microsoft.com/office/drawing/2014/main" id="{CC510263-3CBD-4E3C-BA43-FE878E4BD6E1}"/>
               </a:ext>
             </a:extLst>
           </p:cNvPr>
@@ -4906,7 +4931,7 @@
           <p:cNvPr id="8" name="">
             <a:extLst xmlns:a="http://schemas.openxmlformats.org/drawingml/2006/main">
               <a:ext uri="{FF2B5EF4-FFF2-40B4-BE49-F238E27FC236}">
-                <a16:creationId xmlns:a16="http://schemas.microsoft.com/office/drawing/2014/main" id="{AE6ADA0B-32DB-4590-9BD6-D05198E77B1D}"/>
+                <a16:creationId xmlns:a16="http://schemas.microsoft.com/office/drawing/2014/main" id="{771A747A-A7DE-4372-A310-F4C3ADD3F326}"/>
               </a:ext>
             </a:extLst>
           </p:cNvPr>
@@ -4963,7 +4988,7 @@
           <p:cNvPr id="9" name="">
             <a:extLst xmlns:a="http://schemas.openxmlformats.org/drawingml/2006/main">
               <a:ext uri="{FF2B5EF4-FFF2-40B4-BE49-F238E27FC236}">
-                <a16:creationId xmlns:a16="http://schemas.microsoft.com/office/drawing/2014/main" id="{C9706276-A87B-4E1A-BED1-CD5A5687DD02}"/>
+                <a16:creationId xmlns:a16="http://schemas.microsoft.com/office/drawing/2014/main" id="{6ACF0769-EA93-4748-BC24-B3193E4917A3}"/>
               </a:ext>
             </a:extLst>
           </p:cNvPr>
@@ -5020,7 +5045,7 @@
           <p:cNvPr id="10" name="">
             <a:extLst xmlns:a="http://schemas.openxmlformats.org/drawingml/2006/main">
               <a:ext uri="{FF2B5EF4-FFF2-40B4-BE49-F238E27FC236}">
-                <a16:creationId xmlns:a16="http://schemas.microsoft.com/office/drawing/2014/main" id="{39BF982A-19DF-4BF1-81BB-5F5AB6A9D23C}"/>
+                <a16:creationId xmlns:a16="http://schemas.microsoft.com/office/drawing/2014/main" id="{1A8DC4C0-5106-4F68-8DE4-82E647F7B38C}"/>
               </a:ext>
             </a:extLst>
           </p:cNvPr>
@@ -5077,7 +5102,7 @@
           <p:cNvPr id="11" name="">
             <a:extLst xmlns:a="http://schemas.openxmlformats.org/drawingml/2006/main">
               <a:ext uri="{FF2B5EF4-FFF2-40B4-BE49-F238E27FC236}">
-                <a16:creationId xmlns:a16="http://schemas.microsoft.com/office/drawing/2014/main" id="{5D038025-FDC3-4B05-A399-6DA67FADD2E9}"/>
+                <a16:creationId xmlns:a16="http://schemas.microsoft.com/office/drawing/2014/main" id="{F4A8B0D1-24E2-4103-8E1E-36C199BB6C68}"/>
               </a:ext>
             </a:extLst>
           </p:cNvPr>
@@ -5134,7 +5159,7 @@
           <p:cNvPr id="12" name="">
             <a:extLst xmlns:a="http://schemas.openxmlformats.org/drawingml/2006/main">
               <a:ext uri="{FF2B5EF4-FFF2-40B4-BE49-F238E27FC236}">
-                <a16:creationId xmlns:a16="http://schemas.microsoft.com/office/drawing/2014/main" id="{645571B0-C097-43B7-8774-E366FA97585A}"/>
+                <a16:creationId xmlns:a16="http://schemas.microsoft.com/office/drawing/2014/main" id="{C52D80E0-0190-4FB2-B05E-32BC92B8BCFD}"/>
               </a:ext>
             </a:extLst>
           </p:cNvPr>
@@ -5169,7 +5194,7 @@
           <p:cNvPr id="13" name="">
             <a:extLst xmlns:a="http://schemas.openxmlformats.org/drawingml/2006/main">
               <a:ext uri="{FF2B5EF4-FFF2-40B4-BE49-F238E27FC236}">
-                <a16:creationId xmlns:a16="http://schemas.microsoft.com/office/drawing/2014/main" id="{B639AA25-D5CF-438F-9183-9AFDED8E1323}"/>
+                <a16:creationId xmlns:a16="http://schemas.microsoft.com/office/drawing/2014/main" id="{F60E2E1F-7220-4BD3-A8F6-8F24893F45F9}"/>
               </a:ext>
             </a:extLst>
           </p:cNvPr>
@@ -5226,7 +5251,7 @@
           <p:cNvPr id="14" name="">
             <a:extLst xmlns:a="http://schemas.openxmlformats.org/drawingml/2006/main">
               <a:ext uri="{FF2B5EF4-FFF2-40B4-BE49-F238E27FC236}">
-                <a16:creationId xmlns:a16="http://schemas.microsoft.com/office/drawing/2014/main" id="{78CD7E09-CC84-4BF9-BFF3-3A519BED7058}"/>
+                <a16:creationId xmlns:a16="http://schemas.microsoft.com/office/drawing/2014/main" id="{05B64D5D-C281-43F2-9EBC-6C948B838052}"/>
               </a:ext>
             </a:extLst>
           </p:cNvPr>
@@ -5283,7 +5308,7 @@
           <p:cNvPr id="15" name="">
             <a:extLst xmlns:a="http://schemas.openxmlformats.org/drawingml/2006/main">
               <a:ext uri="{FF2B5EF4-FFF2-40B4-BE49-F238E27FC236}">
-                <a16:creationId xmlns:a16="http://schemas.microsoft.com/office/drawing/2014/main" id="{24C3FAF5-EC4E-42C3-B52C-834A98A82A38}"/>
+                <a16:creationId xmlns:a16="http://schemas.microsoft.com/office/drawing/2014/main" id="{F7DAE058-389D-4855-BCA0-10390DD07FB3}"/>
               </a:ext>
             </a:extLst>
           </p:cNvPr>
@@ -5340,7 +5365,7 @@
           <p:cNvPr id="16" name="">
             <a:extLst xmlns:a="http://schemas.openxmlformats.org/drawingml/2006/main">
               <a:ext uri="{FF2B5EF4-FFF2-40B4-BE49-F238E27FC236}">
-                <a16:creationId xmlns:a16="http://schemas.microsoft.com/office/drawing/2014/main" id="{244AF099-3A60-4D21-BB8B-8EADB2D7B1C9}"/>
+                <a16:creationId xmlns:a16="http://schemas.microsoft.com/office/drawing/2014/main" id="{CE43C376-676A-4FE1-8235-1259305C45F9}"/>
               </a:ext>
             </a:extLst>
           </p:cNvPr>
@@ -5397,7 +5422,7 @@
           <p:cNvPr id="17" name="">
             <a:extLst xmlns:a="http://schemas.openxmlformats.org/drawingml/2006/main">
               <a:ext uri="{FF2B5EF4-FFF2-40B4-BE49-F238E27FC236}">
-                <a16:creationId xmlns:a16="http://schemas.microsoft.com/office/drawing/2014/main" id="{F1AD50AE-60DD-4106-B7DE-0DE5123F6D66}"/>
+                <a16:creationId xmlns:a16="http://schemas.microsoft.com/office/drawing/2014/main" id="{763D0C7F-8746-4AEB-AD9B-BB29CB7C9BEC}"/>
               </a:ext>
             </a:extLst>
           </p:cNvPr>
@@ -5444,7 +5469,7 @@
                 <a:ea typeface="Liberation Sans"/>
                 <a:cs typeface="Liberation Sans"/>
               </a:rPr>
-              <a:t>restarts rising</a:t>
+              <a:t>7 restarts observed</a:t>
             </a:r>
           </a:p>
         </p:txBody>
@@ -5454,7 +5479,7 @@
           <p:cNvPr id="18" name="">
             <a:extLst xmlns:a="http://schemas.openxmlformats.org/drawingml/2006/main">
               <a:ext uri="{FF2B5EF4-FFF2-40B4-BE49-F238E27FC236}">
-                <a16:creationId xmlns:a16="http://schemas.microsoft.com/office/drawing/2014/main" id="{A5F90F0F-0616-41A1-93EE-6CDC353A0D15}"/>
+                <a16:creationId xmlns:a16="http://schemas.microsoft.com/office/drawing/2014/main" id="{9A0DB1C0-05F1-4AD5-A077-389CA3DEFB21}"/>
               </a:ext>
             </a:extLst>
           </p:cNvPr>
@@ -5489,7 +5514,7 @@
           <p:cNvPr id="19" name="">
             <a:extLst xmlns:a="http://schemas.openxmlformats.org/drawingml/2006/main">
               <a:ext uri="{FF2B5EF4-FFF2-40B4-BE49-F238E27FC236}">
-                <a16:creationId xmlns:a16="http://schemas.microsoft.com/office/drawing/2014/main" id="{F9C55342-348E-4C31-AAA2-A460DBA613D4}"/>
+                <a16:creationId xmlns:a16="http://schemas.microsoft.com/office/drawing/2014/main" id="{BE23BCD8-87CC-4B52-B8B3-1F366868B635}"/>
               </a:ext>
             </a:extLst>
           </p:cNvPr>
@@ -5546,7 +5571,7 @@
           <p:cNvPr id="20" name="">
             <a:extLst xmlns:a="http://schemas.openxmlformats.org/drawingml/2006/main">
               <a:ext uri="{FF2B5EF4-FFF2-40B4-BE49-F238E27FC236}">
-                <a16:creationId xmlns:a16="http://schemas.microsoft.com/office/drawing/2014/main" id="{D9C54496-864D-4856-B602-0F479411114E}"/>
+                <a16:creationId xmlns:a16="http://schemas.microsoft.com/office/drawing/2014/main" id="{85615958-EDB9-4578-8690-3548C3CC493D}"/>
               </a:ext>
             </a:extLst>
           </p:cNvPr>
@@ -5603,7 +5628,7 @@
           <p:cNvPr id="21" name="">
             <a:extLst xmlns:a="http://schemas.openxmlformats.org/drawingml/2006/main">
               <a:ext uri="{FF2B5EF4-FFF2-40B4-BE49-F238E27FC236}">
-                <a16:creationId xmlns:a16="http://schemas.microsoft.com/office/drawing/2014/main" id="{3FD62026-636D-4E5A-B37F-928180997257}"/>
+                <a16:creationId xmlns:a16="http://schemas.microsoft.com/office/drawing/2014/main" id="{230C1140-D82F-4E52-A856-CD7E3067EBD7}"/>
               </a:ext>
             </a:extLst>
           </p:cNvPr>
@@ -5660,7 +5685,7 @@
           <p:cNvPr id="22" name="">
             <a:extLst xmlns:a="http://schemas.openxmlformats.org/drawingml/2006/main">
               <a:ext uri="{FF2B5EF4-FFF2-40B4-BE49-F238E27FC236}">
-                <a16:creationId xmlns:a16="http://schemas.microsoft.com/office/drawing/2014/main" id="{EF77DE9C-2F2F-4AB8-8026-E59ED8E74F4B}"/>
+                <a16:creationId xmlns:a16="http://schemas.microsoft.com/office/drawing/2014/main" id="{B8BD04E6-C55D-428F-AD14-69B08C79427C}"/>
               </a:ext>
             </a:extLst>
           </p:cNvPr>
@@ -5717,7 +5742,7 @@
           <p:cNvPr id="23" name="">
             <a:extLst xmlns:a="http://schemas.openxmlformats.org/drawingml/2006/main">
               <a:ext uri="{FF2B5EF4-FFF2-40B4-BE49-F238E27FC236}">
-                <a16:creationId xmlns:a16="http://schemas.microsoft.com/office/drawing/2014/main" id="{362C8FE9-DE96-4818-AC08-D4DDE7D4566F}"/>
+                <a16:creationId xmlns:a16="http://schemas.microsoft.com/office/drawing/2014/main" id="{58C541CA-E0C2-42B2-96C9-D35A8963DD73}"/>
               </a:ext>
             </a:extLst>
           </p:cNvPr>
@@ -5774,7 +5799,7 @@
           <p:cNvPr id="24" name="">
             <a:extLst xmlns:a="http://schemas.openxmlformats.org/drawingml/2006/main">
               <a:ext uri="{FF2B5EF4-FFF2-40B4-BE49-F238E27FC236}">
-                <a16:creationId xmlns:a16="http://schemas.microsoft.com/office/drawing/2014/main" id="{771A5F25-90E6-4EBC-9BBA-A5F0722E88FD}"/>
+                <a16:creationId xmlns:a16="http://schemas.microsoft.com/office/drawing/2014/main" id="{B917758D-AF6A-4067-B19D-D7E08A9E2E2D}"/>
               </a:ext>
             </a:extLst>
           </p:cNvPr>
@@ -5831,7 +5856,7 @@
           <p:cNvPr id="25" name="">
             <a:extLst xmlns:a="http://schemas.openxmlformats.org/drawingml/2006/main">
               <a:ext uri="{FF2B5EF4-FFF2-40B4-BE49-F238E27FC236}">
-                <a16:creationId xmlns:a16="http://schemas.microsoft.com/office/drawing/2014/main" id="{23095FC8-A116-4A3F-9F0E-CB60747175CD}"/>
+                <a16:creationId xmlns:a16="http://schemas.microsoft.com/office/drawing/2014/main" id="{76D543EF-6276-481B-A7DE-59A557AE84BA}"/>
               </a:ext>
             </a:extLst>
           </p:cNvPr>
@@ -5866,7 +5891,7 @@
           <p:cNvPr id="26" name="">
             <a:extLst xmlns:a="http://schemas.openxmlformats.org/drawingml/2006/main">
               <a:ext uri="{FF2B5EF4-FFF2-40B4-BE49-F238E27FC236}">
-                <a16:creationId xmlns:a16="http://schemas.microsoft.com/office/drawing/2014/main" id="{994B81E5-394C-4F0D-BB21-D48B4FB7CEEC}"/>
+                <a16:creationId xmlns:a16="http://schemas.microsoft.com/office/drawing/2014/main" id="{1888F822-1E8B-4F51-9143-D450DDA269D3}"/>
               </a:ext>
             </a:extLst>
           </p:cNvPr>
@@ -5921,7 +5946,7 @@
     </p:spTree>
     <p:extLst>
       <p:ext uri="{BB962C8B-B14F-4D97-AF65-F5344CB8AC3E}">
-        <p14:creationId xmlns:p14="http://schemas.microsoft.com/office/powerpoint/2010/main" val="1617324533"/>
+        <p14:creationId xmlns:p14="http://schemas.microsoft.com/office/powerpoint/2010/main" val="416091867"/>
       </p:ext>
     </p:extLst>
   </p:cSld>
@@ -5952,7 +5977,7 @@
           <p:cNvPr id="31" name="">
             <a:extLst xmlns:a="http://schemas.openxmlformats.org/drawingml/2006/main">
               <a:ext uri="{FF2B5EF4-FFF2-40B4-BE49-F238E27FC236}">
-                <a16:creationId xmlns:a16="http://schemas.microsoft.com/office/drawing/2014/main" id="{D8A21064-28C6-4BD6-850C-1C7ABA531980}"/>
+                <a16:creationId xmlns:a16="http://schemas.microsoft.com/office/drawing/2014/main" id="{FE7A869C-CBB5-48CB-82BB-632B1EC1A3CD}"/>
               </a:ext>
             </a:extLst>
           </p:cNvPr>
@@ -5982,7 +6007,7 @@
           <p:cNvPr id="2" name="">
             <a:extLst xmlns:a="http://schemas.openxmlformats.org/drawingml/2006/main">
               <a:ext uri="{FF2B5EF4-FFF2-40B4-BE49-F238E27FC236}">
-                <a16:creationId xmlns:a16="http://schemas.microsoft.com/office/drawing/2014/main" id="{24E995FA-4C31-4E48-9C74-0D30F26A0D5B}"/>
+                <a16:creationId xmlns:a16="http://schemas.microsoft.com/office/drawing/2014/main" id="{5FCBD931-DD91-4BFA-91E4-A368F12D1222}"/>
               </a:ext>
             </a:extLst>
           </p:cNvPr>
@@ -6039,7 +6064,7 @@
           <p:cNvPr id="3" name="">
             <a:extLst xmlns:a="http://schemas.openxmlformats.org/drawingml/2006/main">
               <a:ext uri="{FF2B5EF4-FFF2-40B4-BE49-F238E27FC236}">
-                <a16:creationId xmlns:a16="http://schemas.microsoft.com/office/drawing/2014/main" id="{E3D71541-8BD1-45E9-A3D8-EB5CD6017F6A}"/>
+                <a16:creationId xmlns:a16="http://schemas.microsoft.com/office/drawing/2014/main" id="{AE036D0F-0F65-461F-B184-E408D5E0F2B8}"/>
               </a:ext>
             </a:extLst>
           </p:cNvPr>
@@ -6096,7 +6121,7 @@
           <p:cNvPr id="4" name="">
             <a:extLst xmlns:a="http://schemas.openxmlformats.org/drawingml/2006/main">
               <a:ext uri="{FF2B5EF4-FFF2-40B4-BE49-F238E27FC236}">
-                <a16:creationId xmlns:a16="http://schemas.microsoft.com/office/drawing/2014/main" id="{FAB434A3-D1AB-40CE-B722-40BACBD990E3}"/>
+                <a16:creationId xmlns:a16="http://schemas.microsoft.com/office/drawing/2014/main" id="{2FBF537F-A660-4CE8-8AEA-E154D016C6CC}"/>
               </a:ext>
             </a:extLst>
           </p:cNvPr>
@@ -6153,7 +6178,7 @@
           <p:cNvPr id="5" name="">
             <a:extLst xmlns:a="http://schemas.openxmlformats.org/drawingml/2006/main">
               <a:ext uri="{FF2B5EF4-FFF2-40B4-BE49-F238E27FC236}">
-                <a16:creationId xmlns:a16="http://schemas.microsoft.com/office/drawing/2014/main" id="{2361B5D3-C94D-4B90-8AD6-CEC11F3E1420}"/>
+                <a16:creationId xmlns:a16="http://schemas.microsoft.com/office/drawing/2014/main" id="{FF133A60-4314-4F0A-BEC7-CC045E599131}"/>
               </a:ext>
             </a:extLst>
           </p:cNvPr>
@@ -6210,7 +6235,7 @@
           <p:cNvPr id="6" name="">
             <a:extLst xmlns:a="http://schemas.openxmlformats.org/drawingml/2006/main">
               <a:ext uri="{FF2B5EF4-FFF2-40B4-BE49-F238E27FC236}">
-                <a16:creationId xmlns:a16="http://schemas.microsoft.com/office/drawing/2014/main" id="{5CF965D7-C78F-4361-BC0B-C5293B133805}"/>
+                <a16:creationId xmlns:a16="http://schemas.microsoft.com/office/drawing/2014/main" id="{97271589-6700-4DEA-ABBE-A9741AEF72A6}"/>
               </a:ext>
             </a:extLst>
           </p:cNvPr>
@@ -6240,7 +6265,7 @@
           <p:cNvPr id="7" name="">
             <a:extLst xmlns:a="http://schemas.openxmlformats.org/drawingml/2006/main">
               <a:ext uri="{FF2B5EF4-FFF2-40B4-BE49-F238E27FC236}">
-                <a16:creationId xmlns:a16="http://schemas.microsoft.com/office/drawing/2014/main" id="{7F4EC70F-B982-4EED-ADE9-691EF46A648C}"/>
+                <a16:creationId xmlns:a16="http://schemas.microsoft.com/office/drawing/2014/main" id="{06E03358-1C66-4961-9B52-9189354DCE9F}"/>
               </a:ext>
             </a:extLst>
           </p:cNvPr>
@@ -6297,7 +6322,7 @@
           <p:cNvPr id="8" name="">
             <a:extLst xmlns:a="http://schemas.openxmlformats.org/drawingml/2006/main">
               <a:ext uri="{FF2B5EF4-FFF2-40B4-BE49-F238E27FC236}">
-                <a16:creationId xmlns:a16="http://schemas.microsoft.com/office/drawing/2014/main" id="{60FFA988-2AE4-47F2-8F9D-74F02F1532AD}"/>
+                <a16:creationId xmlns:a16="http://schemas.microsoft.com/office/drawing/2014/main" id="{F692AB01-0130-42C2-A6AC-914BD458897A}"/>
               </a:ext>
             </a:extLst>
           </p:cNvPr>
@@ -6354,7 +6379,7 @@
           <p:cNvPr id="9" name="">
             <a:extLst xmlns:a="http://schemas.openxmlformats.org/drawingml/2006/main">
               <a:ext uri="{FF2B5EF4-FFF2-40B4-BE49-F238E27FC236}">
-                <a16:creationId xmlns:a16="http://schemas.microsoft.com/office/drawing/2014/main" id="{2D0E2F75-37A1-4150-B581-8A6138FA99EF}"/>
+                <a16:creationId xmlns:a16="http://schemas.microsoft.com/office/drawing/2014/main" id="{D82C898D-7378-430B-BEE6-48A00EFA7561}"/>
               </a:ext>
             </a:extLst>
           </p:cNvPr>
@@ -6385,7 +6410,7 @@
           <p:cNvPr id="10" name="">
             <a:extLst xmlns:a="http://schemas.openxmlformats.org/drawingml/2006/main">
               <a:ext uri="{FF2B5EF4-FFF2-40B4-BE49-F238E27FC236}">
-                <a16:creationId xmlns:a16="http://schemas.microsoft.com/office/drawing/2014/main" id="{277203A0-A508-4EFC-B6B6-92538F0A732C}"/>
+                <a16:creationId xmlns:a16="http://schemas.microsoft.com/office/drawing/2014/main" id="{8B31B686-2B37-4B5A-8CB8-12860C190B10}"/>
               </a:ext>
             </a:extLst>
           </p:cNvPr>
@@ -6415,7 +6440,7 @@
           <p:cNvPr id="11" name="">
             <a:extLst xmlns:a="http://schemas.openxmlformats.org/drawingml/2006/main">
               <a:ext uri="{FF2B5EF4-FFF2-40B4-BE49-F238E27FC236}">
-                <a16:creationId xmlns:a16="http://schemas.microsoft.com/office/drawing/2014/main" id="{58818BF2-D51F-4710-B7C6-29BC050BF204}"/>
+                <a16:creationId xmlns:a16="http://schemas.microsoft.com/office/drawing/2014/main" id="{613A46E2-642D-48E0-B872-BE3F5D207F06}"/>
               </a:ext>
             </a:extLst>
           </p:cNvPr>
@@ -6472,7 +6497,7 @@
           <p:cNvPr id="12" name="">
             <a:extLst xmlns:a="http://schemas.openxmlformats.org/drawingml/2006/main">
               <a:ext uri="{FF2B5EF4-FFF2-40B4-BE49-F238E27FC236}">
-                <a16:creationId xmlns:a16="http://schemas.microsoft.com/office/drawing/2014/main" id="{CC2E1FFA-234C-45D3-A275-406B25B54DE8}"/>
+                <a16:creationId xmlns:a16="http://schemas.microsoft.com/office/drawing/2014/main" id="{C161EC18-A1CC-4859-890F-31F9AD38C10F}"/>
               </a:ext>
             </a:extLst>
           </p:cNvPr>
@@ -6529,7 +6554,7 @@
           <p:cNvPr id="13" name="">
             <a:extLst xmlns:a="http://schemas.openxmlformats.org/drawingml/2006/main">
               <a:ext uri="{FF2B5EF4-FFF2-40B4-BE49-F238E27FC236}">
-                <a16:creationId xmlns:a16="http://schemas.microsoft.com/office/drawing/2014/main" id="{4D1A65DC-36B8-4F48-9A9C-10E6874ABB56}"/>
+                <a16:creationId xmlns:a16="http://schemas.microsoft.com/office/drawing/2014/main" id="{DBC2D867-00A7-4807-8353-5B900348F1EE}"/>
               </a:ext>
             </a:extLst>
           </p:cNvPr>
@@ -6560,7 +6585,7 @@
           <p:cNvPr id="14" name="">
             <a:extLst xmlns:a="http://schemas.openxmlformats.org/drawingml/2006/main">
               <a:ext uri="{FF2B5EF4-FFF2-40B4-BE49-F238E27FC236}">
-                <a16:creationId xmlns:a16="http://schemas.microsoft.com/office/drawing/2014/main" id="{7BF8B8D1-28F4-4BCD-9630-54F57EC221FE}"/>
+                <a16:creationId xmlns:a16="http://schemas.microsoft.com/office/drawing/2014/main" id="{C2E5AA1F-4E47-4EAF-801D-9E12BE709370}"/>
               </a:ext>
             </a:extLst>
           </p:cNvPr>
@@ -6590,7 +6615,7 @@
           <p:cNvPr id="15" name="">
             <a:extLst xmlns:a="http://schemas.openxmlformats.org/drawingml/2006/main">
               <a:ext uri="{FF2B5EF4-FFF2-40B4-BE49-F238E27FC236}">
-                <a16:creationId xmlns:a16="http://schemas.microsoft.com/office/drawing/2014/main" id="{06908C48-71E5-442B-8FF7-E9DCDB8AF638}"/>
+                <a16:creationId xmlns:a16="http://schemas.microsoft.com/office/drawing/2014/main" id="{AC3109C4-843E-4F8A-871C-1EE9EC1E50DC}"/>
               </a:ext>
             </a:extLst>
           </p:cNvPr>
@@ -6647,7 +6672,7 @@
           <p:cNvPr id="16" name="">
             <a:extLst xmlns:a="http://schemas.openxmlformats.org/drawingml/2006/main">
               <a:ext uri="{FF2B5EF4-FFF2-40B4-BE49-F238E27FC236}">
-                <a16:creationId xmlns:a16="http://schemas.microsoft.com/office/drawing/2014/main" id="{1C6B7D67-5771-4015-BC66-28E31C744075}"/>
+                <a16:creationId xmlns:a16="http://schemas.microsoft.com/office/drawing/2014/main" id="{04DC71FA-4789-40F9-B736-B835CF8A8420}"/>
               </a:ext>
             </a:extLst>
           </p:cNvPr>
@@ -6704,7 +6729,7 @@
           <p:cNvPr id="17" name="">
             <a:extLst xmlns:a="http://schemas.openxmlformats.org/drawingml/2006/main">
               <a:ext uri="{FF2B5EF4-FFF2-40B4-BE49-F238E27FC236}">
-                <a16:creationId xmlns:a16="http://schemas.microsoft.com/office/drawing/2014/main" id="{FD61472D-BF85-4AEB-A2B6-58CA6760CCEB}"/>
+                <a16:creationId xmlns:a16="http://schemas.microsoft.com/office/drawing/2014/main" id="{38B5F21A-D999-4D26-BBA9-F3E5B06713B4}"/>
               </a:ext>
             </a:extLst>
           </p:cNvPr>
@@ -6735,7 +6760,7 @@
           <p:cNvPr id="18" name="">
             <a:extLst xmlns:a="http://schemas.openxmlformats.org/drawingml/2006/main">
               <a:ext uri="{FF2B5EF4-FFF2-40B4-BE49-F238E27FC236}">
-                <a16:creationId xmlns:a16="http://schemas.microsoft.com/office/drawing/2014/main" id="{F1FD180A-083E-4CB6-9DB1-429CF58E1F03}"/>
+                <a16:creationId xmlns:a16="http://schemas.microsoft.com/office/drawing/2014/main" id="{107730DF-A55D-4E97-97AB-51A40224FEDB}"/>
               </a:ext>
             </a:extLst>
           </p:cNvPr>
@@ -6765,7 +6790,7 @@
           <p:cNvPr id="19" name="">
             <a:extLst xmlns:a="http://schemas.openxmlformats.org/drawingml/2006/main">
               <a:ext uri="{FF2B5EF4-FFF2-40B4-BE49-F238E27FC236}">
-                <a16:creationId xmlns:a16="http://schemas.microsoft.com/office/drawing/2014/main" id="{89BA154B-0852-413E-AF3B-60CAD1698220}"/>
+                <a16:creationId xmlns:a16="http://schemas.microsoft.com/office/drawing/2014/main" id="{DF7B9C77-391E-4F22-B833-2761E2456B1F}"/>
               </a:ext>
             </a:extLst>
           </p:cNvPr>
@@ -6822,7 +6847,7 @@
           <p:cNvPr id="20" name="">
             <a:extLst xmlns:a="http://schemas.openxmlformats.org/drawingml/2006/main">
               <a:ext uri="{FF2B5EF4-FFF2-40B4-BE49-F238E27FC236}">
-                <a16:creationId xmlns:a16="http://schemas.microsoft.com/office/drawing/2014/main" id="{B08C7581-E4D4-4FBC-B689-A9A4E3B79F83}"/>
+                <a16:creationId xmlns:a16="http://schemas.microsoft.com/office/drawing/2014/main" id="{DDAB7083-A8DF-4DC1-9772-C7180B684D6C}"/>
               </a:ext>
             </a:extLst>
           </p:cNvPr>
@@ -6879,7 +6904,7 @@
           <p:cNvPr id="21" name="">
             <a:extLst xmlns:a="http://schemas.openxmlformats.org/drawingml/2006/main">
               <a:ext uri="{FF2B5EF4-FFF2-40B4-BE49-F238E27FC236}">
-                <a16:creationId xmlns:a16="http://schemas.microsoft.com/office/drawing/2014/main" id="{ACB4739A-7E8A-47C6-9141-C29CEFA7D827}"/>
+                <a16:creationId xmlns:a16="http://schemas.microsoft.com/office/drawing/2014/main" id="{2A6A5F50-4C11-41C2-911E-12042808C070}"/>
               </a:ext>
             </a:extLst>
           </p:cNvPr>
@@ -6910,7 +6935,7 @@
           <p:cNvPr id="22" name="">
             <a:extLst xmlns:a="http://schemas.openxmlformats.org/drawingml/2006/main">
               <a:ext uri="{FF2B5EF4-FFF2-40B4-BE49-F238E27FC236}">
-                <a16:creationId xmlns:a16="http://schemas.microsoft.com/office/drawing/2014/main" id="{6D232D3C-C826-46A4-8164-20BCF66DC26D}"/>
+                <a16:creationId xmlns:a16="http://schemas.microsoft.com/office/drawing/2014/main" id="{151545EA-FF7C-4AE3-8DAB-6777C39F413C}"/>
               </a:ext>
             </a:extLst>
           </p:cNvPr>
@@ -6945,7 +6970,7 @@
           <p:cNvPr id="23" name="">
             <a:extLst xmlns:a="http://schemas.openxmlformats.org/drawingml/2006/main">
               <a:ext uri="{FF2B5EF4-FFF2-40B4-BE49-F238E27FC236}">
-                <a16:creationId xmlns:a16="http://schemas.microsoft.com/office/drawing/2014/main" id="{C95217F5-1FEC-4D59-BE9D-DAD9CE3BD1D8}"/>
+                <a16:creationId xmlns:a16="http://schemas.microsoft.com/office/drawing/2014/main" id="{25268148-7F84-44A2-8E0A-A2553C9C578F}"/>
               </a:ext>
             </a:extLst>
           </p:cNvPr>
@@ -7002,7 +7027,7 @@
           <p:cNvPr id="24" name="">
             <a:extLst xmlns:a="http://schemas.openxmlformats.org/drawingml/2006/main">
               <a:ext uri="{FF2B5EF4-FFF2-40B4-BE49-F238E27FC236}">
-                <a16:creationId xmlns:a16="http://schemas.microsoft.com/office/drawing/2014/main" id="{1B83F92D-DF0F-4943-8CFC-D7BFEBE0D831}"/>
+                <a16:creationId xmlns:a16="http://schemas.microsoft.com/office/drawing/2014/main" id="{86662A1C-0A49-461A-87A2-70F4C16C382C}"/>
               </a:ext>
             </a:extLst>
           </p:cNvPr>
@@ -7059,7 +7084,7 @@
           <p:cNvPr id="25" name="">
             <a:extLst xmlns:a="http://schemas.openxmlformats.org/drawingml/2006/main">
               <a:ext uri="{FF2B5EF4-FFF2-40B4-BE49-F238E27FC236}">
-                <a16:creationId xmlns:a16="http://schemas.microsoft.com/office/drawing/2014/main" id="{5A9ADD61-C599-4363-A55E-F81A34B80623}"/>
+                <a16:creationId xmlns:a16="http://schemas.microsoft.com/office/drawing/2014/main" id="{10C88C4C-02FB-4CA7-BD7A-9EBB5B80BE5F}"/>
               </a:ext>
             </a:extLst>
           </p:cNvPr>
@@ -7090,7 +7115,7 @@
           <p:cNvPr id="26" name="">
             <a:extLst xmlns:a="http://schemas.openxmlformats.org/drawingml/2006/main">
               <a:ext uri="{FF2B5EF4-FFF2-40B4-BE49-F238E27FC236}">
-                <a16:creationId xmlns:a16="http://schemas.microsoft.com/office/drawing/2014/main" id="{44268BF3-B77D-4723-9508-BE0B646F1507}"/>
+                <a16:creationId xmlns:a16="http://schemas.microsoft.com/office/drawing/2014/main" id="{C8A11930-6535-4E2B-8DCC-E6D0474F4736}"/>
               </a:ext>
             </a:extLst>
           </p:cNvPr>
@@ -7147,7 +7172,7 @@
           <p:cNvPr id="27" name="">
             <a:extLst xmlns:a="http://schemas.openxmlformats.org/drawingml/2006/main">
               <a:ext uri="{FF2B5EF4-FFF2-40B4-BE49-F238E27FC236}">
-                <a16:creationId xmlns:a16="http://schemas.microsoft.com/office/drawing/2014/main" id="{CB10DA4F-EDD7-4691-8EF0-94A18BF9E71A}"/>
+                <a16:creationId xmlns:a16="http://schemas.microsoft.com/office/drawing/2014/main" id="{1B7803B4-F135-4507-AF1D-89010DED8C3D}"/>
               </a:ext>
             </a:extLst>
           </p:cNvPr>
@@ -7178,7 +7203,7 @@
           <p:cNvPr id="28" name="">
             <a:extLst xmlns:a="http://schemas.openxmlformats.org/drawingml/2006/main">
               <a:ext uri="{FF2B5EF4-FFF2-40B4-BE49-F238E27FC236}">
-                <a16:creationId xmlns:a16="http://schemas.microsoft.com/office/drawing/2014/main" id="{FA2C453A-7EDE-429E-BCA3-141544E20513}"/>
+                <a16:creationId xmlns:a16="http://schemas.microsoft.com/office/drawing/2014/main" id="{BDE7FA62-0FCA-48E3-BD5B-55AA114D2BFC}"/>
               </a:ext>
             </a:extLst>
           </p:cNvPr>
@@ -7235,7 +7260,7 @@
           <p:cNvPr id="29" name="">
             <a:extLst xmlns:a="http://schemas.openxmlformats.org/drawingml/2006/main">
               <a:ext uri="{FF2B5EF4-FFF2-40B4-BE49-F238E27FC236}">
-                <a16:creationId xmlns:a16="http://schemas.microsoft.com/office/drawing/2014/main" id="{6119D77B-65C8-4F83-89BC-54AF013B193E}"/>
+                <a16:creationId xmlns:a16="http://schemas.microsoft.com/office/drawing/2014/main" id="{9DC99E09-4500-44F8-ADCB-7672AEC57147}"/>
               </a:ext>
             </a:extLst>
           </p:cNvPr>
@@ -7266,7 +7291,7 @@
           <p:cNvPr id="30" name="">
             <a:extLst xmlns:a="http://schemas.openxmlformats.org/drawingml/2006/main">
               <a:ext uri="{FF2B5EF4-FFF2-40B4-BE49-F238E27FC236}">
-                <a16:creationId xmlns:a16="http://schemas.microsoft.com/office/drawing/2014/main" id="{B649645F-3EC0-4574-85F7-BA07FA325601}"/>
+                <a16:creationId xmlns:a16="http://schemas.microsoft.com/office/drawing/2014/main" id="{1D6F27F9-7D8A-48EF-8D4E-717E6D427D49}"/>
               </a:ext>
             </a:extLst>
           </p:cNvPr>
@@ -7321,7 +7346,7 @@
     </p:spTree>
     <p:extLst>
       <p:ext uri="{BB962C8B-B14F-4D97-AF65-F5344CB8AC3E}">
-        <p14:creationId xmlns:p14="http://schemas.microsoft.com/office/powerpoint/2010/main" val="1214569235"/>
+        <p14:creationId xmlns:p14="http://schemas.microsoft.com/office/powerpoint/2010/main" val="240591595"/>
       </p:ext>
     </p:extLst>
   </p:cSld>
@@ -7352,7 +7377,7 @@
           <p:cNvPr id="24" name="">
             <a:extLst xmlns:a="http://schemas.openxmlformats.org/drawingml/2006/main">
               <a:ext uri="{FF2B5EF4-FFF2-40B4-BE49-F238E27FC236}">
-                <a16:creationId xmlns:a16="http://schemas.microsoft.com/office/drawing/2014/main" id="{C77BE5C9-59F7-4AE4-97D9-DADB9E907FCE}"/>
+                <a16:creationId xmlns:a16="http://schemas.microsoft.com/office/drawing/2014/main" id="{19C82A80-A5CC-4190-99AA-CB42A87CCF77}"/>
               </a:ext>
             </a:extLst>
           </p:cNvPr>
@@ -7382,7 +7407,7 @@
           <p:cNvPr id="2" name="">
             <a:extLst xmlns:a="http://schemas.openxmlformats.org/drawingml/2006/main">
               <a:ext uri="{FF2B5EF4-FFF2-40B4-BE49-F238E27FC236}">
-                <a16:creationId xmlns:a16="http://schemas.microsoft.com/office/drawing/2014/main" id="{14F7D0CA-79F3-48D5-914C-D70509AFE2AE}"/>
+                <a16:creationId xmlns:a16="http://schemas.microsoft.com/office/drawing/2014/main" id="{D0A84E5D-0349-44D9-8D20-9655586C02F2}"/>
               </a:ext>
             </a:extLst>
           </p:cNvPr>
@@ -7439,7 +7464,7 @@
           <p:cNvPr id="3" name="">
             <a:extLst xmlns:a="http://schemas.openxmlformats.org/drawingml/2006/main">
               <a:ext uri="{FF2B5EF4-FFF2-40B4-BE49-F238E27FC236}">
-                <a16:creationId xmlns:a16="http://schemas.microsoft.com/office/drawing/2014/main" id="{37C1D538-4094-49D9-83A4-6DBEFC2549A0}"/>
+                <a16:creationId xmlns:a16="http://schemas.microsoft.com/office/drawing/2014/main" id="{42BEC5EA-54BA-4F5B-AF4C-A697185F8865}"/>
               </a:ext>
             </a:extLst>
           </p:cNvPr>
@@ -7496,7 +7521,7 @@
           <p:cNvPr id="4" name="">
             <a:extLst xmlns:a="http://schemas.openxmlformats.org/drawingml/2006/main">
               <a:ext uri="{FF2B5EF4-FFF2-40B4-BE49-F238E27FC236}">
-                <a16:creationId xmlns:a16="http://schemas.microsoft.com/office/drawing/2014/main" id="{CCD826F0-8011-41A6-9E6F-AD20D22D537B}"/>
+                <a16:creationId xmlns:a16="http://schemas.microsoft.com/office/drawing/2014/main" id="{E26D9359-2A8B-4A81-B720-6B63A3D6EB2F}"/>
               </a:ext>
             </a:extLst>
           </p:cNvPr>
@@ -7553,7 +7578,7 @@
           <p:cNvPr id="5" name="">
             <a:extLst xmlns:a="http://schemas.openxmlformats.org/drawingml/2006/main">
               <a:ext uri="{FF2B5EF4-FFF2-40B4-BE49-F238E27FC236}">
-                <a16:creationId xmlns:a16="http://schemas.microsoft.com/office/drawing/2014/main" id="{4AEC2B14-B662-4D87-B3EA-B726349CEAEC}"/>
+                <a16:creationId xmlns:a16="http://schemas.microsoft.com/office/drawing/2014/main" id="{7534C9D7-3758-4CC3-8DE1-F067EE1A0281}"/>
               </a:ext>
             </a:extLst>
           </p:cNvPr>
@@ -7610,7 +7635,7 @@
           <p:cNvPr id="6" name="">
             <a:extLst xmlns:a="http://schemas.openxmlformats.org/drawingml/2006/main">
               <a:ext uri="{FF2B5EF4-FFF2-40B4-BE49-F238E27FC236}">
-                <a16:creationId xmlns:a16="http://schemas.microsoft.com/office/drawing/2014/main" id="{53E5CAD0-49FC-4AD8-BF68-1E4B08B49A62}"/>
+                <a16:creationId xmlns:a16="http://schemas.microsoft.com/office/drawing/2014/main" id="{57CE8EBD-7D98-4E99-9518-D5CB54BFCD6A}"/>
               </a:ext>
             </a:extLst>
           </p:cNvPr>
@@ -7643,7 +7668,7 @@
           <p:cNvPr id="7" name="">
             <a:extLst xmlns:a="http://schemas.openxmlformats.org/drawingml/2006/main">
               <a:ext uri="{FF2B5EF4-FFF2-40B4-BE49-F238E27FC236}">
-                <a16:creationId xmlns:a16="http://schemas.microsoft.com/office/drawing/2014/main" id="{A2EBBE13-E343-4C03-BCF0-82FBF1E6755E}"/>
+                <a16:creationId xmlns:a16="http://schemas.microsoft.com/office/drawing/2014/main" id="{96D6F702-AF4C-44B9-93CD-827E509BE481}"/>
               </a:ext>
             </a:extLst>
           </p:cNvPr>
@@ -7723,7 +7748,7 @@
           <p:cNvPr id="8" name="">
             <a:extLst xmlns:a="http://schemas.openxmlformats.org/drawingml/2006/main">
               <a:ext uri="{FF2B5EF4-FFF2-40B4-BE49-F238E27FC236}">
-                <a16:creationId xmlns:a16="http://schemas.microsoft.com/office/drawing/2014/main" id="{5FE81639-6323-4B73-9C0F-A1E75F0525B2}"/>
+                <a16:creationId xmlns:a16="http://schemas.microsoft.com/office/drawing/2014/main" id="{B3577C06-2381-4891-8B64-05CF2EB67080}"/>
               </a:ext>
             </a:extLst>
           </p:cNvPr>
@@ -7780,7 +7805,7 @@
           <p:cNvPr id="9" name="">
             <a:extLst xmlns:a="http://schemas.openxmlformats.org/drawingml/2006/main">
               <a:ext uri="{FF2B5EF4-FFF2-40B4-BE49-F238E27FC236}">
-                <a16:creationId xmlns:a16="http://schemas.microsoft.com/office/drawing/2014/main" id="{782A6D7B-BF9A-4A14-A276-EE7762349CA4}"/>
+                <a16:creationId xmlns:a16="http://schemas.microsoft.com/office/drawing/2014/main" id="{A011B752-9A21-49CC-8859-284C3E1FD3F1}"/>
               </a:ext>
             </a:extLst>
           </p:cNvPr>
@@ -7810,7 +7835,7 @@
           <p:cNvPr id="10" name="">
             <a:extLst xmlns:a="http://schemas.openxmlformats.org/drawingml/2006/main">
               <a:ext uri="{FF2B5EF4-FFF2-40B4-BE49-F238E27FC236}">
-                <a16:creationId xmlns:a16="http://schemas.microsoft.com/office/drawing/2014/main" id="{89437A0E-B860-4E5F-95A8-52DA5B3ABAFA}"/>
+                <a16:creationId xmlns:a16="http://schemas.microsoft.com/office/drawing/2014/main" id="{0AAB4323-7E33-48BE-BB20-81CA27126565}"/>
               </a:ext>
             </a:extLst>
           </p:cNvPr>
@@ -7867,7 +7892,7 @@
           <p:cNvPr id="11" name="">
             <a:extLst xmlns:a="http://schemas.openxmlformats.org/drawingml/2006/main">
               <a:ext uri="{FF2B5EF4-FFF2-40B4-BE49-F238E27FC236}">
-                <a16:creationId xmlns:a16="http://schemas.microsoft.com/office/drawing/2014/main" id="{8692C83B-FB44-4121-A6E9-EF544A3673C5}"/>
+                <a16:creationId xmlns:a16="http://schemas.microsoft.com/office/drawing/2014/main" id="{A0E56BAC-C5D2-4D52-A639-6A453581D66F}"/>
               </a:ext>
             </a:extLst>
           </p:cNvPr>
@@ -7924,7 +7949,7 @@
           <p:cNvPr id="12" name="">
             <a:extLst xmlns:a="http://schemas.openxmlformats.org/drawingml/2006/main">
               <a:ext uri="{FF2B5EF4-FFF2-40B4-BE49-F238E27FC236}">
-                <a16:creationId xmlns:a16="http://schemas.microsoft.com/office/drawing/2014/main" id="{7B1EF6A3-2109-471B-BF1B-D90D27D4EB86}"/>
+                <a16:creationId xmlns:a16="http://schemas.microsoft.com/office/drawing/2014/main" id="{B548175C-37F3-45A8-975F-6042E21CAA81}"/>
               </a:ext>
             </a:extLst>
           </p:cNvPr>
@@ -7954,7 +7979,7 @@
           <p:cNvPr id="13" name="">
             <a:extLst xmlns:a="http://schemas.openxmlformats.org/drawingml/2006/main">
               <a:ext uri="{FF2B5EF4-FFF2-40B4-BE49-F238E27FC236}">
-                <a16:creationId xmlns:a16="http://schemas.microsoft.com/office/drawing/2014/main" id="{2B858369-000B-4773-A6B3-C8A0A2A4A4F6}"/>
+                <a16:creationId xmlns:a16="http://schemas.microsoft.com/office/drawing/2014/main" id="{127F72ED-5D60-4051-B6BD-E6A9B6269798}"/>
               </a:ext>
             </a:extLst>
           </p:cNvPr>
@@ -8011,7 +8036,7 @@
           <p:cNvPr id="14" name="">
             <a:extLst xmlns:a="http://schemas.openxmlformats.org/drawingml/2006/main">
               <a:ext uri="{FF2B5EF4-FFF2-40B4-BE49-F238E27FC236}">
-                <a16:creationId xmlns:a16="http://schemas.microsoft.com/office/drawing/2014/main" id="{1F322E95-3114-4F23-8240-7EA6B3A8484A}"/>
+                <a16:creationId xmlns:a16="http://schemas.microsoft.com/office/drawing/2014/main" id="{72B34DD7-B076-430D-809E-EA5B652A6846}"/>
               </a:ext>
             </a:extLst>
           </p:cNvPr>
@@ -8068,7 +8093,7 @@
           <p:cNvPr id="15" name="">
             <a:extLst xmlns:a="http://schemas.openxmlformats.org/drawingml/2006/main">
               <a:ext uri="{FF2B5EF4-FFF2-40B4-BE49-F238E27FC236}">
-                <a16:creationId xmlns:a16="http://schemas.microsoft.com/office/drawing/2014/main" id="{72CC1492-4825-4060-BB8F-D8915F88DAF9}"/>
+                <a16:creationId xmlns:a16="http://schemas.microsoft.com/office/drawing/2014/main" id="{2CE0CCA0-11DE-4D95-9E11-07EB73AF46BD}"/>
               </a:ext>
             </a:extLst>
           </p:cNvPr>
@@ -8098,7 +8123,7 @@
           <p:cNvPr id="16" name="">
             <a:extLst xmlns:a="http://schemas.openxmlformats.org/drawingml/2006/main">
               <a:ext uri="{FF2B5EF4-FFF2-40B4-BE49-F238E27FC236}">
-                <a16:creationId xmlns:a16="http://schemas.microsoft.com/office/drawing/2014/main" id="{FC166375-7742-4175-BE84-8C978B05DEC2}"/>
+                <a16:creationId xmlns:a16="http://schemas.microsoft.com/office/drawing/2014/main" id="{06C34197-8341-43FD-BC75-C527FB26E391}"/>
               </a:ext>
             </a:extLst>
           </p:cNvPr>
@@ -8155,7 +8180,7 @@
           <p:cNvPr id="17" name="">
             <a:extLst xmlns:a="http://schemas.openxmlformats.org/drawingml/2006/main">
               <a:ext uri="{FF2B5EF4-FFF2-40B4-BE49-F238E27FC236}">
-                <a16:creationId xmlns:a16="http://schemas.microsoft.com/office/drawing/2014/main" id="{564B1A87-2FB2-44A9-B451-31182645AEF9}"/>
+                <a16:creationId xmlns:a16="http://schemas.microsoft.com/office/drawing/2014/main" id="{AA32AE3C-D1C4-4823-816F-36ED93393CF8}"/>
               </a:ext>
             </a:extLst>
           </p:cNvPr>
@@ -8212,7 +8237,7 @@
           <p:cNvPr id="18" name="">
             <a:extLst xmlns:a="http://schemas.openxmlformats.org/drawingml/2006/main">
               <a:ext uri="{FF2B5EF4-FFF2-40B4-BE49-F238E27FC236}">
-                <a16:creationId xmlns:a16="http://schemas.microsoft.com/office/drawing/2014/main" id="{6A9D2970-EB08-4343-B3FE-F827C9BE70E0}"/>
+                <a16:creationId xmlns:a16="http://schemas.microsoft.com/office/drawing/2014/main" id="{64372FC3-786E-44E1-8A8A-784C50E9FD94}"/>
               </a:ext>
             </a:extLst>
           </p:cNvPr>
@@ -8242,7 +8267,7 @@
           <p:cNvPr id="19" name="">
             <a:extLst xmlns:a="http://schemas.openxmlformats.org/drawingml/2006/main">
               <a:ext uri="{FF2B5EF4-FFF2-40B4-BE49-F238E27FC236}">
-                <a16:creationId xmlns:a16="http://schemas.microsoft.com/office/drawing/2014/main" id="{7D44311A-B108-4549-8D4C-E8EC2596472E}"/>
+                <a16:creationId xmlns:a16="http://schemas.microsoft.com/office/drawing/2014/main" id="{CF134ABD-D46A-4497-A44D-ABC140862D25}"/>
               </a:ext>
             </a:extLst>
           </p:cNvPr>
@@ -8299,7 +8324,7 @@
           <p:cNvPr id="20" name="">
             <a:extLst xmlns:a="http://schemas.openxmlformats.org/drawingml/2006/main">
               <a:ext uri="{FF2B5EF4-FFF2-40B4-BE49-F238E27FC236}">
-                <a16:creationId xmlns:a16="http://schemas.microsoft.com/office/drawing/2014/main" id="{C11C5236-597C-49AC-BA9A-D422E7D2A606}"/>
+                <a16:creationId xmlns:a16="http://schemas.microsoft.com/office/drawing/2014/main" id="{60151F2F-1F4D-4919-A7D0-7859BD3C86F9}"/>
               </a:ext>
             </a:extLst>
           </p:cNvPr>
@@ -8330,7 +8355,7 @@
           <p:cNvPr id="21" name="">
             <a:extLst xmlns:a="http://schemas.openxmlformats.org/drawingml/2006/main">
               <a:ext uri="{FF2B5EF4-FFF2-40B4-BE49-F238E27FC236}">
-                <a16:creationId xmlns:a16="http://schemas.microsoft.com/office/drawing/2014/main" id="{DB7DE00A-10A2-4C45-8C2A-E9041F00937B}"/>
+                <a16:creationId xmlns:a16="http://schemas.microsoft.com/office/drawing/2014/main" id="{319E1B71-BEE9-41EF-A342-0CED9D0AC6AA}"/>
               </a:ext>
             </a:extLst>
           </p:cNvPr>
@@ -8361,7 +8386,7 @@
           <p:cNvPr id="22" name="">
             <a:extLst xmlns:a="http://schemas.openxmlformats.org/drawingml/2006/main">
               <a:ext uri="{FF2B5EF4-FFF2-40B4-BE49-F238E27FC236}">
-                <a16:creationId xmlns:a16="http://schemas.microsoft.com/office/drawing/2014/main" id="{4B903875-08EB-4B09-B382-1F27A7B0647F}"/>
+                <a16:creationId xmlns:a16="http://schemas.microsoft.com/office/drawing/2014/main" id="{70F4789F-043C-4068-94BD-FCB0470442B1}"/>
               </a:ext>
             </a:extLst>
           </p:cNvPr>
@@ -8392,7 +8417,7 @@
           <p:cNvPr id="23" name="">
             <a:extLst xmlns:a="http://schemas.openxmlformats.org/drawingml/2006/main">
               <a:ext uri="{FF2B5EF4-FFF2-40B4-BE49-F238E27FC236}">
-                <a16:creationId xmlns:a16="http://schemas.microsoft.com/office/drawing/2014/main" id="{47E25AD9-9E58-4EDF-8564-DE17D1A561A6}"/>
+                <a16:creationId xmlns:a16="http://schemas.microsoft.com/office/drawing/2014/main" id="{39738820-A55A-4CCE-8405-3E99AB6B2939}"/>
               </a:ext>
             </a:extLst>
           </p:cNvPr>
@@ -8421,7 +8446,7 @@
     </p:spTree>
     <p:extLst>
       <p:ext uri="{BB962C8B-B14F-4D97-AF65-F5344CB8AC3E}">
-        <p14:creationId xmlns:p14="http://schemas.microsoft.com/office/powerpoint/2010/main" val="1760983112"/>
+        <p14:creationId xmlns:p14="http://schemas.microsoft.com/office/powerpoint/2010/main" val="84391277"/>
       </p:ext>
     </p:extLst>
   </p:cSld>
@@ -8452,7 +8477,7 @@
           <p:cNvPr id="23" name="">
             <a:extLst xmlns:a="http://schemas.openxmlformats.org/drawingml/2006/main">
               <a:ext uri="{FF2B5EF4-FFF2-40B4-BE49-F238E27FC236}">
-                <a16:creationId xmlns:a16="http://schemas.microsoft.com/office/drawing/2014/main" id="{75899A8B-AA94-45C5-A80D-412EE71B628C}"/>
+                <a16:creationId xmlns:a16="http://schemas.microsoft.com/office/drawing/2014/main" id="{56B7458D-9744-4561-809C-48CCC4F2F5E3}"/>
               </a:ext>
             </a:extLst>
           </p:cNvPr>
@@ -8482,7 +8507,7 @@
           <p:cNvPr id="2" name="">
             <a:extLst xmlns:a="http://schemas.openxmlformats.org/drawingml/2006/main">
               <a:ext uri="{FF2B5EF4-FFF2-40B4-BE49-F238E27FC236}">
-                <a16:creationId xmlns:a16="http://schemas.microsoft.com/office/drawing/2014/main" id="{0F26E168-ADED-4E82-863E-6963A901E334}"/>
+                <a16:creationId xmlns:a16="http://schemas.microsoft.com/office/drawing/2014/main" id="{CAE73AA5-EA6C-4C7B-813F-76316C385743}"/>
               </a:ext>
             </a:extLst>
           </p:cNvPr>
@@ -8539,7 +8564,7 @@
           <p:cNvPr id="3" name="">
             <a:extLst xmlns:a="http://schemas.openxmlformats.org/drawingml/2006/main">
               <a:ext uri="{FF2B5EF4-FFF2-40B4-BE49-F238E27FC236}">
-                <a16:creationId xmlns:a16="http://schemas.microsoft.com/office/drawing/2014/main" id="{9FEBAA4F-FD48-45E9-9A60-9926549A1753}"/>
+                <a16:creationId xmlns:a16="http://schemas.microsoft.com/office/drawing/2014/main" id="{7EC50950-CBDF-40FC-A840-50DA5B10ABA5}"/>
               </a:ext>
             </a:extLst>
           </p:cNvPr>
@@ -8596,7 +8621,7 @@
           <p:cNvPr id="4" name="">
             <a:extLst xmlns:a="http://schemas.openxmlformats.org/drawingml/2006/main">
               <a:ext uri="{FF2B5EF4-FFF2-40B4-BE49-F238E27FC236}">
-                <a16:creationId xmlns:a16="http://schemas.microsoft.com/office/drawing/2014/main" id="{7B497CB5-14D2-4A4D-AE7F-BEFFCAAC3D22}"/>
+                <a16:creationId xmlns:a16="http://schemas.microsoft.com/office/drawing/2014/main" id="{86A50139-36BE-4B41-AE40-044CA9245052}"/>
               </a:ext>
             </a:extLst>
           </p:cNvPr>
@@ -8653,7 +8678,7 @@
           <p:cNvPr id="5" name="">
             <a:extLst xmlns:a="http://schemas.openxmlformats.org/drawingml/2006/main">
               <a:ext uri="{FF2B5EF4-FFF2-40B4-BE49-F238E27FC236}">
-                <a16:creationId xmlns:a16="http://schemas.microsoft.com/office/drawing/2014/main" id="{C775AC7D-B425-48DF-8452-D90A7A9C9D6C}"/>
+                <a16:creationId xmlns:a16="http://schemas.microsoft.com/office/drawing/2014/main" id="{28665BEC-DD92-4E5A-ABD8-4957E0B91B50}"/>
               </a:ext>
             </a:extLst>
           </p:cNvPr>
@@ -8710,7 +8735,7 @@
           <p:cNvPr id="6" name="">
             <a:extLst xmlns:a="http://schemas.openxmlformats.org/drawingml/2006/main">
               <a:ext uri="{FF2B5EF4-FFF2-40B4-BE49-F238E27FC236}">
-                <a16:creationId xmlns:a16="http://schemas.microsoft.com/office/drawing/2014/main" id="{BC816947-5E2A-414C-930B-C09BBC04A653}"/>
+                <a16:creationId xmlns:a16="http://schemas.microsoft.com/office/drawing/2014/main" id="{8ECECE6F-E649-4259-85C7-D7C3AA5C1653}"/>
               </a:ext>
             </a:extLst>
           </p:cNvPr>
@@ -8745,7 +8770,7 @@
           <p:cNvPr id="7" name="">
             <a:extLst xmlns:a="http://schemas.openxmlformats.org/drawingml/2006/main">
               <a:ext uri="{FF2B5EF4-FFF2-40B4-BE49-F238E27FC236}">
-                <a16:creationId xmlns:a16="http://schemas.microsoft.com/office/drawing/2014/main" id="{F8291E5A-7D4D-412B-BD07-ADB677DB87FF}"/>
+                <a16:creationId xmlns:a16="http://schemas.microsoft.com/office/drawing/2014/main" id="{6476D5D0-7B15-4920-989D-F699E588AE57}"/>
               </a:ext>
             </a:extLst>
           </p:cNvPr>
@@ -8775,7 +8800,7 @@
           <p:cNvPr id="8" name="">
             <a:extLst xmlns:a="http://schemas.openxmlformats.org/drawingml/2006/main">
               <a:ext uri="{FF2B5EF4-FFF2-40B4-BE49-F238E27FC236}">
-                <a16:creationId xmlns:a16="http://schemas.microsoft.com/office/drawing/2014/main" id="{01B71D70-AF25-4FDF-B5E3-7B176A08867B}"/>
+                <a16:creationId xmlns:a16="http://schemas.microsoft.com/office/drawing/2014/main" id="{B5523C19-896B-4E3C-98F7-78B682DAF1DD}"/>
               </a:ext>
             </a:extLst>
           </p:cNvPr>
@@ -8832,7 +8857,7 @@
           <p:cNvPr id="9" name="">
             <a:extLst xmlns:a="http://schemas.openxmlformats.org/drawingml/2006/main">
               <a:ext uri="{FF2B5EF4-FFF2-40B4-BE49-F238E27FC236}">
-                <a16:creationId xmlns:a16="http://schemas.microsoft.com/office/drawing/2014/main" id="{9644964D-E12F-4770-872C-2F8AB601B10A}"/>
+                <a16:creationId xmlns:a16="http://schemas.microsoft.com/office/drawing/2014/main" id="{650C134A-0F85-4E3E-BDB6-A60CBBE1A4CA}"/>
               </a:ext>
             </a:extLst>
           </p:cNvPr>
@@ -8889,7 +8914,7 @@
           <p:cNvPr id="10" name="">
             <a:extLst xmlns:a="http://schemas.openxmlformats.org/drawingml/2006/main">
               <a:ext uri="{FF2B5EF4-FFF2-40B4-BE49-F238E27FC236}">
-                <a16:creationId xmlns:a16="http://schemas.microsoft.com/office/drawing/2014/main" id="{EE6D0CBD-A150-40D8-8815-1C1A0896610B}"/>
+                <a16:creationId xmlns:a16="http://schemas.microsoft.com/office/drawing/2014/main" id="{7C1581C4-57B6-47AC-B46A-91E36502A590}"/>
               </a:ext>
             </a:extLst>
           </p:cNvPr>
@@ -8924,7 +8949,7 @@
           <p:cNvPr id="11" name="">
             <a:extLst xmlns:a="http://schemas.openxmlformats.org/drawingml/2006/main">
               <a:ext uri="{FF2B5EF4-FFF2-40B4-BE49-F238E27FC236}">
-                <a16:creationId xmlns:a16="http://schemas.microsoft.com/office/drawing/2014/main" id="{962CD33D-D5E5-4968-A71A-82F4BFE1F819}"/>
+                <a16:creationId xmlns:a16="http://schemas.microsoft.com/office/drawing/2014/main" id="{4BD8B7A2-939C-47ED-9771-8ABCC676D05A}"/>
               </a:ext>
             </a:extLst>
           </p:cNvPr>
@@ -8954,7 +8979,7 @@
           <p:cNvPr id="12" name="">
             <a:extLst xmlns:a="http://schemas.openxmlformats.org/drawingml/2006/main">
               <a:ext uri="{FF2B5EF4-FFF2-40B4-BE49-F238E27FC236}">
-                <a16:creationId xmlns:a16="http://schemas.microsoft.com/office/drawing/2014/main" id="{B642C837-35D2-45D8-959C-BF925241AA2B}"/>
+                <a16:creationId xmlns:a16="http://schemas.microsoft.com/office/drawing/2014/main" id="{8414922C-CEB1-474F-A88B-1F9ABF4810F9}"/>
               </a:ext>
             </a:extLst>
           </p:cNvPr>
@@ -9011,7 +9036,7 @@
           <p:cNvPr id="13" name="">
             <a:extLst xmlns:a="http://schemas.openxmlformats.org/drawingml/2006/main">
               <a:ext uri="{FF2B5EF4-FFF2-40B4-BE49-F238E27FC236}">
-                <a16:creationId xmlns:a16="http://schemas.microsoft.com/office/drawing/2014/main" id="{5118960A-ABB8-4B25-948B-61DBD0CB8A04}"/>
+                <a16:creationId xmlns:a16="http://schemas.microsoft.com/office/drawing/2014/main" id="{1851EF6F-D52B-477C-8C09-33C4208E4D38}"/>
               </a:ext>
             </a:extLst>
           </p:cNvPr>
@@ -9068,7 +9093,7 @@
           <p:cNvPr id="14" name="">
             <a:extLst xmlns:a="http://schemas.openxmlformats.org/drawingml/2006/main">
               <a:ext uri="{FF2B5EF4-FFF2-40B4-BE49-F238E27FC236}">
-                <a16:creationId xmlns:a16="http://schemas.microsoft.com/office/drawing/2014/main" id="{058F3A25-BC17-43AF-B7E4-4D3F25671E6C}"/>
+                <a16:creationId xmlns:a16="http://schemas.microsoft.com/office/drawing/2014/main" id="{79B346A8-26ED-4F05-BB82-8358BCA10332}"/>
               </a:ext>
             </a:extLst>
           </p:cNvPr>
@@ -9103,7 +9128,7 @@
           <p:cNvPr id="15" name="">
             <a:extLst xmlns:a="http://schemas.openxmlformats.org/drawingml/2006/main">
               <a:ext uri="{FF2B5EF4-FFF2-40B4-BE49-F238E27FC236}">
-                <a16:creationId xmlns:a16="http://schemas.microsoft.com/office/drawing/2014/main" id="{ABF4B214-E654-4C93-8EC2-A3D25AE844B5}"/>
+                <a16:creationId xmlns:a16="http://schemas.microsoft.com/office/drawing/2014/main" id="{E182A4EA-BC8E-4C32-B1BE-F64CB55B6B31}"/>
               </a:ext>
             </a:extLst>
           </p:cNvPr>
@@ -9133,7 +9158,7 @@
           <p:cNvPr id="16" name="">
             <a:extLst xmlns:a="http://schemas.openxmlformats.org/drawingml/2006/main">
               <a:ext uri="{FF2B5EF4-FFF2-40B4-BE49-F238E27FC236}">
-                <a16:creationId xmlns:a16="http://schemas.microsoft.com/office/drawing/2014/main" id="{48B8A2C2-49C4-4BDE-8C8E-BD018842DFC7}"/>
+                <a16:creationId xmlns:a16="http://schemas.microsoft.com/office/drawing/2014/main" id="{C88809B1-E1D0-4F15-8D99-056B19B8A214}"/>
               </a:ext>
             </a:extLst>
           </p:cNvPr>
@@ -9190,7 +9215,7 @@
           <p:cNvPr id="17" name="">
             <a:extLst xmlns:a="http://schemas.openxmlformats.org/drawingml/2006/main">
               <a:ext uri="{FF2B5EF4-FFF2-40B4-BE49-F238E27FC236}">
-                <a16:creationId xmlns:a16="http://schemas.microsoft.com/office/drawing/2014/main" id="{E4A1DD3C-3E24-40FC-895D-DDD350A3D413}"/>
+                <a16:creationId xmlns:a16="http://schemas.microsoft.com/office/drawing/2014/main" id="{B075F992-197D-4B2E-A1CE-B63D1A29082C}"/>
               </a:ext>
             </a:extLst>
           </p:cNvPr>
@@ -9247,7 +9272,7 @@
           <p:cNvPr id="18" name="">
             <a:extLst xmlns:a="http://schemas.openxmlformats.org/drawingml/2006/main">
               <a:ext uri="{FF2B5EF4-FFF2-40B4-BE49-F238E27FC236}">
-                <a16:creationId xmlns:a16="http://schemas.microsoft.com/office/drawing/2014/main" id="{35AF1F32-986D-4B1C-B3E2-D46EAD72C44C}"/>
+                <a16:creationId xmlns:a16="http://schemas.microsoft.com/office/drawing/2014/main" id="{FAC1386F-B690-4EBE-9E70-AB3F7D213CD2}"/>
               </a:ext>
             </a:extLst>
           </p:cNvPr>
@@ -9282,7 +9307,7 @@
           <p:cNvPr id="19" name="">
             <a:extLst xmlns:a="http://schemas.openxmlformats.org/drawingml/2006/main">
               <a:ext uri="{FF2B5EF4-FFF2-40B4-BE49-F238E27FC236}">
-                <a16:creationId xmlns:a16="http://schemas.microsoft.com/office/drawing/2014/main" id="{55DA0100-7BB9-4FE1-993A-7D01620C72FB}"/>
+                <a16:creationId xmlns:a16="http://schemas.microsoft.com/office/drawing/2014/main" id="{F76AA6CD-9972-49A8-87D2-9F04DAB74944}"/>
               </a:ext>
             </a:extLst>
           </p:cNvPr>
@@ -9312,7 +9337,7 @@
           <p:cNvPr id="20" name="">
             <a:extLst xmlns:a="http://schemas.openxmlformats.org/drawingml/2006/main">
               <a:ext uri="{FF2B5EF4-FFF2-40B4-BE49-F238E27FC236}">
-                <a16:creationId xmlns:a16="http://schemas.microsoft.com/office/drawing/2014/main" id="{44DB56F3-A71F-4A62-9A81-B02EE5ED6E76}"/>
+                <a16:creationId xmlns:a16="http://schemas.microsoft.com/office/drawing/2014/main" id="{1C77CE79-40F6-411A-9D64-5030B807AAEC}"/>
               </a:ext>
             </a:extLst>
           </p:cNvPr>
@@ -9369,7 +9394,7 @@
           <p:cNvPr id="21" name="">
             <a:extLst xmlns:a="http://schemas.openxmlformats.org/drawingml/2006/main">
               <a:ext uri="{FF2B5EF4-FFF2-40B4-BE49-F238E27FC236}">
-                <a16:creationId xmlns:a16="http://schemas.microsoft.com/office/drawing/2014/main" id="{DB9F54CA-765F-475E-9A37-C60777D94DB1}"/>
+                <a16:creationId xmlns:a16="http://schemas.microsoft.com/office/drawing/2014/main" id="{FCC61687-0F60-47C0-AD10-C6012D45E795}"/>
               </a:ext>
             </a:extLst>
           </p:cNvPr>
@@ -9426,7 +9451,7 @@
           <p:cNvPr id="22" name="">
             <a:extLst xmlns:a="http://schemas.openxmlformats.org/drawingml/2006/main">
               <a:ext uri="{FF2B5EF4-FFF2-40B4-BE49-F238E27FC236}">
-                <a16:creationId xmlns:a16="http://schemas.microsoft.com/office/drawing/2014/main" id="{7A305885-2C6B-4238-8494-07BF81C370ED}"/>
+                <a16:creationId xmlns:a16="http://schemas.microsoft.com/office/drawing/2014/main" id="{63D0B5AE-03EE-46CB-B65A-7C6B1A1F17A6}"/>
               </a:ext>
             </a:extLst>
           </p:cNvPr>
@@ -9481,7 +9506,7 @@
     </p:spTree>
     <p:extLst>
       <p:ext uri="{BB962C8B-B14F-4D97-AF65-F5344CB8AC3E}">
-        <p14:creationId xmlns:p14="http://schemas.microsoft.com/office/powerpoint/2010/main" val="435294066"/>
+        <p14:creationId xmlns:p14="http://schemas.microsoft.com/office/powerpoint/2010/main" val="1076639894"/>
       </p:ext>
     </p:extLst>
   </p:cSld>
@@ -9512,7 +9537,7 @@
           <p:cNvPr id="33" name="">
             <a:extLst xmlns:a="http://schemas.openxmlformats.org/drawingml/2006/main">
               <a:ext uri="{FF2B5EF4-FFF2-40B4-BE49-F238E27FC236}">
-                <a16:creationId xmlns:a16="http://schemas.microsoft.com/office/drawing/2014/main" id="{1B9F41A0-1199-4CC6-BB4E-2CDA22C245EB}"/>
+                <a16:creationId xmlns:a16="http://schemas.microsoft.com/office/drawing/2014/main" id="{C0B98F40-6531-429E-AAAD-5EF617C53014}"/>
               </a:ext>
             </a:extLst>
           </p:cNvPr>
@@ -9542,7 +9567,7 @@
           <p:cNvPr id="2" name="">
             <a:extLst xmlns:a="http://schemas.openxmlformats.org/drawingml/2006/main">
               <a:ext uri="{FF2B5EF4-FFF2-40B4-BE49-F238E27FC236}">
-                <a16:creationId xmlns:a16="http://schemas.microsoft.com/office/drawing/2014/main" id="{B1CE1A3B-7E5E-4E22-9131-C22E09A3097E}"/>
+                <a16:creationId xmlns:a16="http://schemas.microsoft.com/office/drawing/2014/main" id="{70D878F0-72B3-48E8-9E33-318D5AEE01EB}"/>
               </a:ext>
             </a:extLst>
           </p:cNvPr>
@@ -9599,7 +9624,7 @@
           <p:cNvPr id="3" name="">
             <a:extLst xmlns:a="http://schemas.openxmlformats.org/drawingml/2006/main">
               <a:ext uri="{FF2B5EF4-FFF2-40B4-BE49-F238E27FC236}">
-                <a16:creationId xmlns:a16="http://schemas.microsoft.com/office/drawing/2014/main" id="{B4DD2899-4353-42C7-A316-D1A4559FE426}"/>
+                <a16:creationId xmlns:a16="http://schemas.microsoft.com/office/drawing/2014/main" id="{3C52DDCC-DECC-4A27-A4B5-B432F1149938}"/>
               </a:ext>
             </a:extLst>
           </p:cNvPr>
@@ -9656,7 +9681,7 @@
           <p:cNvPr id="4" name="">
             <a:extLst xmlns:a="http://schemas.openxmlformats.org/drawingml/2006/main">
               <a:ext uri="{FF2B5EF4-FFF2-40B4-BE49-F238E27FC236}">
-                <a16:creationId xmlns:a16="http://schemas.microsoft.com/office/drawing/2014/main" id="{4015DFEC-064D-45A7-80E2-A224A2350E4F}"/>
+                <a16:creationId xmlns:a16="http://schemas.microsoft.com/office/drawing/2014/main" id="{539538DF-10C4-4461-B7F3-044A2C927F01}"/>
               </a:ext>
             </a:extLst>
           </p:cNvPr>
@@ -9713,7 +9738,7 @@
           <p:cNvPr id="5" name="">
             <a:extLst xmlns:a="http://schemas.openxmlformats.org/drawingml/2006/main">
               <a:ext uri="{FF2B5EF4-FFF2-40B4-BE49-F238E27FC236}">
-                <a16:creationId xmlns:a16="http://schemas.microsoft.com/office/drawing/2014/main" id="{69677194-B73E-4930-8221-FD8F1277CD3B}"/>
+                <a16:creationId xmlns:a16="http://schemas.microsoft.com/office/drawing/2014/main" id="{3DA5A63C-F316-4874-95AE-8C88AF8F7B34}"/>
               </a:ext>
             </a:extLst>
           </p:cNvPr>
@@ -9770,7 +9795,7 @@
           <p:cNvPr id="6" name="">
             <a:extLst xmlns:a="http://schemas.openxmlformats.org/drawingml/2006/main">
               <a:ext uri="{FF2B5EF4-FFF2-40B4-BE49-F238E27FC236}">
-                <a16:creationId xmlns:a16="http://schemas.microsoft.com/office/drawing/2014/main" id="{E64D1D62-6849-4153-917F-09BF7D12BFB9}"/>
+                <a16:creationId xmlns:a16="http://schemas.microsoft.com/office/drawing/2014/main" id="{F7590C78-0DE2-463E-9EFF-D28F636CE0D4}"/>
               </a:ext>
             </a:extLst>
           </p:cNvPr>
@@ -9800,7 +9825,7 @@
           <p:cNvPr id="7" name="">
             <a:extLst xmlns:a="http://schemas.openxmlformats.org/drawingml/2006/main">
               <a:ext uri="{FF2B5EF4-FFF2-40B4-BE49-F238E27FC236}">
-                <a16:creationId xmlns:a16="http://schemas.microsoft.com/office/drawing/2014/main" id="{4B79FE3A-067C-42CD-88F3-A688C04E6F3A}"/>
+                <a16:creationId xmlns:a16="http://schemas.microsoft.com/office/drawing/2014/main" id="{A0440247-70F1-44D6-853C-AFEFF54A2669}"/>
               </a:ext>
             </a:extLst>
           </p:cNvPr>
@@ -9857,7 +9882,7 @@
           <p:cNvPr id="8" name="">
             <a:extLst xmlns:a="http://schemas.openxmlformats.org/drawingml/2006/main">
               <a:ext uri="{FF2B5EF4-FFF2-40B4-BE49-F238E27FC236}">
-                <a16:creationId xmlns:a16="http://schemas.microsoft.com/office/drawing/2014/main" id="{95BDF4BA-E0B9-445C-A202-3B24CF84C094}"/>
+                <a16:creationId xmlns:a16="http://schemas.microsoft.com/office/drawing/2014/main" id="{625632F2-B6A6-485C-B88C-09AFBBC87320}"/>
               </a:ext>
             </a:extLst>
           </p:cNvPr>
@@ -9914,7 +9939,7 @@
           <p:cNvPr id="9" name="">
             <a:extLst xmlns:a="http://schemas.openxmlformats.org/drawingml/2006/main">
               <a:ext uri="{FF2B5EF4-FFF2-40B4-BE49-F238E27FC236}">
-                <a16:creationId xmlns:a16="http://schemas.microsoft.com/office/drawing/2014/main" id="{C1279941-6703-4F56-B4A0-49BBF2A33CB6}"/>
+                <a16:creationId xmlns:a16="http://schemas.microsoft.com/office/drawing/2014/main" id="{F4382EBE-F3B4-42B9-9DD8-B7F3083DF58F}"/>
               </a:ext>
             </a:extLst>
           </p:cNvPr>
@@ -9971,7 +9996,7 @@
           <p:cNvPr id="10" name="">
             <a:extLst xmlns:a="http://schemas.openxmlformats.org/drawingml/2006/main">
               <a:ext uri="{FF2B5EF4-FFF2-40B4-BE49-F238E27FC236}">
-                <a16:creationId xmlns:a16="http://schemas.microsoft.com/office/drawing/2014/main" id="{0249CC5F-4F2F-4E73-A916-6A711609B5EC}"/>
+                <a16:creationId xmlns:a16="http://schemas.microsoft.com/office/drawing/2014/main" id="{480EE6BA-74F1-4F74-B9DE-052F50C0FDAB}"/>
               </a:ext>
             </a:extLst>
           </p:cNvPr>
@@ -10002,7 +10027,7 @@
           <p:cNvPr id="11" name="">
             <a:extLst xmlns:a="http://schemas.openxmlformats.org/drawingml/2006/main">
               <a:ext uri="{FF2B5EF4-FFF2-40B4-BE49-F238E27FC236}">
-                <a16:creationId xmlns:a16="http://schemas.microsoft.com/office/drawing/2014/main" id="{184A14E8-8C2E-4F21-9A5E-BA3AA41C5127}"/>
+                <a16:creationId xmlns:a16="http://schemas.microsoft.com/office/drawing/2014/main" id="{0A8B32BE-6FFD-4E20-A920-272CF8157723}"/>
               </a:ext>
             </a:extLst>
           </p:cNvPr>
@@ -10032,7 +10057,7 @@
           <p:cNvPr id="12" name="">
             <a:extLst xmlns:a="http://schemas.openxmlformats.org/drawingml/2006/main">
               <a:ext uri="{FF2B5EF4-FFF2-40B4-BE49-F238E27FC236}">
-                <a16:creationId xmlns:a16="http://schemas.microsoft.com/office/drawing/2014/main" id="{C9904067-92C5-4C7A-9945-7322CE076EEE}"/>
+                <a16:creationId xmlns:a16="http://schemas.microsoft.com/office/drawing/2014/main" id="{F28383EB-C06F-423D-AF97-7DB607B4AA8A}"/>
               </a:ext>
             </a:extLst>
           </p:cNvPr>
@@ -10089,7 +10114,7 @@
           <p:cNvPr id="13" name="">
             <a:extLst xmlns:a="http://schemas.openxmlformats.org/drawingml/2006/main">
               <a:ext uri="{FF2B5EF4-FFF2-40B4-BE49-F238E27FC236}">
-                <a16:creationId xmlns:a16="http://schemas.microsoft.com/office/drawing/2014/main" id="{D80A0CEF-7688-4416-965B-4FD80B754C24}"/>
+                <a16:creationId xmlns:a16="http://schemas.microsoft.com/office/drawing/2014/main" id="{523727E7-91DE-4B4C-A88F-62838972D4E1}"/>
               </a:ext>
             </a:extLst>
           </p:cNvPr>
@@ -10146,7 +10171,7 @@
           <p:cNvPr id="14" name="">
             <a:extLst xmlns:a="http://schemas.openxmlformats.org/drawingml/2006/main">
               <a:ext uri="{FF2B5EF4-FFF2-40B4-BE49-F238E27FC236}">
-                <a16:creationId xmlns:a16="http://schemas.microsoft.com/office/drawing/2014/main" id="{0BAD1D9B-34A4-4E07-BA36-FFE4C3798010}"/>
+                <a16:creationId xmlns:a16="http://schemas.microsoft.com/office/drawing/2014/main" id="{A5BCBBA4-AF0D-4CD0-A7B5-910688F9EB3C}"/>
               </a:ext>
             </a:extLst>
           </p:cNvPr>
@@ -10203,7 +10228,7 @@
           <p:cNvPr id="15" name="">
             <a:extLst xmlns:a="http://schemas.openxmlformats.org/drawingml/2006/main">
               <a:ext uri="{FF2B5EF4-FFF2-40B4-BE49-F238E27FC236}">
-                <a16:creationId xmlns:a16="http://schemas.microsoft.com/office/drawing/2014/main" id="{C421724C-13DE-4808-B9F0-EF70E8EC595E}"/>
+                <a16:creationId xmlns:a16="http://schemas.microsoft.com/office/drawing/2014/main" id="{281C5579-D708-4B3F-A051-F6C486664B65}"/>
               </a:ext>
             </a:extLst>
           </p:cNvPr>
@@ -10234,7 +10259,7 @@
           <p:cNvPr id="16" name="">
             <a:extLst xmlns:a="http://schemas.openxmlformats.org/drawingml/2006/main">
               <a:ext uri="{FF2B5EF4-FFF2-40B4-BE49-F238E27FC236}">
-                <a16:creationId xmlns:a16="http://schemas.microsoft.com/office/drawing/2014/main" id="{CA21A2CB-1299-482C-B997-CFB60AEFDBD0}"/>
+                <a16:creationId xmlns:a16="http://schemas.microsoft.com/office/drawing/2014/main" id="{DD518311-903B-45AB-86E1-4EA66E2089B8}"/>
               </a:ext>
             </a:extLst>
           </p:cNvPr>
@@ -10264,7 +10289,7 @@
           <p:cNvPr id="17" name="">
             <a:extLst xmlns:a="http://schemas.openxmlformats.org/drawingml/2006/main">
               <a:ext uri="{FF2B5EF4-FFF2-40B4-BE49-F238E27FC236}">
-                <a16:creationId xmlns:a16="http://schemas.microsoft.com/office/drawing/2014/main" id="{DB0E53DD-8033-437A-8E24-D986BA250192}"/>
+                <a16:creationId xmlns:a16="http://schemas.microsoft.com/office/drawing/2014/main" id="{FAB2D596-FB18-4E63-A0E7-13D4AF40D46F}"/>
               </a:ext>
             </a:extLst>
           </p:cNvPr>
@@ -10321,7 +10346,7 @@
           <p:cNvPr id="18" name="">
             <a:extLst xmlns:a="http://schemas.openxmlformats.org/drawingml/2006/main">
               <a:ext uri="{FF2B5EF4-FFF2-40B4-BE49-F238E27FC236}">
-                <a16:creationId xmlns:a16="http://schemas.microsoft.com/office/drawing/2014/main" id="{12476E78-F1F4-4B2B-8E2A-C15AC0162305}"/>
+                <a16:creationId xmlns:a16="http://schemas.microsoft.com/office/drawing/2014/main" id="{5BA79CFD-2BD4-4C41-9A29-703C94E17A1E}"/>
               </a:ext>
             </a:extLst>
           </p:cNvPr>
@@ -10378,7 +10403,7 @@
           <p:cNvPr id="19" name="">
             <a:extLst xmlns:a="http://schemas.openxmlformats.org/drawingml/2006/main">
               <a:ext uri="{FF2B5EF4-FFF2-40B4-BE49-F238E27FC236}">
-                <a16:creationId xmlns:a16="http://schemas.microsoft.com/office/drawing/2014/main" id="{924BF639-D73D-4B80-A001-A2CB7C8D562C}"/>
+                <a16:creationId xmlns:a16="http://schemas.microsoft.com/office/drawing/2014/main" id="{FFB72DEF-7DAB-432A-AD91-31D7780BC1D9}"/>
               </a:ext>
             </a:extLst>
           </p:cNvPr>
@@ -10435,7 +10460,7 @@
           <p:cNvPr id="20" name="">
             <a:extLst xmlns:a="http://schemas.openxmlformats.org/drawingml/2006/main">
               <a:ext uri="{FF2B5EF4-FFF2-40B4-BE49-F238E27FC236}">
-                <a16:creationId xmlns:a16="http://schemas.microsoft.com/office/drawing/2014/main" id="{D533FAE0-DD63-4D36-88CB-3E9A0130A03A}"/>
+                <a16:creationId xmlns:a16="http://schemas.microsoft.com/office/drawing/2014/main" id="{E9A9B767-3094-492E-9C4B-2829A6CDE3C3}"/>
               </a:ext>
             </a:extLst>
           </p:cNvPr>
@@ -10466,7 +10491,7 @@
           <p:cNvPr id="21" name="">
             <a:extLst xmlns:a="http://schemas.openxmlformats.org/drawingml/2006/main">
               <a:ext uri="{FF2B5EF4-FFF2-40B4-BE49-F238E27FC236}">
-                <a16:creationId xmlns:a16="http://schemas.microsoft.com/office/drawing/2014/main" id="{96B76BF8-DF11-4C38-9E60-2018BDB716C5}"/>
+                <a16:creationId xmlns:a16="http://schemas.microsoft.com/office/drawing/2014/main" id="{2365403C-5429-43FC-A81B-811893B87846}"/>
               </a:ext>
             </a:extLst>
           </p:cNvPr>
@@ -10496,7 +10521,7 @@
           <p:cNvPr id="22" name="">
             <a:extLst xmlns:a="http://schemas.openxmlformats.org/drawingml/2006/main">
               <a:ext uri="{FF2B5EF4-FFF2-40B4-BE49-F238E27FC236}">
-                <a16:creationId xmlns:a16="http://schemas.microsoft.com/office/drawing/2014/main" id="{5D959865-7C30-4C9E-B9E8-CC1D68C33941}"/>
+                <a16:creationId xmlns:a16="http://schemas.microsoft.com/office/drawing/2014/main" id="{521275DF-E051-4048-9AE7-E6F8FAFEB8BF}"/>
               </a:ext>
             </a:extLst>
           </p:cNvPr>
@@ -10553,7 +10578,7 @@
           <p:cNvPr id="23" name="">
             <a:extLst xmlns:a="http://schemas.openxmlformats.org/drawingml/2006/main">
               <a:ext uri="{FF2B5EF4-FFF2-40B4-BE49-F238E27FC236}">
-                <a16:creationId xmlns:a16="http://schemas.microsoft.com/office/drawing/2014/main" id="{C12C0695-A196-4A4C-85DF-0D2FAF0A2D21}"/>
+                <a16:creationId xmlns:a16="http://schemas.microsoft.com/office/drawing/2014/main" id="{E33B8046-13FB-4965-87C3-CD04CD44A061}"/>
               </a:ext>
             </a:extLst>
           </p:cNvPr>
@@ -10610,7 +10635,7 @@
           <p:cNvPr id="24" name="">
             <a:extLst xmlns:a="http://schemas.openxmlformats.org/drawingml/2006/main">
               <a:ext uri="{FF2B5EF4-FFF2-40B4-BE49-F238E27FC236}">
-                <a16:creationId xmlns:a16="http://schemas.microsoft.com/office/drawing/2014/main" id="{57573545-F1BA-4B37-8F3B-9075E9910294}"/>
+                <a16:creationId xmlns:a16="http://schemas.microsoft.com/office/drawing/2014/main" id="{35C368D1-C3B9-4DA1-B4E9-6E6F0E9ABB58}"/>
               </a:ext>
             </a:extLst>
           </p:cNvPr>
@@ -10667,7 +10692,7 @@
           <p:cNvPr id="25" name="">
             <a:extLst xmlns:a="http://schemas.openxmlformats.org/drawingml/2006/main">
               <a:ext uri="{FF2B5EF4-FFF2-40B4-BE49-F238E27FC236}">
-                <a16:creationId xmlns:a16="http://schemas.microsoft.com/office/drawing/2014/main" id="{683F25C1-C9A7-477C-A21B-D917EF462F4F}"/>
+                <a16:creationId xmlns:a16="http://schemas.microsoft.com/office/drawing/2014/main" id="{FC3C273B-940D-4240-A77B-ABBC796589D7}"/>
               </a:ext>
             </a:extLst>
           </p:cNvPr>
@@ -10698,7 +10723,7 @@
           <p:cNvPr id="26" name="">
             <a:extLst xmlns:a="http://schemas.openxmlformats.org/drawingml/2006/main">
               <a:ext uri="{FF2B5EF4-FFF2-40B4-BE49-F238E27FC236}">
-                <a16:creationId xmlns:a16="http://schemas.microsoft.com/office/drawing/2014/main" id="{61683525-D5B1-4EA5-979E-F0FB2A1A1FF5}"/>
+                <a16:creationId xmlns:a16="http://schemas.microsoft.com/office/drawing/2014/main" id="{2F19AD0C-B8B3-418F-A823-4EFCF28FF005}"/>
               </a:ext>
             </a:extLst>
           </p:cNvPr>
@@ -10728,7 +10753,7 @@
           <p:cNvPr id="27" name="">
             <a:extLst xmlns:a="http://schemas.openxmlformats.org/drawingml/2006/main">
               <a:ext uri="{FF2B5EF4-FFF2-40B4-BE49-F238E27FC236}">
-                <a16:creationId xmlns:a16="http://schemas.microsoft.com/office/drawing/2014/main" id="{E2CE8CD4-1B2B-4E66-8C1A-3054DDDD35BA}"/>
+                <a16:creationId xmlns:a16="http://schemas.microsoft.com/office/drawing/2014/main" id="{0318CA85-73D5-44F1-BFAB-FC21F1D82944}"/>
               </a:ext>
             </a:extLst>
           </p:cNvPr>
@@ -10785,7 +10810,7 @@
           <p:cNvPr id="28" name="">
             <a:extLst xmlns:a="http://schemas.openxmlformats.org/drawingml/2006/main">
               <a:ext uri="{FF2B5EF4-FFF2-40B4-BE49-F238E27FC236}">
-                <a16:creationId xmlns:a16="http://schemas.microsoft.com/office/drawing/2014/main" id="{2484AA7A-74D9-4BD8-864C-5FE8F6EC0E43}"/>
+                <a16:creationId xmlns:a16="http://schemas.microsoft.com/office/drawing/2014/main" id="{AE30C56C-751E-4A63-97A6-677A5975AF7F}"/>
               </a:ext>
             </a:extLst>
           </p:cNvPr>
@@ -10842,7 +10867,7 @@
           <p:cNvPr id="29" name="">
             <a:extLst xmlns:a="http://schemas.openxmlformats.org/drawingml/2006/main">
               <a:ext uri="{FF2B5EF4-FFF2-40B4-BE49-F238E27FC236}">
-                <a16:creationId xmlns:a16="http://schemas.microsoft.com/office/drawing/2014/main" id="{17D763F4-D98C-43C9-969D-B6C05BDE9258}"/>
+                <a16:creationId xmlns:a16="http://schemas.microsoft.com/office/drawing/2014/main" id="{FD8AE4E0-951E-4F02-8C14-B26D4250B33A}"/>
               </a:ext>
             </a:extLst>
           </p:cNvPr>
@@ -10899,7 +10924,7 @@
           <p:cNvPr id="30" name="">
             <a:extLst xmlns:a="http://schemas.openxmlformats.org/drawingml/2006/main">
               <a:ext uri="{FF2B5EF4-FFF2-40B4-BE49-F238E27FC236}">
-                <a16:creationId xmlns:a16="http://schemas.microsoft.com/office/drawing/2014/main" id="{2B90C12F-13E3-4111-B0A6-8B8093A77548}"/>
+                <a16:creationId xmlns:a16="http://schemas.microsoft.com/office/drawing/2014/main" id="{B76101BD-5F1B-472D-A95C-D41D96D30AC8}"/>
               </a:ext>
             </a:extLst>
           </p:cNvPr>
@@ -10934,7 +10959,7 @@
           <p:cNvPr id="31" name="">
             <a:extLst xmlns:a="http://schemas.openxmlformats.org/drawingml/2006/main">
               <a:ext uri="{FF2B5EF4-FFF2-40B4-BE49-F238E27FC236}">
-                <a16:creationId xmlns:a16="http://schemas.microsoft.com/office/drawing/2014/main" id="{5C71685E-70B2-413E-80E5-CE1C16E4F029}"/>
+                <a16:creationId xmlns:a16="http://schemas.microsoft.com/office/drawing/2014/main" id="{971BC9FA-E101-4D1C-91E6-963531F9314D}"/>
               </a:ext>
             </a:extLst>
           </p:cNvPr>
@@ -10991,7 +11016,7 @@
           <p:cNvPr id="32" name="">
             <a:extLst xmlns:a="http://schemas.openxmlformats.org/drawingml/2006/main">
               <a:ext uri="{FF2B5EF4-FFF2-40B4-BE49-F238E27FC236}">
-                <a16:creationId xmlns:a16="http://schemas.microsoft.com/office/drawing/2014/main" id="{7C73D08C-7517-47D4-8E30-F435D100AB4B}"/>
+                <a16:creationId xmlns:a16="http://schemas.microsoft.com/office/drawing/2014/main" id="{5E3079AA-7861-41E3-8917-B154C2C65F28}"/>
               </a:ext>
             </a:extLst>
           </p:cNvPr>
@@ -11046,7 +11071,7 @@
     </p:spTree>
     <p:extLst>
       <p:ext uri="{BB962C8B-B14F-4D97-AF65-F5344CB8AC3E}">
-        <p14:creationId xmlns:p14="http://schemas.microsoft.com/office/powerpoint/2010/main" val="2110173464"/>
+        <p14:creationId xmlns:p14="http://schemas.microsoft.com/office/powerpoint/2010/main" val="1911986792"/>
       </p:ext>
     </p:extLst>
   </p:cSld>
@@ -11077,7 +11102,7 @@
           <p:cNvPr id="26" name="">
             <a:extLst xmlns:a="http://schemas.openxmlformats.org/drawingml/2006/main">
               <a:ext uri="{FF2B5EF4-FFF2-40B4-BE49-F238E27FC236}">
-                <a16:creationId xmlns:a16="http://schemas.microsoft.com/office/drawing/2014/main" id="{11CEC775-C12F-4280-B779-AEDF8AE639F0}"/>
+                <a16:creationId xmlns:a16="http://schemas.microsoft.com/office/drawing/2014/main" id="{4C300EFA-20C5-41F3-B80F-D0489D02544F}"/>
               </a:ext>
             </a:extLst>
           </p:cNvPr>
@@ -11107,7 +11132,7 @@
           <p:cNvPr id="2" name="">
             <a:extLst xmlns:a="http://schemas.openxmlformats.org/drawingml/2006/main">
               <a:ext uri="{FF2B5EF4-FFF2-40B4-BE49-F238E27FC236}">
-                <a16:creationId xmlns:a16="http://schemas.microsoft.com/office/drawing/2014/main" id="{85414FBF-0B5F-4D7E-97C9-4C9D5BE5F8C8}"/>
+                <a16:creationId xmlns:a16="http://schemas.microsoft.com/office/drawing/2014/main" id="{747288BC-C269-4C97-B68E-D9A92AB6E8AB}"/>
               </a:ext>
             </a:extLst>
           </p:cNvPr>
@@ -11164,7 +11189,7 @@
           <p:cNvPr id="3" name="">
             <a:extLst xmlns:a="http://schemas.openxmlformats.org/drawingml/2006/main">
               <a:ext uri="{FF2B5EF4-FFF2-40B4-BE49-F238E27FC236}">
-                <a16:creationId xmlns:a16="http://schemas.microsoft.com/office/drawing/2014/main" id="{416F60E9-6108-4FEA-AA6C-5DF72DE1EFFC}"/>
+                <a16:creationId xmlns:a16="http://schemas.microsoft.com/office/drawing/2014/main" id="{066FE5CD-2050-425A-862A-D59F157EECD8}"/>
               </a:ext>
             </a:extLst>
           </p:cNvPr>
@@ -11221,7 +11246,7 @@
           <p:cNvPr id="4" name="">
             <a:extLst xmlns:a="http://schemas.openxmlformats.org/drawingml/2006/main">
               <a:ext uri="{FF2B5EF4-FFF2-40B4-BE49-F238E27FC236}">
-                <a16:creationId xmlns:a16="http://schemas.microsoft.com/office/drawing/2014/main" id="{4274B275-5490-4CF6-8903-81BD6F9CD21D}"/>
+                <a16:creationId xmlns:a16="http://schemas.microsoft.com/office/drawing/2014/main" id="{4C77F199-54F4-4495-9020-0FA71C645BA3}"/>
               </a:ext>
             </a:extLst>
           </p:cNvPr>
@@ -11278,7 +11303,7 @@
           <p:cNvPr id="5" name="">
             <a:extLst xmlns:a="http://schemas.openxmlformats.org/drawingml/2006/main">
               <a:ext uri="{FF2B5EF4-FFF2-40B4-BE49-F238E27FC236}">
-                <a16:creationId xmlns:a16="http://schemas.microsoft.com/office/drawing/2014/main" id="{F243FF4E-37C8-4F1A-82EA-BBD04A08299F}"/>
+                <a16:creationId xmlns:a16="http://schemas.microsoft.com/office/drawing/2014/main" id="{CF43164F-D043-40BF-BC70-16123F03A2F5}"/>
               </a:ext>
             </a:extLst>
           </p:cNvPr>
@@ -11335,7 +11360,7 @@
           <p:cNvPr id="6" name="">
             <a:extLst xmlns:a="http://schemas.openxmlformats.org/drawingml/2006/main">
               <a:ext uri="{FF2B5EF4-FFF2-40B4-BE49-F238E27FC236}">
-                <a16:creationId xmlns:a16="http://schemas.microsoft.com/office/drawing/2014/main" id="{BF7F6531-0754-46E6-B871-81CF2FE51DF1}"/>
+                <a16:creationId xmlns:a16="http://schemas.microsoft.com/office/drawing/2014/main" id="{E795BC62-CFDA-4945-A205-6D20F10790C1}"/>
               </a:ext>
             </a:extLst>
           </p:cNvPr>
@@ -11370,7 +11395,7 @@
           <p:cNvPr id="7" name="">
             <a:extLst xmlns:a="http://schemas.openxmlformats.org/drawingml/2006/main">
               <a:ext uri="{FF2B5EF4-FFF2-40B4-BE49-F238E27FC236}">
-                <a16:creationId xmlns:a16="http://schemas.microsoft.com/office/drawing/2014/main" id="{2E6CCE95-132A-4A43-88CF-4DBE195DEF42}"/>
+                <a16:creationId xmlns:a16="http://schemas.microsoft.com/office/drawing/2014/main" id="{21FBE094-3A9A-4128-B839-D3A91747F825}"/>
               </a:ext>
             </a:extLst>
           </p:cNvPr>
@@ -11427,7 +11452,7 @@
           <p:cNvPr id="8" name="">
             <a:extLst xmlns:a="http://schemas.openxmlformats.org/drawingml/2006/main">
               <a:ext uri="{FF2B5EF4-FFF2-40B4-BE49-F238E27FC236}">
-                <a16:creationId xmlns:a16="http://schemas.microsoft.com/office/drawing/2014/main" id="{5B0D6280-4EDB-4F97-9A93-D034F7C5C578}"/>
+                <a16:creationId xmlns:a16="http://schemas.microsoft.com/office/drawing/2014/main" id="{48E38B0C-D088-46A0-8D49-4B0E2E0180B0}"/>
               </a:ext>
             </a:extLst>
           </p:cNvPr>
@@ -11484,7 +11509,7 @@
           <p:cNvPr id="9" name="">
             <a:extLst xmlns:a="http://schemas.openxmlformats.org/drawingml/2006/main">
               <a:ext uri="{FF2B5EF4-FFF2-40B4-BE49-F238E27FC236}">
-                <a16:creationId xmlns:a16="http://schemas.microsoft.com/office/drawing/2014/main" id="{A1849B8C-E3E3-4E75-9E20-BDA850F7EF2D}"/>
+                <a16:creationId xmlns:a16="http://schemas.microsoft.com/office/drawing/2014/main" id="{D3E3A7AE-CA08-4140-9562-27E631821918}"/>
               </a:ext>
             </a:extLst>
           </p:cNvPr>
@@ -11541,7 +11566,7 @@
           <p:cNvPr id="10" name="">
             <a:extLst xmlns:a="http://schemas.openxmlformats.org/drawingml/2006/main">
               <a:ext uri="{FF2B5EF4-FFF2-40B4-BE49-F238E27FC236}">
-                <a16:creationId xmlns:a16="http://schemas.microsoft.com/office/drawing/2014/main" id="{291B5006-D00F-47FE-B670-43D0244E4D2C}"/>
+                <a16:creationId xmlns:a16="http://schemas.microsoft.com/office/drawing/2014/main" id="{94CC4949-045B-493E-9DEA-13A24EE000B4}"/>
               </a:ext>
             </a:extLst>
           </p:cNvPr>
@@ -11598,7 +11623,7 @@
           <p:cNvPr id="11" name="">
             <a:extLst xmlns:a="http://schemas.openxmlformats.org/drawingml/2006/main">
               <a:ext uri="{FF2B5EF4-FFF2-40B4-BE49-F238E27FC236}">
-                <a16:creationId xmlns:a16="http://schemas.microsoft.com/office/drawing/2014/main" id="{1A5DF8EA-6ADC-4AE0-B4A2-91014A306888}"/>
+                <a16:creationId xmlns:a16="http://schemas.microsoft.com/office/drawing/2014/main" id="{3FA83F55-2872-4650-AA36-F2092AC7A953}"/>
               </a:ext>
             </a:extLst>
           </p:cNvPr>
@@ -11655,7 +11680,7 @@
           <p:cNvPr id="12" name="">
             <a:extLst xmlns:a="http://schemas.openxmlformats.org/drawingml/2006/main">
               <a:ext uri="{FF2B5EF4-FFF2-40B4-BE49-F238E27FC236}">
-                <a16:creationId xmlns:a16="http://schemas.microsoft.com/office/drawing/2014/main" id="{8CF974BB-DCBA-4C15-86EB-59BA51AEE6D0}"/>
+                <a16:creationId xmlns:a16="http://schemas.microsoft.com/office/drawing/2014/main" id="{DD7FCA71-66A1-4DDF-91B2-A1409D13FA2B}"/>
               </a:ext>
             </a:extLst>
           </p:cNvPr>
@@ -11712,7 +11737,7 @@
           <p:cNvPr id="13" name="">
             <a:extLst xmlns:a="http://schemas.openxmlformats.org/drawingml/2006/main">
               <a:ext uri="{FF2B5EF4-FFF2-40B4-BE49-F238E27FC236}">
-                <a16:creationId xmlns:a16="http://schemas.microsoft.com/office/drawing/2014/main" id="{63462CBC-B570-4A1E-AEAA-09A996409701}"/>
+                <a16:creationId xmlns:a16="http://schemas.microsoft.com/office/drawing/2014/main" id="{834ADF26-29BD-4E4D-B4AE-704996EE93BF}"/>
               </a:ext>
             </a:extLst>
           </p:cNvPr>
@@ -11769,7 +11794,7 @@
           <p:cNvPr id="14" name="">
             <a:extLst xmlns:a="http://schemas.openxmlformats.org/drawingml/2006/main">
               <a:ext uri="{FF2B5EF4-FFF2-40B4-BE49-F238E27FC236}">
-                <a16:creationId xmlns:a16="http://schemas.microsoft.com/office/drawing/2014/main" id="{A75D56D3-F541-4CB9-BC2F-5283FB799CE1}"/>
+                <a16:creationId xmlns:a16="http://schemas.microsoft.com/office/drawing/2014/main" id="{EB112423-CDA2-4FA1-B06D-7FAE9BDA0959}"/>
               </a:ext>
             </a:extLst>
           </p:cNvPr>
@@ -11826,7 +11851,7 @@
           <p:cNvPr id="15" name="">
             <a:extLst xmlns:a="http://schemas.openxmlformats.org/drawingml/2006/main">
               <a:ext uri="{FF2B5EF4-FFF2-40B4-BE49-F238E27FC236}">
-                <a16:creationId xmlns:a16="http://schemas.microsoft.com/office/drawing/2014/main" id="{FBF03190-E427-4A6D-83EE-B8C705444769}"/>
+                <a16:creationId xmlns:a16="http://schemas.microsoft.com/office/drawing/2014/main" id="{B5A36283-7AC6-4FCF-9E40-0DD2802A4EA6}"/>
               </a:ext>
             </a:extLst>
           </p:cNvPr>
@@ -11883,7 +11908,7 @@
           <p:cNvPr id="16" name="">
             <a:extLst xmlns:a="http://schemas.openxmlformats.org/drawingml/2006/main">
               <a:ext uri="{FF2B5EF4-FFF2-40B4-BE49-F238E27FC236}">
-                <a16:creationId xmlns:a16="http://schemas.microsoft.com/office/drawing/2014/main" id="{5A6B61F8-464B-46D5-BE3F-F255C448ACC1}"/>
+                <a16:creationId xmlns:a16="http://schemas.microsoft.com/office/drawing/2014/main" id="{A2754403-6599-4E8B-B478-74BEF6D262E2}"/>
               </a:ext>
             </a:extLst>
           </p:cNvPr>
@@ -11918,7 +11943,7 @@
           <p:cNvPr id="17" name="">
             <a:extLst xmlns:a="http://schemas.openxmlformats.org/drawingml/2006/main">
               <a:ext uri="{FF2B5EF4-FFF2-40B4-BE49-F238E27FC236}">
-                <a16:creationId xmlns:a16="http://schemas.microsoft.com/office/drawing/2014/main" id="{A83C8880-1703-4604-897D-9083282AAEDC}"/>
+                <a16:creationId xmlns:a16="http://schemas.microsoft.com/office/drawing/2014/main" id="{D7E209C8-2FCE-4233-AAE7-F0D8720B350F}"/>
               </a:ext>
             </a:extLst>
           </p:cNvPr>
@@ -11975,7 +12000,7 @@
           <p:cNvPr id="18" name="">
             <a:extLst xmlns:a="http://schemas.openxmlformats.org/drawingml/2006/main">
               <a:ext uri="{FF2B5EF4-FFF2-40B4-BE49-F238E27FC236}">
-                <a16:creationId xmlns:a16="http://schemas.microsoft.com/office/drawing/2014/main" id="{298F80C8-DB79-4539-943E-F0DED9E623E6}"/>
+                <a16:creationId xmlns:a16="http://schemas.microsoft.com/office/drawing/2014/main" id="{482E4545-2254-4CE7-95F5-12B4D655B03A}"/>
               </a:ext>
             </a:extLst>
           </p:cNvPr>
@@ -12032,7 +12057,7 @@
           <p:cNvPr id="19" name="">
             <a:extLst xmlns:a="http://schemas.openxmlformats.org/drawingml/2006/main">
               <a:ext uri="{FF2B5EF4-FFF2-40B4-BE49-F238E27FC236}">
-                <a16:creationId xmlns:a16="http://schemas.microsoft.com/office/drawing/2014/main" id="{DFDF8AF2-CF9D-4550-9A25-6A830E3D1CE1}"/>
+                <a16:creationId xmlns:a16="http://schemas.microsoft.com/office/drawing/2014/main" id="{901A87A9-6FF8-4622-964A-EA1B57BD8107}"/>
               </a:ext>
             </a:extLst>
           </p:cNvPr>
@@ -12089,7 +12114,7 @@
           <p:cNvPr id="20" name="">
             <a:extLst xmlns:a="http://schemas.openxmlformats.org/drawingml/2006/main">
               <a:ext uri="{FF2B5EF4-FFF2-40B4-BE49-F238E27FC236}">
-                <a16:creationId xmlns:a16="http://schemas.microsoft.com/office/drawing/2014/main" id="{2D25EB12-B78E-4BB4-ADD3-C9BC7AA3A65C}"/>
+                <a16:creationId xmlns:a16="http://schemas.microsoft.com/office/drawing/2014/main" id="{78F2157D-C6B8-4CED-916F-E85D6087C18E}"/>
               </a:ext>
             </a:extLst>
           </p:cNvPr>
@@ -12146,7 +12171,7 @@
           <p:cNvPr id="21" name="">
             <a:extLst xmlns:a="http://schemas.openxmlformats.org/drawingml/2006/main">
               <a:ext uri="{FF2B5EF4-FFF2-40B4-BE49-F238E27FC236}">
-                <a16:creationId xmlns:a16="http://schemas.microsoft.com/office/drawing/2014/main" id="{70A73929-8504-47D2-81B6-294552A727EB}"/>
+                <a16:creationId xmlns:a16="http://schemas.microsoft.com/office/drawing/2014/main" id="{D6AE9482-0D29-4725-84D0-FE77BC7F3FDE}"/>
               </a:ext>
             </a:extLst>
           </p:cNvPr>
@@ -12203,7 +12228,7 @@
           <p:cNvPr id="22" name="">
             <a:extLst xmlns:a="http://schemas.openxmlformats.org/drawingml/2006/main">
               <a:ext uri="{FF2B5EF4-FFF2-40B4-BE49-F238E27FC236}">
-                <a16:creationId xmlns:a16="http://schemas.microsoft.com/office/drawing/2014/main" id="{A62C4D90-18E5-496A-9277-C8EF8F2B9125}"/>
+                <a16:creationId xmlns:a16="http://schemas.microsoft.com/office/drawing/2014/main" id="{7A4F9ACE-AB8F-4DCA-A89E-BAA9C20F7669}"/>
               </a:ext>
             </a:extLst>
           </p:cNvPr>
@@ -12260,7 +12285,7 @@
           <p:cNvPr id="23" name="">
             <a:extLst xmlns:a="http://schemas.openxmlformats.org/drawingml/2006/main">
               <a:ext uri="{FF2B5EF4-FFF2-40B4-BE49-F238E27FC236}">
-                <a16:creationId xmlns:a16="http://schemas.microsoft.com/office/drawing/2014/main" id="{7A9E8E81-D796-4542-A249-28389F39E886}"/>
+                <a16:creationId xmlns:a16="http://schemas.microsoft.com/office/drawing/2014/main" id="{BE8B8830-7617-4905-85B9-D0B1EA8D4A26}"/>
               </a:ext>
             </a:extLst>
           </p:cNvPr>
@@ -12317,7 +12342,7 @@
           <p:cNvPr id="24" name="">
             <a:extLst xmlns:a="http://schemas.openxmlformats.org/drawingml/2006/main">
               <a:ext uri="{FF2B5EF4-FFF2-40B4-BE49-F238E27FC236}">
-                <a16:creationId xmlns:a16="http://schemas.microsoft.com/office/drawing/2014/main" id="{7DE44252-51F8-4B8A-B0A1-C766F6DEB362}"/>
+                <a16:creationId xmlns:a16="http://schemas.microsoft.com/office/drawing/2014/main" id="{FDDA7D16-89EA-4733-9E62-EF6BA1AEFA9B}"/>
               </a:ext>
             </a:extLst>
           </p:cNvPr>
@@ -12374,7 +12399,7 @@
           <p:cNvPr id="25" name="">
             <a:extLst xmlns:a="http://schemas.openxmlformats.org/drawingml/2006/main">
               <a:ext uri="{FF2B5EF4-FFF2-40B4-BE49-F238E27FC236}">
-                <a16:creationId xmlns:a16="http://schemas.microsoft.com/office/drawing/2014/main" id="{9C0E9A86-AEE2-4230-BE63-09C46DEA5B2C}"/>
+                <a16:creationId xmlns:a16="http://schemas.microsoft.com/office/drawing/2014/main" id="{23E22510-E3A5-490D-8397-075C17044E2A}"/>
               </a:ext>
             </a:extLst>
           </p:cNvPr>
@@ -12429,7 +12454,7 @@
     </p:spTree>
     <p:extLst>
       <p:ext uri="{BB962C8B-B14F-4D97-AF65-F5344CB8AC3E}">
-        <p14:creationId xmlns:p14="http://schemas.microsoft.com/office/powerpoint/2010/main" val="1635779338"/>
+        <p14:creationId xmlns:p14="http://schemas.microsoft.com/office/powerpoint/2010/main" val="186971509"/>
       </p:ext>
     </p:extLst>
   </p:cSld>
@@ -12460,7 +12485,7 @@
           <p:cNvPr id="35" name="">
             <a:extLst xmlns:a="http://schemas.openxmlformats.org/drawingml/2006/main">
               <a:ext uri="{FF2B5EF4-FFF2-40B4-BE49-F238E27FC236}">
-                <a16:creationId xmlns:a16="http://schemas.microsoft.com/office/drawing/2014/main" id="{7E6E00CF-8852-4C61-ABE2-2D74C63C40DC}"/>
+                <a16:creationId xmlns:a16="http://schemas.microsoft.com/office/drawing/2014/main" id="{26E60E1C-FF74-47FC-90FF-2AAD62041A99}"/>
               </a:ext>
             </a:extLst>
           </p:cNvPr>
@@ -12490,7 +12515,7 @@
           <p:cNvPr id="2" name="">
             <a:extLst xmlns:a="http://schemas.openxmlformats.org/drawingml/2006/main">
               <a:ext uri="{FF2B5EF4-FFF2-40B4-BE49-F238E27FC236}">
-                <a16:creationId xmlns:a16="http://schemas.microsoft.com/office/drawing/2014/main" id="{C9E537C8-4808-4513-870C-26ED36A3EE90}"/>
+                <a16:creationId xmlns:a16="http://schemas.microsoft.com/office/drawing/2014/main" id="{81BE9495-5BC4-4070-B4D2-3B0F74A74954}"/>
               </a:ext>
             </a:extLst>
           </p:cNvPr>
@@ -12547,7 +12572,7 @@
           <p:cNvPr id="3" name="">
             <a:extLst xmlns:a="http://schemas.openxmlformats.org/drawingml/2006/main">
               <a:ext uri="{FF2B5EF4-FFF2-40B4-BE49-F238E27FC236}">
-                <a16:creationId xmlns:a16="http://schemas.microsoft.com/office/drawing/2014/main" id="{85A88071-9637-4BEE-81F2-6DE738AA9158}"/>
+                <a16:creationId xmlns:a16="http://schemas.microsoft.com/office/drawing/2014/main" id="{CB7B9EF8-6978-48B5-A655-DB39AEDBB7C6}"/>
               </a:ext>
             </a:extLst>
           </p:cNvPr>
@@ -12604,7 +12629,7 @@
           <p:cNvPr id="4" name="">
             <a:extLst xmlns:a="http://schemas.openxmlformats.org/drawingml/2006/main">
               <a:ext uri="{FF2B5EF4-FFF2-40B4-BE49-F238E27FC236}">
-                <a16:creationId xmlns:a16="http://schemas.microsoft.com/office/drawing/2014/main" id="{5F3F09CA-EECC-410B-ADA1-EB0958D4D703}"/>
+                <a16:creationId xmlns:a16="http://schemas.microsoft.com/office/drawing/2014/main" id="{00A1583F-42B9-49F8-8992-DB589DE5464E}"/>
               </a:ext>
             </a:extLst>
           </p:cNvPr>
@@ -12661,7 +12686,7 @@
           <p:cNvPr id="5" name="">
             <a:extLst xmlns:a="http://schemas.openxmlformats.org/drawingml/2006/main">
               <a:ext uri="{FF2B5EF4-FFF2-40B4-BE49-F238E27FC236}">
-                <a16:creationId xmlns:a16="http://schemas.microsoft.com/office/drawing/2014/main" id="{A5D9638A-DFA5-443B-9303-A52235040178}"/>
+                <a16:creationId xmlns:a16="http://schemas.microsoft.com/office/drawing/2014/main" id="{38093BED-5A69-4148-916F-28A97E319BFA}"/>
               </a:ext>
             </a:extLst>
           </p:cNvPr>
@@ -12718,7 +12743,7 @@
           <p:cNvPr id="6" name="">
             <a:extLst xmlns:a="http://schemas.openxmlformats.org/drawingml/2006/main">
               <a:ext uri="{FF2B5EF4-FFF2-40B4-BE49-F238E27FC236}">
-                <a16:creationId xmlns:a16="http://schemas.microsoft.com/office/drawing/2014/main" id="{64154528-8A29-40A7-B0B8-D023DACDC3DC}"/>
+                <a16:creationId xmlns:a16="http://schemas.microsoft.com/office/drawing/2014/main" id="{C9C9F787-9C98-421F-B45D-B047E51E797D}"/>
               </a:ext>
             </a:extLst>
           </p:cNvPr>
@@ -12753,7 +12778,7 @@
           <p:cNvPr id="7" name="">
             <a:extLst xmlns:a="http://schemas.openxmlformats.org/drawingml/2006/main">
               <a:ext uri="{FF2B5EF4-FFF2-40B4-BE49-F238E27FC236}">
-                <a16:creationId xmlns:a16="http://schemas.microsoft.com/office/drawing/2014/main" id="{5BA621F2-0A1E-42EB-A207-F25FDB4D46B5}"/>
+                <a16:creationId xmlns:a16="http://schemas.microsoft.com/office/drawing/2014/main" id="{7CCE64C6-0436-436E-8B9D-BC1B4C3C565D}"/>
               </a:ext>
             </a:extLst>
           </p:cNvPr>
@@ -12783,7 +12808,7 @@
           <p:cNvPr id="8" name="">
             <a:extLst xmlns:a="http://schemas.openxmlformats.org/drawingml/2006/main">
               <a:ext uri="{FF2B5EF4-FFF2-40B4-BE49-F238E27FC236}">
-                <a16:creationId xmlns:a16="http://schemas.microsoft.com/office/drawing/2014/main" id="{B6420995-F64E-488F-8957-808536E47007}"/>
+                <a16:creationId xmlns:a16="http://schemas.microsoft.com/office/drawing/2014/main" id="{803A01CD-6F41-4524-94D7-6E5ABD552E1E}"/>
               </a:ext>
             </a:extLst>
           </p:cNvPr>
@@ -12814,7 +12839,7 @@
           <p:cNvPr id="9" name="">
             <a:extLst xmlns:a="http://schemas.openxmlformats.org/drawingml/2006/main">
               <a:ext uri="{FF2B5EF4-FFF2-40B4-BE49-F238E27FC236}">
-                <a16:creationId xmlns:a16="http://schemas.microsoft.com/office/drawing/2014/main" id="{6BEB2B23-9365-45E2-B420-A6C245E2DFF3}"/>
+                <a16:creationId xmlns:a16="http://schemas.microsoft.com/office/drawing/2014/main" id="{F7000D9A-984A-4BD2-AF46-4360341FDB8A}"/>
               </a:ext>
             </a:extLst>
           </p:cNvPr>
@@ -12871,7 +12896,7 @@
           <p:cNvPr id="10" name="">
             <a:extLst xmlns:a="http://schemas.openxmlformats.org/drawingml/2006/main">
               <a:ext uri="{FF2B5EF4-FFF2-40B4-BE49-F238E27FC236}">
-                <a16:creationId xmlns:a16="http://schemas.microsoft.com/office/drawing/2014/main" id="{631DBDF1-88A5-431B-80FF-FAB0E5FF1E1C}"/>
+                <a16:creationId xmlns:a16="http://schemas.microsoft.com/office/drawing/2014/main" id="{3F42761E-8DAD-4152-98C2-2191DC252FB6}"/>
               </a:ext>
             </a:extLst>
           </p:cNvPr>
@@ -12928,7 +12953,7 @@
           <p:cNvPr id="11" name="">
             <a:extLst xmlns:a="http://schemas.openxmlformats.org/drawingml/2006/main">
               <a:ext uri="{FF2B5EF4-FFF2-40B4-BE49-F238E27FC236}">
-                <a16:creationId xmlns:a16="http://schemas.microsoft.com/office/drawing/2014/main" id="{0764C391-5B6F-44DB-A6AE-18E24DB9F9E2}"/>
+                <a16:creationId xmlns:a16="http://schemas.microsoft.com/office/drawing/2014/main" id="{1A1CEF5E-2552-46A3-867F-259BB9D39E16}"/>
               </a:ext>
             </a:extLst>
           </p:cNvPr>
@@ -12958,7 +12983,7 @@
           <p:cNvPr id="12" name="">
             <a:extLst xmlns:a="http://schemas.openxmlformats.org/drawingml/2006/main">
               <a:ext uri="{FF2B5EF4-FFF2-40B4-BE49-F238E27FC236}">
-                <a16:creationId xmlns:a16="http://schemas.microsoft.com/office/drawing/2014/main" id="{54FB58EE-015D-4A6E-BC5A-B26567EE98BA}"/>
+                <a16:creationId xmlns:a16="http://schemas.microsoft.com/office/drawing/2014/main" id="{FD86FDAB-9289-4789-BDA1-25D99E56BE89}"/>
               </a:ext>
             </a:extLst>
           </p:cNvPr>
@@ -12989,7 +13014,7 @@
           <p:cNvPr id="13" name="">
             <a:extLst xmlns:a="http://schemas.openxmlformats.org/drawingml/2006/main">
               <a:ext uri="{FF2B5EF4-FFF2-40B4-BE49-F238E27FC236}">
-                <a16:creationId xmlns:a16="http://schemas.microsoft.com/office/drawing/2014/main" id="{EBC3BCB5-8B6D-4EF0-B6A0-DA465F60A7BC}"/>
+                <a16:creationId xmlns:a16="http://schemas.microsoft.com/office/drawing/2014/main" id="{43EB015B-19D8-49BD-9CE1-68DD0C6CEAFF}"/>
               </a:ext>
             </a:extLst>
           </p:cNvPr>
@@ -13046,7 +13071,7 @@
           <p:cNvPr id="14" name="">
             <a:extLst xmlns:a="http://schemas.openxmlformats.org/drawingml/2006/main">
               <a:ext uri="{FF2B5EF4-FFF2-40B4-BE49-F238E27FC236}">
-                <a16:creationId xmlns:a16="http://schemas.microsoft.com/office/drawing/2014/main" id="{B6744459-A215-4357-B09D-8109A92FAAF1}"/>
+                <a16:creationId xmlns:a16="http://schemas.microsoft.com/office/drawing/2014/main" id="{4A2DC776-B516-41B6-AB56-60ECB7787281}"/>
               </a:ext>
             </a:extLst>
           </p:cNvPr>
@@ -13103,7 +13128,7 @@
           <p:cNvPr id="15" name="">
             <a:extLst xmlns:a="http://schemas.openxmlformats.org/drawingml/2006/main">
               <a:ext uri="{FF2B5EF4-FFF2-40B4-BE49-F238E27FC236}">
-                <a16:creationId xmlns:a16="http://schemas.microsoft.com/office/drawing/2014/main" id="{3E07AFA4-C7A4-48B0-B3B6-3CCE0810ED34}"/>
+                <a16:creationId xmlns:a16="http://schemas.microsoft.com/office/drawing/2014/main" id="{10B5340E-304B-4AB4-8AD1-DC7148E8F397}"/>
               </a:ext>
             </a:extLst>
           </p:cNvPr>
@@ -13133,7 +13158,7 @@
           <p:cNvPr id="16" name="">
             <a:extLst xmlns:a="http://schemas.openxmlformats.org/drawingml/2006/main">
               <a:ext uri="{FF2B5EF4-FFF2-40B4-BE49-F238E27FC236}">
-                <a16:creationId xmlns:a16="http://schemas.microsoft.com/office/drawing/2014/main" id="{E5B9DF36-0533-4C4B-9F25-D0F1B7A57609}"/>
+                <a16:creationId xmlns:a16="http://schemas.microsoft.com/office/drawing/2014/main" id="{C8AEA237-6D8C-4D8D-8DB8-A00905EEC1B3}"/>
               </a:ext>
             </a:extLst>
           </p:cNvPr>
@@ -13164,7 +13189,7 @@
           <p:cNvPr id="17" name="">
             <a:extLst xmlns:a="http://schemas.openxmlformats.org/drawingml/2006/main">
               <a:ext uri="{FF2B5EF4-FFF2-40B4-BE49-F238E27FC236}">
-                <a16:creationId xmlns:a16="http://schemas.microsoft.com/office/drawing/2014/main" id="{84C03B5C-90AE-4538-A6AF-96D31A49E8AF}"/>
+                <a16:creationId xmlns:a16="http://schemas.microsoft.com/office/drawing/2014/main" id="{0EF42D8A-2E79-46B4-86C8-B24207AD4968}"/>
               </a:ext>
             </a:extLst>
           </p:cNvPr>
@@ -13221,7 +13246,7 @@
           <p:cNvPr id="18" name="">
             <a:extLst xmlns:a="http://schemas.openxmlformats.org/drawingml/2006/main">
               <a:ext uri="{FF2B5EF4-FFF2-40B4-BE49-F238E27FC236}">
-                <a16:creationId xmlns:a16="http://schemas.microsoft.com/office/drawing/2014/main" id="{57C424DF-0B93-4EAC-BC4D-0DAAE793640F}"/>
+                <a16:creationId xmlns:a16="http://schemas.microsoft.com/office/drawing/2014/main" id="{BF9A5DE0-8CA3-4CFB-915B-7C2B6B6B8011}"/>
               </a:ext>
             </a:extLst>
           </p:cNvPr>
@@ -13278,7 +13303,7 @@
           <p:cNvPr id="19" name="">
             <a:extLst xmlns:a="http://schemas.openxmlformats.org/drawingml/2006/main">
               <a:ext uri="{FF2B5EF4-FFF2-40B4-BE49-F238E27FC236}">
-                <a16:creationId xmlns:a16="http://schemas.microsoft.com/office/drawing/2014/main" id="{CC25B19F-970F-4848-8CF6-C594C0E8E444}"/>
+                <a16:creationId xmlns:a16="http://schemas.microsoft.com/office/drawing/2014/main" id="{9ACA38E3-F3CC-495C-8FE5-6E9A98C34298}"/>
               </a:ext>
             </a:extLst>
           </p:cNvPr>
@@ -13308,7 +13333,7 @@
           <p:cNvPr id="20" name="">
             <a:extLst xmlns:a="http://schemas.openxmlformats.org/drawingml/2006/main">
               <a:ext uri="{FF2B5EF4-FFF2-40B4-BE49-F238E27FC236}">
-                <a16:creationId xmlns:a16="http://schemas.microsoft.com/office/drawing/2014/main" id="{8846B344-A5A6-4290-9CCA-498D0CC8606D}"/>
+                <a16:creationId xmlns:a16="http://schemas.microsoft.com/office/drawing/2014/main" id="{5FF0F02D-279E-4C2A-B23A-506A8AC4F117}"/>
               </a:ext>
             </a:extLst>
           </p:cNvPr>
@@ -13339,7 +13364,7 @@
           <p:cNvPr id="21" name="">
             <a:extLst xmlns:a="http://schemas.openxmlformats.org/drawingml/2006/main">
               <a:ext uri="{FF2B5EF4-FFF2-40B4-BE49-F238E27FC236}">
-                <a16:creationId xmlns:a16="http://schemas.microsoft.com/office/drawing/2014/main" id="{5595F128-7911-4478-A854-DCDDD980B239}"/>
+                <a16:creationId xmlns:a16="http://schemas.microsoft.com/office/drawing/2014/main" id="{D8B8D7E4-D880-4E3F-AB9E-6BB7B5ECAA70}"/>
               </a:ext>
             </a:extLst>
           </p:cNvPr>
@@ -13396,7 +13421,7 @@
           <p:cNvPr id="22" name="">
             <a:extLst xmlns:a="http://schemas.openxmlformats.org/drawingml/2006/main">
               <a:ext uri="{FF2B5EF4-FFF2-40B4-BE49-F238E27FC236}">
-                <a16:creationId xmlns:a16="http://schemas.microsoft.com/office/drawing/2014/main" id="{5F065F1A-6535-4209-A30D-1DF37BEDDCEF}"/>
+                <a16:creationId xmlns:a16="http://schemas.microsoft.com/office/drawing/2014/main" id="{89DA82C1-42AF-45C9-B724-DD4B7929F3B4}"/>
               </a:ext>
             </a:extLst>
           </p:cNvPr>
@@ -13453,7 +13478,7 @@
           <p:cNvPr id="23" name="">
             <a:extLst xmlns:a="http://schemas.openxmlformats.org/drawingml/2006/main">
               <a:ext uri="{FF2B5EF4-FFF2-40B4-BE49-F238E27FC236}">
-                <a16:creationId xmlns:a16="http://schemas.microsoft.com/office/drawing/2014/main" id="{76FBD9ED-0F6D-481E-8E12-C22506014486}"/>
+                <a16:creationId xmlns:a16="http://schemas.microsoft.com/office/drawing/2014/main" id="{5224A0B9-ED58-457C-AE84-C2CFF8A5B3AC}"/>
               </a:ext>
             </a:extLst>
           </p:cNvPr>
@@ -13483,7 +13508,7 @@
           <p:cNvPr id="24" name="">
             <a:extLst xmlns:a="http://schemas.openxmlformats.org/drawingml/2006/main">
               <a:ext uri="{FF2B5EF4-FFF2-40B4-BE49-F238E27FC236}">
-                <a16:creationId xmlns:a16="http://schemas.microsoft.com/office/drawing/2014/main" id="{F0C4EB82-C4EB-4C09-9E35-5BCBCF3AAF57}"/>
+                <a16:creationId xmlns:a16="http://schemas.microsoft.com/office/drawing/2014/main" id="{A8CFBEF8-E074-4BC7-8270-8BFB2A39E9C2}"/>
               </a:ext>
             </a:extLst>
           </p:cNvPr>
@@ -13540,7 +13565,7 @@
           <p:cNvPr id="25" name="">
             <a:extLst xmlns:a="http://schemas.openxmlformats.org/drawingml/2006/main">
               <a:ext uri="{FF2B5EF4-FFF2-40B4-BE49-F238E27FC236}">
-                <a16:creationId xmlns:a16="http://schemas.microsoft.com/office/drawing/2014/main" id="{9EA4AAB7-476C-44F3-AFDB-2ABBA18DAE28}"/>
+                <a16:creationId xmlns:a16="http://schemas.microsoft.com/office/drawing/2014/main" id="{4169310F-DD86-4E8A-8456-816FA02135B7}"/>
               </a:ext>
             </a:extLst>
           </p:cNvPr>
@@ -13597,7 +13622,7 @@
           <p:cNvPr id="26" name="">
             <a:extLst xmlns:a="http://schemas.openxmlformats.org/drawingml/2006/main">
               <a:ext uri="{FF2B5EF4-FFF2-40B4-BE49-F238E27FC236}">
-                <a16:creationId xmlns:a16="http://schemas.microsoft.com/office/drawing/2014/main" id="{A57804E5-0DD3-4C6E-9694-E3D63C3B45B1}"/>
+                <a16:creationId xmlns:a16="http://schemas.microsoft.com/office/drawing/2014/main" id="{DE4B2811-A09F-498D-ADFC-B52E692A9FFB}"/>
               </a:ext>
             </a:extLst>
           </p:cNvPr>
@@ -13654,7 +13679,7 @@
           <p:cNvPr id="27" name="">
             <a:extLst xmlns:a="http://schemas.openxmlformats.org/drawingml/2006/main">
               <a:ext uri="{FF2B5EF4-FFF2-40B4-BE49-F238E27FC236}">
-                <a16:creationId xmlns:a16="http://schemas.microsoft.com/office/drawing/2014/main" id="{67F25ABF-711D-4BDA-9A35-D8329420B362}"/>
+                <a16:creationId xmlns:a16="http://schemas.microsoft.com/office/drawing/2014/main" id="{DCE1F392-8C31-48C5-872F-EECC2ADD93D6}"/>
               </a:ext>
             </a:extLst>
           </p:cNvPr>
@@ -13711,7 +13736,7 @@
           <p:cNvPr id="28" name="">
             <a:extLst xmlns:a="http://schemas.openxmlformats.org/drawingml/2006/main">
               <a:ext uri="{FF2B5EF4-FFF2-40B4-BE49-F238E27FC236}">
-                <a16:creationId xmlns:a16="http://schemas.microsoft.com/office/drawing/2014/main" id="{14E8DCDD-4AEF-4F48-8242-6CA58BE4DCE2}"/>
+                <a16:creationId xmlns:a16="http://schemas.microsoft.com/office/drawing/2014/main" id="{4DAD1549-C514-43B7-9D6A-DAAD1594BAAE}"/>
               </a:ext>
             </a:extLst>
           </p:cNvPr>
@@ -13768,7 +13793,7 @@
           <p:cNvPr id="29" name="">
             <a:extLst xmlns:a="http://schemas.openxmlformats.org/drawingml/2006/main">
               <a:ext uri="{FF2B5EF4-FFF2-40B4-BE49-F238E27FC236}">
-                <a16:creationId xmlns:a16="http://schemas.microsoft.com/office/drawing/2014/main" id="{33668192-BF76-42D7-ACE4-2EAF04DC75E1}"/>
+                <a16:creationId xmlns:a16="http://schemas.microsoft.com/office/drawing/2014/main" id="{73D52A65-F22E-46A9-A74C-D7A730618466}"/>
               </a:ext>
             </a:extLst>
           </p:cNvPr>
@@ -13825,7 +13850,7 @@
           <p:cNvPr id="30" name="">
             <a:extLst xmlns:a="http://schemas.openxmlformats.org/drawingml/2006/main">
               <a:ext uri="{FF2B5EF4-FFF2-40B4-BE49-F238E27FC236}">
-                <a16:creationId xmlns:a16="http://schemas.microsoft.com/office/drawing/2014/main" id="{6D961EE8-1DD4-433E-B11A-3091D9E11A4F}"/>
+                <a16:creationId xmlns:a16="http://schemas.microsoft.com/office/drawing/2014/main" id="{70AF2367-E9DD-472D-8A85-C5373E4DDB27}"/>
               </a:ext>
             </a:extLst>
           </p:cNvPr>
@@ -13882,7 +13907,7 @@
           <p:cNvPr id="31" name="">
             <a:extLst xmlns:a="http://schemas.openxmlformats.org/drawingml/2006/main">
               <a:ext uri="{FF2B5EF4-FFF2-40B4-BE49-F238E27FC236}">
-                <a16:creationId xmlns:a16="http://schemas.microsoft.com/office/drawing/2014/main" id="{DA934F4B-0E95-4F8D-814E-2975A9B0E49E}"/>
+                <a16:creationId xmlns:a16="http://schemas.microsoft.com/office/drawing/2014/main" id="{54B1DB6B-ED57-46F4-BFBB-D02A22908ACC}"/>
               </a:ext>
             </a:extLst>
           </p:cNvPr>
@@ -13939,7 +13964,7 @@
           <p:cNvPr id="32" name="">
             <a:extLst xmlns:a="http://schemas.openxmlformats.org/drawingml/2006/main">
               <a:ext uri="{FF2B5EF4-FFF2-40B4-BE49-F238E27FC236}">
-                <a16:creationId xmlns:a16="http://schemas.microsoft.com/office/drawing/2014/main" id="{E4D8541C-3095-4605-96D4-DF8A50995CBD}"/>
+                <a16:creationId xmlns:a16="http://schemas.microsoft.com/office/drawing/2014/main" id="{A4946E40-39ED-4B2E-86DD-194D85310798}"/>
               </a:ext>
             </a:extLst>
           </p:cNvPr>
@@ -13996,7 +14021,7 @@
           <p:cNvPr id="33" name="">
             <a:extLst xmlns:a="http://schemas.openxmlformats.org/drawingml/2006/main">
               <a:ext uri="{FF2B5EF4-FFF2-40B4-BE49-F238E27FC236}">
-                <a16:creationId xmlns:a16="http://schemas.microsoft.com/office/drawing/2014/main" id="{0B69A1F9-EE61-49DD-A550-42B8E6C8CFF1}"/>
+                <a16:creationId xmlns:a16="http://schemas.microsoft.com/office/drawing/2014/main" id="{32317D6F-09B6-4CD6-8A81-BEC43D63100F}"/>
               </a:ext>
             </a:extLst>
           </p:cNvPr>
@@ -14053,7 +14078,7 @@
           <p:cNvPr id="34" name="">
             <a:extLst xmlns:a="http://schemas.openxmlformats.org/drawingml/2006/main">
               <a:ext uri="{FF2B5EF4-FFF2-40B4-BE49-F238E27FC236}">
-                <a16:creationId xmlns:a16="http://schemas.microsoft.com/office/drawing/2014/main" id="{838B45C5-5651-42A0-9232-13F8DCE84A54}"/>
+                <a16:creationId xmlns:a16="http://schemas.microsoft.com/office/drawing/2014/main" id="{9625036A-FC14-47DD-94AB-51144A6E73BD}"/>
               </a:ext>
             </a:extLst>
           </p:cNvPr>
@@ -14108,7 +14133,7 @@
     </p:spTree>
     <p:extLst>
       <p:ext uri="{BB962C8B-B14F-4D97-AF65-F5344CB8AC3E}">
-        <p14:creationId xmlns:p14="http://schemas.microsoft.com/office/powerpoint/2010/main" val="1664198654"/>
+        <p14:creationId xmlns:p14="http://schemas.microsoft.com/office/powerpoint/2010/main" val="1419750235"/>
       </p:ext>
     </p:extLst>
   </p:cSld>
@@ -14139,7 +14164,7 @@
           <p:cNvPr id="25" name="">
             <a:extLst xmlns:a="http://schemas.openxmlformats.org/drawingml/2006/main">
               <a:ext uri="{FF2B5EF4-FFF2-40B4-BE49-F238E27FC236}">
-                <a16:creationId xmlns:a16="http://schemas.microsoft.com/office/drawing/2014/main" id="{1EC4D8AB-9407-4A73-8516-88EFA94CA979}"/>
+                <a16:creationId xmlns:a16="http://schemas.microsoft.com/office/drawing/2014/main" id="{C612C09F-97C5-47BE-9A7C-C1D0A4262F8D}"/>
               </a:ext>
             </a:extLst>
           </p:cNvPr>
@@ -14169,7 +14194,7 @@
           <p:cNvPr id="2" name="">
             <a:extLst xmlns:a="http://schemas.openxmlformats.org/drawingml/2006/main">
               <a:ext uri="{FF2B5EF4-FFF2-40B4-BE49-F238E27FC236}">
-                <a16:creationId xmlns:a16="http://schemas.microsoft.com/office/drawing/2014/main" id="{ACE430E9-4727-4133-963C-C3DF691521D6}"/>
+                <a16:creationId xmlns:a16="http://schemas.microsoft.com/office/drawing/2014/main" id="{C1678367-0DA1-44E9-8A1B-27AACC6DCC2A}"/>
               </a:ext>
             </a:extLst>
           </p:cNvPr>
@@ -14226,7 +14251,7 @@
           <p:cNvPr id="3" name="">
             <a:extLst xmlns:a="http://schemas.openxmlformats.org/drawingml/2006/main">
               <a:ext uri="{FF2B5EF4-FFF2-40B4-BE49-F238E27FC236}">
-                <a16:creationId xmlns:a16="http://schemas.microsoft.com/office/drawing/2014/main" id="{0E39D1AD-6A2F-4524-A06F-F7C5A927EA72}"/>
+                <a16:creationId xmlns:a16="http://schemas.microsoft.com/office/drawing/2014/main" id="{DEA3F93B-B572-4CB8-A5AA-A9FB69BE1246}"/>
               </a:ext>
             </a:extLst>
           </p:cNvPr>
@@ -14283,7 +14308,7 @@
           <p:cNvPr id="4" name="">
             <a:extLst xmlns:a="http://schemas.openxmlformats.org/drawingml/2006/main">
               <a:ext uri="{FF2B5EF4-FFF2-40B4-BE49-F238E27FC236}">
-                <a16:creationId xmlns:a16="http://schemas.microsoft.com/office/drawing/2014/main" id="{011BF0C8-2E5B-4165-8A0E-FEC566897735}"/>
+                <a16:creationId xmlns:a16="http://schemas.microsoft.com/office/drawing/2014/main" id="{C32AD9A3-944A-464D-AF9C-6C432D7814F3}"/>
               </a:ext>
             </a:extLst>
           </p:cNvPr>
@@ -14340,7 +14365,7 @@
           <p:cNvPr id="5" name="">
             <a:extLst xmlns:a="http://schemas.openxmlformats.org/drawingml/2006/main">
               <a:ext uri="{FF2B5EF4-FFF2-40B4-BE49-F238E27FC236}">
-                <a16:creationId xmlns:a16="http://schemas.microsoft.com/office/drawing/2014/main" id="{19DBB6FF-238A-459F-BAE5-8A71E99D497D}"/>
+                <a16:creationId xmlns:a16="http://schemas.microsoft.com/office/drawing/2014/main" id="{8ED502A4-DFD1-4907-A38B-F138BE509225}"/>
               </a:ext>
             </a:extLst>
           </p:cNvPr>
@@ -14397,7 +14422,7 @@
           <p:cNvPr id="6" name="">
             <a:extLst xmlns:a="http://schemas.openxmlformats.org/drawingml/2006/main">
               <a:ext uri="{FF2B5EF4-FFF2-40B4-BE49-F238E27FC236}">
-                <a16:creationId xmlns:a16="http://schemas.microsoft.com/office/drawing/2014/main" id="{5F6B1237-CA2D-4E06-AAEE-5CF816B00D09}"/>
+                <a16:creationId xmlns:a16="http://schemas.microsoft.com/office/drawing/2014/main" id="{07860E40-48FC-494D-BB05-67D073D28481}"/>
               </a:ext>
             </a:extLst>
           </p:cNvPr>
@@ -14432,7 +14457,7 @@
           <p:cNvPr id="7" name="">
             <a:extLst xmlns:a="http://schemas.openxmlformats.org/drawingml/2006/main">
               <a:ext uri="{FF2B5EF4-FFF2-40B4-BE49-F238E27FC236}">
-                <a16:creationId xmlns:a16="http://schemas.microsoft.com/office/drawing/2014/main" id="{DDFF06DA-5210-4BB8-A503-39CA33E4900A}"/>
+                <a16:creationId xmlns:a16="http://schemas.microsoft.com/office/drawing/2014/main" id="{6766E17C-2870-4842-A2CB-F6D82C885E59}"/>
               </a:ext>
             </a:extLst>
           </p:cNvPr>
@@ -14489,7 +14514,7 @@
           <p:cNvPr id="8" name="">
             <a:extLst xmlns:a="http://schemas.openxmlformats.org/drawingml/2006/main">
               <a:ext uri="{FF2B5EF4-FFF2-40B4-BE49-F238E27FC236}">
-                <a16:creationId xmlns:a16="http://schemas.microsoft.com/office/drawing/2014/main" id="{1C4758C7-0982-457D-BAB2-E7CCFA3E01A6}"/>
+                <a16:creationId xmlns:a16="http://schemas.microsoft.com/office/drawing/2014/main" id="{AC78F111-D43E-4C9D-97BF-C4BA16FA2388}"/>
               </a:ext>
             </a:extLst>
           </p:cNvPr>
@@ -14536,7 +14561,30 @@
                 <a:ea typeface="Liberation Sans"/>
                 <a:cs typeface="Liberation Sans"/>
               </a:rPr>
-              <a:t>Inventory, workflow, permissions, run history</a:t>
+              <a:t>Verified RCA run</a:t>
+            </a:r>
+          </a:p>
+          <a:p xmlns:a="http://schemas.openxmlformats.org/drawingml/2006/main">
+            <a:pPr>
+              <a:defRPr sz="1575" b="0">
+                <a:solidFill>
+                  <a:srgbClr val="F4F8FC"/>
+                </a:solidFill>
+                <a:latin typeface="Liberation Sans"/>
+                <a:ea typeface="Liberation Sans"/>
+                <a:cs typeface="Liberation Sans"/>
+              </a:defRPr>
+            </a:pPr>
+            <a:r>
+              <a:rPr sz="1575" b="0">
+                <a:solidFill>
+                  <a:srgbClr val="F4F8FC"/>
+                </a:solidFill>
+                <a:latin typeface="Liberation Sans"/>
+                <a:ea typeface="Liberation Sans"/>
+                <a:cs typeface="Liberation Sans"/>
+              </a:rPr>
+              <a:t>High confidence finding</a:t>
             </a:r>
           </a:p>
         </p:txBody>
@@ -14546,7 +14594,7 @@
           <p:cNvPr id="9" name="">
             <a:extLst xmlns:a="http://schemas.openxmlformats.org/drawingml/2006/main">
               <a:ext uri="{FF2B5EF4-FFF2-40B4-BE49-F238E27FC236}">
-                <a16:creationId xmlns:a16="http://schemas.microsoft.com/office/drawing/2014/main" id="{EFEE4B5F-2DFE-41CB-A42B-56FB31ABF1FB}"/>
+                <a16:creationId xmlns:a16="http://schemas.microsoft.com/office/drawing/2014/main" id="{B96B0C99-8653-4F33-AE61-1A736026DD10}"/>
               </a:ext>
             </a:extLst>
           </p:cNvPr>
@@ -14576,7 +14624,7 @@
           <p:cNvPr id="10" name="">
             <a:extLst xmlns:a="http://schemas.openxmlformats.org/drawingml/2006/main">
               <a:ext uri="{FF2B5EF4-FFF2-40B4-BE49-F238E27FC236}">
-                <a16:creationId xmlns:a16="http://schemas.microsoft.com/office/drawing/2014/main" id="{6491094C-FA19-47A3-82C3-1590D34BFD77}"/>
+                <a16:creationId xmlns:a16="http://schemas.microsoft.com/office/drawing/2014/main" id="{2C16493F-9B56-4EA0-A054-1D4D7F74DF1F}"/>
               </a:ext>
             </a:extLst>
           </p:cNvPr>
@@ -14633,7 +14681,7 @@
           <p:cNvPr id="11" name="">
             <a:extLst xmlns:a="http://schemas.openxmlformats.org/drawingml/2006/main">
               <a:ext uri="{FF2B5EF4-FFF2-40B4-BE49-F238E27FC236}">
-                <a16:creationId xmlns:a16="http://schemas.microsoft.com/office/drawing/2014/main" id="{CA588FA5-8B95-4131-A297-8971088FD72F}"/>
+                <a16:creationId xmlns:a16="http://schemas.microsoft.com/office/drawing/2014/main" id="{C37F785F-387E-4383-AEF5-0D2F85C2AC9B}"/>
               </a:ext>
             </a:extLst>
           </p:cNvPr>
@@ -14668,7 +14716,7 @@
           <p:cNvPr id="12" name="">
             <a:extLst xmlns:a="http://schemas.openxmlformats.org/drawingml/2006/main">
               <a:ext uri="{FF2B5EF4-FFF2-40B4-BE49-F238E27FC236}">
-                <a16:creationId xmlns:a16="http://schemas.microsoft.com/office/drawing/2014/main" id="{E84ECB15-B8E7-41FA-B6FA-3E0500D8EF7C}"/>
+                <a16:creationId xmlns:a16="http://schemas.microsoft.com/office/drawing/2014/main" id="{688F7FF2-1FF6-4B24-9E4E-8E981CD2098B}"/>
               </a:ext>
             </a:extLst>
           </p:cNvPr>
@@ -14725,7 +14773,7 @@
           <p:cNvPr id="13" name="">
             <a:extLst xmlns:a="http://schemas.openxmlformats.org/drawingml/2006/main">
               <a:ext uri="{FF2B5EF4-FFF2-40B4-BE49-F238E27FC236}">
-                <a16:creationId xmlns:a16="http://schemas.microsoft.com/office/drawing/2014/main" id="{0ED9479F-1476-4282-AE00-A69FBB07D333}"/>
+                <a16:creationId xmlns:a16="http://schemas.microsoft.com/office/drawing/2014/main" id="{6465A8FD-C4AC-4B57-9C95-56CAEC2C2832}"/>
               </a:ext>
             </a:extLst>
           </p:cNvPr>
@@ -14772,7 +14820,7 @@
                 <a:ea typeface="Liberation Sans"/>
                 <a:cs typeface="Liberation Sans"/>
               </a:rPr>
-              <a:t>Alert evaluation and webhook delivery</a:t>
+              <a:t>Normal / Pending / Firing / Normal</a:t>
             </a:r>
           </a:p>
         </p:txBody>
@@ -14782,7 +14830,7 @@
           <p:cNvPr id="14" name="">
             <a:extLst xmlns:a="http://schemas.openxmlformats.org/drawingml/2006/main">
               <a:ext uri="{FF2B5EF4-FFF2-40B4-BE49-F238E27FC236}">
-                <a16:creationId xmlns:a16="http://schemas.microsoft.com/office/drawing/2014/main" id="{22390C48-B703-4200-B080-1A6CE4B26E6E}"/>
+                <a16:creationId xmlns:a16="http://schemas.microsoft.com/office/drawing/2014/main" id="{B9723E2F-3060-48EC-9243-4DB40D0C8F25}"/>
               </a:ext>
             </a:extLst>
           </p:cNvPr>
@@ -14812,7 +14860,7 @@
           <p:cNvPr id="15" name="">
             <a:extLst xmlns:a="http://schemas.openxmlformats.org/drawingml/2006/main">
               <a:ext uri="{FF2B5EF4-FFF2-40B4-BE49-F238E27FC236}">
-                <a16:creationId xmlns:a16="http://schemas.microsoft.com/office/drawing/2014/main" id="{6FB6BE4A-AD35-4C16-A48F-370A27E4F872}"/>
+                <a16:creationId xmlns:a16="http://schemas.microsoft.com/office/drawing/2014/main" id="{65B30A77-3B5E-4965-93ED-7F528BB3FA81}"/>
               </a:ext>
             </a:extLst>
           </p:cNvPr>
@@ -14869,7 +14917,7 @@
           <p:cNvPr id="16" name="">
             <a:extLst xmlns:a="http://schemas.openxmlformats.org/drawingml/2006/main">
               <a:ext uri="{FF2B5EF4-FFF2-40B4-BE49-F238E27FC236}">
-                <a16:creationId xmlns:a16="http://schemas.microsoft.com/office/drawing/2014/main" id="{38E25696-599A-415D-AE46-DA6CB4FD1668}"/>
+                <a16:creationId xmlns:a16="http://schemas.microsoft.com/office/drawing/2014/main" id="{DE51F4B2-C18B-4DEF-B329-5B5E1E005A57}"/>
               </a:ext>
             </a:extLst>
           </p:cNvPr>
@@ -14904,7 +14952,7 @@
           <p:cNvPr id="17" name="">
             <a:extLst xmlns:a="http://schemas.openxmlformats.org/drawingml/2006/main">
               <a:ext uri="{FF2B5EF4-FFF2-40B4-BE49-F238E27FC236}">
-                <a16:creationId xmlns:a16="http://schemas.microsoft.com/office/drawing/2014/main" id="{E8316375-7399-4EA0-9008-2343092979FB}"/>
+                <a16:creationId xmlns:a16="http://schemas.microsoft.com/office/drawing/2014/main" id="{11F734EF-8226-4B1D-A6AF-76D66EFD763A}"/>
               </a:ext>
             </a:extLst>
           </p:cNvPr>
@@ -14961,7 +15009,7 @@
           <p:cNvPr id="18" name="">
             <a:extLst xmlns:a="http://schemas.openxmlformats.org/drawingml/2006/main">
               <a:ext uri="{FF2B5EF4-FFF2-40B4-BE49-F238E27FC236}">
-                <a16:creationId xmlns:a16="http://schemas.microsoft.com/office/drawing/2014/main" id="{82BCB6BD-7D44-4A37-8AC7-EE57647D79FD}"/>
+                <a16:creationId xmlns:a16="http://schemas.microsoft.com/office/drawing/2014/main" id="{E98B9D2E-3D3C-46C3-97A5-09AD3C32929E}"/>
               </a:ext>
             </a:extLst>
           </p:cNvPr>
@@ -15008,7 +15056,7 @@
                 <a:ea typeface="Liberation Sans"/>
                 <a:cs typeface="Liberation Sans"/>
               </a:rPr>
-              <a:t>Repair diff and automated review</a:t>
+              <a:t>Open PR #1 with AgentOps review</a:t>
             </a:r>
           </a:p>
         </p:txBody>
@@ -15018,7 +15066,7 @@
           <p:cNvPr id="19" name="">
             <a:extLst xmlns:a="http://schemas.openxmlformats.org/drawingml/2006/main">
               <a:ext uri="{FF2B5EF4-FFF2-40B4-BE49-F238E27FC236}">
-                <a16:creationId xmlns:a16="http://schemas.microsoft.com/office/drawing/2014/main" id="{0C2328F1-F7A4-4CC0-9728-D27B3C668BA1}"/>
+                <a16:creationId xmlns:a16="http://schemas.microsoft.com/office/drawing/2014/main" id="{D35B6D85-FB00-487D-B761-CEACC93B3BDD}"/>
               </a:ext>
             </a:extLst>
           </p:cNvPr>
@@ -15048,7 +15096,7 @@
           <p:cNvPr id="20" name="">
             <a:extLst xmlns:a="http://schemas.openxmlformats.org/drawingml/2006/main">
               <a:ext uri="{FF2B5EF4-FFF2-40B4-BE49-F238E27FC236}">
-                <a16:creationId xmlns:a16="http://schemas.microsoft.com/office/drawing/2014/main" id="{36651931-6A10-4EDF-8539-14675974D747}"/>
+                <a16:creationId xmlns:a16="http://schemas.microsoft.com/office/drawing/2014/main" id="{4450B484-C33F-44C6-8337-DA8102692F98}"/>
               </a:ext>
             </a:extLst>
           </p:cNvPr>
@@ -15105,7 +15153,7 @@
           <p:cNvPr id="21" name="">
             <a:extLst xmlns:a="http://schemas.openxmlformats.org/drawingml/2006/main">
               <a:ext uri="{FF2B5EF4-FFF2-40B4-BE49-F238E27FC236}">
-                <a16:creationId xmlns:a16="http://schemas.microsoft.com/office/drawing/2014/main" id="{C7B9C5AF-2F4D-401D-A642-528BA225044B}"/>
+                <a16:creationId xmlns:a16="http://schemas.microsoft.com/office/drawing/2014/main" id="{6B0E2320-46F2-44FA-AEE4-947FAFB3E136}"/>
               </a:ext>
             </a:extLst>
           </p:cNvPr>
@@ -15140,7 +15188,7 @@
           <p:cNvPr id="22" name="">
             <a:extLst xmlns:a="http://schemas.openxmlformats.org/drawingml/2006/main">
               <a:ext uri="{FF2B5EF4-FFF2-40B4-BE49-F238E27FC236}">
-                <a16:creationId xmlns:a16="http://schemas.microsoft.com/office/drawing/2014/main" id="{81D06CB8-14C0-4298-A789-1952A86E27D7}"/>
+                <a16:creationId xmlns:a16="http://schemas.microsoft.com/office/drawing/2014/main" id="{932CC261-86EF-462B-BE2D-0FDEFFD0810A}"/>
               </a:ext>
             </a:extLst>
           </p:cNvPr>
@@ -15197,7 +15245,7 @@
           <p:cNvPr id="23" name="">
             <a:extLst xmlns:a="http://schemas.openxmlformats.org/drawingml/2006/main">
               <a:ext uri="{FF2B5EF4-FFF2-40B4-BE49-F238E27FC236}">
-                <a16:creationId xmlns:a16="http://schemas.microsoft.com/office/drawing/2014/main" id="{6BFA27E0-77C3-4E3D-8009-0D3C56CC15B5}"/>
+                <a16:creationId xmlns:a16="http://schemas.microsoft.com/office/drawing/2014/main" id="{1C741247-C28A-4283-A078-7E381B61D2F0}"/>
               </a:ext>
             </a:extLst>
           </p:cNvPr>
@@ -15254,7 +15302,7 @@
           <p:cNvPr id="24" name="">
             <a:extLst xmlns:a="http://schemas.openxmlformats.org/drawingml/2006/main">
               <a:ext uri="{FF2B5EF4-FFF2-40B4-BE49-F238E27FC236}">
-                <a16:creationId xmlns:a16="http://schemas.microsoft.com/office/drawing/2014/main" id="{B2C7AACB-CA9E-491C-B543-972C952CC98C}"/>
+                <a16:creationId xmlns:a16="http://schemas.microsoft.com/office/drawing/2014/main" id="{9BABEC41-830A-4C26-9544-2D409D7DCC40}"/>
               </a:ext>
             </a:extLst>
           </p:cNvPr>
@@ -15309,7 +15357,7 @@
     </p:spTree>
     <p:extLst>
       <p:ext uri="{BB962C8B-B14F-4D97-AF65-F5344CB8AC3E}">
-        <p14:creationId xmlns:p14="http://schemas.microsoft.com/office/powerpoint/2010/main" val="1303619741"/>
+        <p14:creationId xmlns:p14="http://schemas.microsoft.com/office/powerpoint/2010/main" val="231811748"/>
       </p:ext>
     </p:extLst>
   </p:cSld>
@@ -15340,7 +15388,7 @@
           <p:cNvPr id="23" name="">
             <a:extLst xmlns:a="http://schemas.openxmlformats.org/drawingml/2006/main">
               <a:ext uri="{FF2B5EF4-FFF2-40B4-BE49-F238E27FC236}">
-                <a16:creationId xmlns:a16="http://schemas.microsoft.com/office/drawing/2014/main" id="{C0202433-6FA3-4DA2-B63E-CD70E1351904}"/>
+                <a16:creationId xmlns:a16="http://schemas.microsoft.com/office/drawing/2014/main" id="{D706C555-1064-4ACF-BC27-7D73AC633963}"/>
               </a:ext>
             </a:extLst>
           </p:cNvPr>
@@ -15370,7 +15418,7 @@
           <p:cNvPr id="2" name="">
             <a:extLst xmlns:a="http://schemas.openxmlformats.org/drawingml/2006/main">
               <a:ext uri="{FF2B5EF4-FFF2-40B4-BE49-F238E27FC236}">
-                <a16:creationId xmlns:a16="http://schemas.microsoft.com/office/drawing/2014/main" id="{BE547128-D0FE-4E26-B06E-CD6FC21E2A3E}"/>
+                <a16:creationId xmlns:a16="http://schemas.microsoft.com/office/drawing/2014/main" id="{B96D2529-F75B-4863-851E-A273E5C2FE91}"/>
               </a:ext>
             </a:extLst>
           </p:cNvPr>
@@ -15427,7 +15475,7 @@
           <p:cNvPr id="3" name="">
             <a:extLst xmlns:a="http://schemas.openxmlformats.org/drawingml/2006/main">
               <a:ext uri="{FF2B5EF4-FFF2-40B4-BE49-F238E27FC236}">
-                <a16:creationId xmlns:a16="http://schemas.microsoft.com/office/drawing/2014/main" id="{2895CBBD-08BF-4DC7-8256-E479BA3EEC7C}"/>
+                <a16:creationId xmlns:a16="http://schemas.microsoft.com/office/drawing/2014/main" id="{74772F0A-E897-4115-914A-875BAA6B00BE}"/>
               </a:ext>
             </a:extLst>
           </p:cNvPr>
@@ -15484,7 +15532,7 @@
           <p:cNvPr id="4" name="">
             <a:extLst xmlns:a="http://schemas.openxmlformats.org/drawingml/2006/main">
               <a:ext uri="{FF2B5EF4-FFF2-40B4-BE49-F238E27FC236}">
-                <a16:creationId xmlns:a16="http://schemas.microsoft.com/office/drawing/2014/main" id="{480752F8-B608-4721-B4B4-CAC7BDC4A5DA}"/>
+                <a16:creationId xmlns:a16="http://schemas.microsoft.com/office/drawing/2014/main" id="{037F25D8-98BA-4832-A555-0A1C0212A195}"/>
               </a:ext>
             </a:extLst>
           </p:cNvPr>
@@ -15541,7 +15589,7 @@
           <p:cNvPr id="5" name="">
             <a:extLst xmlns:a="http://schemas.openxmlformats.org/drawingml/2006/main">
               <a:ext uri="{FF2B5EF4-FFF2-40B4-BE49-F238E27FC236}">
-                <a16:creationId xmlns:a16="http://schemas.microsoft.com/office/drawing/2014/main" id="{56EE0550-420D-4A26-822C-933286BB3A1D}"/>
+                <a16:creationId xmlns:a16="http://schemas.microsoft.com/office/drawing/2014/main" id="{9C48EDB9-3BF8-4CAE-BE78-D24754A749DF}"/>
               </a:ext>
             </a:extLst>
           </p:cNvPr>
@@ -15598,7 +15646,7 @@
           <p:cNvPr id="6" name="">
             <a:extLst xmlns:a="http://schemas.openxmlformats.org/drawingml/2006/main">
               <a:ext uri="{FF2B5EF4-FFF2-40B4-BE49-F238E27FC236}">
-                <a16:creationId xmlns:a16="http://schemas.microsoft.com/office/drawing/2014/main" id="{D0DBB7B0-F636-4212-8D78-FA91980A631D}"/>
+                <a16:creationId xmlns:a16="http://schemas.microsoft.com/office/drawing/2014/main" id="{4CDFDF8B-0633-4EB4-8BA3-5998865F1042}"/>
               </a:ext>
             </a:extLst>
           </p:cNvPr>
@@ -15633,7 +15681,7 @@
           <p:cNvPr id="7" name="">
             <a:extLst xmlns:a="http://schemas.openxmlformats.org/drawingml/2006/main">
               <a:ext uri="{FF2B5EF4-FFF2-40B4-BE49-F238E27FC236}">
-                <a16:creationId xmlns:a16="http://schemas.microsoft.com/office/drawing/2014/main" id="{3A50C139-97E7-43AC-9507-AC861C03BAA1}"/>
+                <a16:creationId xmlns:a16="http://schemas.microsoft.com/office/drawing/2014/main" id="{094D87E9-D400-4236-8802-89CB7D5B238C}"/>
               </a:ext>
             </a:extLst>
           </p:cNvPr>
@@ -15690,7 +15738,7 @@
           <p:cNvPr id="8" name="">
             <a:extLst xmlns:a="http://schemas.openxmlformats.org/drawingml/2006/main">
               <a:ext uri="{FF2B5EF4-FFF2-40B4-BE49-F238E27FC236}">
-                <a16:creationId xmlns:a16="http://schemas.microsoft.com/office/drawing/2014/main" id="{5429A252-0823-441D-987A-0656E5D4F490}"/>
+                <a16:creationId xmlns:a16="http://schemas.microsoft.com/office/drawing/2014/main" id="{5DB0AF4C-3D31-42AC-A223-AF31B60550B9}"/>
               </a:ext>
             </a:extLst>
           </p:cNvPr>
@@ -15747,7 +15795,7 @@
           <p:cNvPr id="9" name="">
             <a:extLst xmlns:a="http://schemas.openxmlformats.org/drawingml/2006/main">
               <a:ext uri="{FF2B5EF4-FFF2-40B4-BE49-F238E27FC236}">
-                <a16:creationId xmlns:a16="http://schemas.microsoft.com/office/drawing/2014/main" id="{E7EF68FE-9371-47B7-9D45-3F700A8C8220}"/>
+                <a16:creationId xmlns:a16="http://schemas.microsoft.com/office/drawing/2014/main" id="{6BB13A17-8F8E-4635-BB17-ED53361D9066}"/>
               </a:ext>
             </a:extLst>
           </p:cNvPr>
@@ -15827,7 +15875,7 @@
           <p:cNvPr id="10" name="">
             <a:extLst xmlns:a="http://schemas.openxmlformats.org/drawingml/2006/main">
               <a:ext uri="{FF2B5EF4-FFF2-40B4-BE49-F238E27FC236}">
-                <a16:creationId xmlns:a16="http://schemas.microsoft.com/office/drawing/2014/main" id="{24FD236B-F707-49EF-BF8F-AE87BDCC682C}"/>
+                <a16:creationId xmlns:a16="http://schemas.microsoft.com/office/drawing/2014/main" id="{A7AD920D-FF68-4505-A26C-2465528C050E}"/>
               </a:ext>
             </a:extLst>
           </p:cNvPr>
@@ -15862,7 +15910,7 @@
           <p:cNvPr id="11" name="">
             <a:extLst xmlns:a="http://schemas.openxmlformats.org/drawingml/2006/main">
               <a:ext uri="{FF2B5EF4-FFF2-40B4-BE49-F238E27FC236}">
-                <a16:creationId xmlns:a16="http://schemas.microsoft.com/office/drawing/2014/main" id="{3016422D-4278-4099-9A5A-BB25C826C0EC}"/>
+                <a16:creationId xmlns:a16="http://schemas.microsoft.com/office/drawing/2014/main" id="{31057E62-C75A-4B56-A5CA-18163E304BE3}"/>
               </a:ext>
             </a:extLst>
           </p:cNvPr>
@@ -15919,7 +15967,7 @@
           <p:cNvPr id="12" name="">
             <a:extLst xmlns:a="http://schemas.openxmlformats.org/drawingml/2006/main">
               <a:ext uri="{FF2B5EF4-FFF2-40B4-BE49-F238E27FC236}">
-                <a16:creationId xmlns:a16="http://schemas.microsoft.com/office/drawing/2014/main" id="{AD8574B1-EC90-4719-8555-5797FA32E26D}"/>
+                <a16:creationId xmlns:a16="http://schemas.microsoft.com/office/drawing/2014/main" id="{3B06916C-7E0B-49B0-9DDD-46508D72F3F6}"/>
               </a:ext>
             </a:extLst>
           </p:cNvPr>
@@ -15976,7 +16024,7 @@
           <p:cNvPr id="13" name="">
             <a:extLst xmlns:a="http://schemas.openxmlformats.org/drawingml/2006/main">
               <a:ext uri="{FF2B5EF4-FFF2-40B4-BE49-F238E27FC236}">
-                <a16:creationId xmlns:a16="http://schemas.microsoft.com/office/drawing/2014/main" id="{1B65AC6B-E576-4345-98CA-E47D14ADA347}"/>
+                <a16:creationId xmlns:a16="http://schemas.microsoft.com/office/drawing/2014/main" id="{2FA03364-5D7E-4ECF-B23D-04F6012DF3D1}"/>
               </a:ext>
             </a:extLst>
           </p:cNvPr>
@@ -16056,7 +16104,7 @@
           <p:cNvPr id="14" name="">
             <a:extLst xmlns:a="http://schemas.openxmlformats.org/drawingml/2006/main">
               <a:ext uri="{FF2B5EF4-FFF2-40B4-BE49-F238E27FC236}">
-                <a16:creationId xmlns:a16="http://schemas.microsoft.com/office/drawing/2014/main" id="{E2309B51-AEB0-47F6-99DF-60C080A0B073}"/>
+                <a16:creationId xmlns:a16="http://schemas.microsoft.com/office/drawing/2014/main" id="{863FC079-29C9-47AB-8454-6B5BF52E81C4}"/>
               </a:ext>
             </a:extLst>
           </p:cNvPr>
@@ -16091,7 +16139,7 @@
           <p:cNvPr id="15" name="">
             <a:extLst xmlns:a="http://schemas.openxmlformats.org/drawingml/2006/main">
               <a:ext uri="{FF2B5EF4-FFF2-40B4-BE49-F238E27FC236}">
-                <a16:creationId xmlns:a16="http://schemas.microsoft.com/office/drawing/2014/main" id="{D6A1A99A-5889-412B-882C-A9472584BDCD}"/>
+                <a16:creationId xmlns:a16="http://schemas.microsoft.com/office/drawing/2014/main" id="{D0F51405-62C7-4D27-838E-961F3AA5CA5F}"/>
               </a:ext>
             </a:extLst>
           </p:cNvPr>
@@ -16148,7 +16196,7 @@
           <p:cNvPr id="16" name="">
             <a:extLst xmlns:a="http://schemas.openxmlformats.org/drawingml/2006/main">
               <a:ext uri="{FF2B5EF4-FFF2-40B4-BE49-F238E27FC236}">
-                <a16:creationId xmlns:a16="http://schemas.microsoft.com/office/drawing/2014/main" id="{7078FF7A-366E-4ABD-85F3-3D209A26BBD2}"/>
+                <a16:creationId xmlns:a16="http://schemas.microsoft.com/office/drawing/2014/main" id="{5CA244E6-3292-43F2-BD1E-3053713501C2}"/>
               </a:ext>
             </a:extLst>
           </p:cNvPr>
@@ -16205,7 +16253,7 @@
           <p:cNvPr id="17" name="">
             <a:extLst xmlns:a="http://schemas.openxmlformats.org/drawingml/2006/main">
               <a:ext uri="{FF2B5EF4-FFF2-40B4-BE49-F238E27FC236}">
-                <a16:creationId xmlns:a16="http://schemas.microsoft.com/office/drawing/2014/main" id="{4CAF3D89-F8EF-490C-9AE1-907C5B1DA78F}"/>
+                <a16:creationId xmlns:a16="http://schemas.microsoft.com/office/drawing/2014/main" id="{164953FF-910B-4AF8-A63B-B65EB31A4BF9}"/>
               </a:ext>
             </a:extLst>
           </p:cNvPr>
@@ -16285,7 +16333,7 @@
           <p:cNvPr id="18" name="">
             <a:extLst xmlns:a="http://schemas.openxmlformats.org/drawingml/2006/main">
               <a:ext uri="{FF2B5EF4-FFF2-40B4-BE49-F238E27FC236}">
-                <a16:creationId xmlns:a16="http://schemas.microsoft.com/office/drawing/2014/main" id="{28330A57-35F9-4055-9836-2897F5B8F11A}"/>
+                <a16:creationId xmlns:a16="http://schemas.microsoft.com/office/drawing/2014/main" id="{106F4840-7848-477B-A434-6703E7A38AB5}"/>
               </a:ext>
             </a:extLst>
           </p:cNvPr>
@@ -16320,7 +16368,7 @@
           <p:cNvPr id="19" name="">
             <a:extLst xmlns:a="http://schemas.openxmlformats.org/drawingml/2006/main">
               <a:ext uri="{FF2B5EF4-FFF2-40B4-BE49-F238E27FC236}">
-                <a16:creationId xmlns:a16="http://schemas.microsoft.com/office/drawing/2014/main" id="{A85C32B9-F28E-4D7C-8DB4-4431E03785AF}"/>
+                <a16:creationId xmlns:a16="http://schemas.microsoft.com/office/drawing/2014/main" id="{E7D2A55A-DA0C-4F41-B877-257486D87762}"/>
               </a:ext>
             </a:extLst>
           </p:cNvPr>
@@ -16377,7 +16425,7 @@
           <p:cNvPr id="20" name="">
             <a:extLst xmlns:a="http://schemas.openxmlformats.org/drawingml/2006/main">
               <a:ext uri="{FF2B5EF4-FFF2-40B4-BE49-F238E27FC236}">
-                <a16:creationId xmlns:a16="http://schemas.microsoft.com/office/drawing/2014/main" id="{F64C57A4-B1F1-4A6D-899B-BBB1DEE354BE}"/>
+                <a16:creationId xmlns:a16="http://schemas.microsoft.com/office/drawing/2014/main" id="{1CAB835C-E7DD-4D26-AFD5-18BAD81D004B}"/>
               </a:ext>
             </a:extLst>
           </p:cNvPr>
@@ -16434,7 +16482,7 @@
           <p:cNvPr id="21" name="">
             <a:extLst xmlns:a="http://schemas.openxmlformats.org/drawingml/2006/main">
               <a:ext uri="{FF2B5EF4-FFF2-40B4-BE49-F238E27FC236}">
-                <a16:creationId xmlns:a16="http://schemas.microsoft.com/office/drawing/2014/main" id="{E3BA1C59-4C20-40F6-9EF8-6790C0177CAC}"/>
+                <a16:creationId xmlns:a16="http://schemas.microsoft.com/office/drawing/2014/main" id="{E28F046E-B257-4568-8B9A-800CDCDFA149}"/>
               </a:ext>
             </a:extLst>
           </p:cNvPr>
@@ -16514,7 +16562,7 @@
           <p:cNvPr id="22" name="">
             <a:extLst xmlns:a="http://schemas.openxmlformats.org/drawingml/2006/main">
               <a:ext uri="{FF2B5EF4-FFF2-40B4-BE49-F238E27FC236}">
-                <a16:creationId xmlns:a16="http://schemas.microsoft.com/office/drawing/2014/main" id="{6637AE4F-A469-4E11-94AC-87DDE434E4E0}"/>
+                <a16:creationId xmlns:a16="http://schemas.microsoft.com/office/drawing/2014/main" id="{115AD7F6-3A67-4298-A81F-C2461583EB53}"/>
               </a:ext>
             </a:extLst>
           </p:cNvPr>
@@ -16569,7 +16617,7 @@
     </p:spTree>
     <p:extLst>
       <p:ext uri="{BB962C8B-B14F-4D97-AF65-F5344CB8AC3E}">
-        <p14:creationId xmlns:p14="http://schemas.microsoft.com/office/powerpoint/2010/main" val="288118655"/>
+        <p14:creationId xmlns:p14="http://schemas.microsoft.com/office/powerpoint/2010/main" val="1737088380"/>
       </p:ext>
     </p:extLst>
   </p:cSld>

</xml_diff>